<commit_message>
Max-extra Rocket League presentation with music and all transitions
- Chiptune gaming beat (C major pentatonic, 140 BPM) embedded and set
  to auto-play across all 9 slides on loop
- Every available OOXML transition type used: zoom, push, strips, wheel,
  vertical split, checkerboard, newsflash, diamond, zoom-out
- Staggered entrance animations on all elements (cascade auto-plays on
  slide load): zoom, slide, randomBar, wipe, dissolve, wheel filters
- Scale-pulse emphasis bounce on leading elements after entrance
- No text content changed

Co-Authored-By: Claude Sonnet 4.6 <noreply@anthropic.com>
Claude-Session: https://claude.ai/code/session_01QS7srrPkzgdxeHFxN7zTWR
</commit_message>
<xml_diff>
--- a/rl_bachelor_extra.pptx
+++ b/rl_bachelor_extra.pptx
@@ -1735,6 +1735,36 @@
           </a:prstGeom>
         </p:spPr>
       </p:pic>
+      <p:pic>
+        <p:nvPicPr>
+          <p:cNvPr id="99" name="background_audio">
+            <a:hlinkClick r:id="rId99" action="ppaction://media"/>
+          </p:cNvPr>
+          <p:cNvPicPr>
+            <a:picLocks noRot="1" noChangeAspect="1" noMove="1" noResize="1" noSelect="1" noCrop="1" noGrp="1"/>
+          </p:cNvPicPr>
+          <p:nvPr>
+            <p:cNvMediaPr>
+              <a:audioFile r:link="rId99"/>
+            </p:cNvMediaPr>
+          </p:nvPr>
+        </p:nvPicPr>
+        <p:blipFill>
+          <a:blip r:embed="rId99"/>
+          <a:stretch>
+            <a:fillRect/>
+          </a:stretch>
+        </p:blipFill>
+        <p:spPr>
+          <a:xfrm>
+            <a:off x="-914400" y="-914400"/>
+            <a:ext cx="457200" cy="457200"/>
+          </a:xfrm>
+          <a:prstGeom prst="rect">
+            <a:avLst/>
+          </a:prstGeom>
+        </p:spPr>
+      </p:pic>
     </p:spTree>
   </p:cSld>
   <p:clrMapOvr>
@@ -1749,20 +1779,46 @@
         <p:cTn id="1" dur="indefinite" restart="whenNotActive" nodeType="tmRoot">
           <p:childTnLst>
             <p:par>
+              <p:cTn id="5" fill="hold">
+                <p:stCondLst>
+                  <p:cond delay="0"/>
+                </p:stCondLst>
+                <p:childTnLst>
+                  <p:par>
+                    <p:cTn id="900" fill="hold" nodeType="withEffect">
+                      <p:stCondLst>
+                        <p:cond delay="0"/>
+                      </p:stCondLst>
+                      <p:childTnLst>
+                        <p:audio isNarration="0">
+                          <p:cMediaNode vol="80000" mute="0" numSld="9" showWhenStopped="0">
+                            <p:cTn id="901" fill="hold" nodeType="withEffect"/>
+                            <p:tgtEl>
+                              <p:spTgt spid="99"/>
+                            </p:tgtEl>
+                          </p:cMediaNode>
+                        </p:audio>
+                      </p:childTnLst>
+                    </p:cTn>
+                  </p:par>
+                </p:childTnLst>
+              </p:cTn>
+            </p:par>
+            <p:par>
               <p:cTn id="2" fill="hold">
                 <p:stCondLst>
-                  <p:cond delay="400"/>
+                  <p:cond delay="300"/>
                 </p:stCondLst>
                 <p:childTnLst>
                   <p:par>
-                    <p:cTn id="3" presetID="10" presetClass="entr" presetSubtype="0" fill="hold" grpId="0" nodeType="withEffect">
+                    <p:cTn id="10" presetID="10" presetClass="entr" presetSubtype="0" fill="hold" grpId="0" nodeType="withEffect">
                       <p:stCondLst>
                         <p:cond delay="0"/>
                       </p:stCondLst>
                       <p:childTnLst>
                         <p:set>
                           <p:cBhvr>
-                            <p:cTn id="4" dur="1" fill="hold"/>
+                            <p:cTn id="11" dur="1" fill="hold"/>
                             <p:tgtEl>
                               <p:spTgt spid="2"/>
                             </p:tgtEl>
@@ -1776,7 +1832,7 @@
                         </p:set>
                         <p:animEffect transition="in" filter="zoom(inCenter)">
                           <p:cBhvr>
-                            <p:cTn id="5" dur="700"/>
+                            <p:cTn id="12" dur="700"/>
                             <p:tgtEl>
                               <p:spTgt spid="2"/>
                             </p:tgtEl>
@@ -1786,14 +1842,32 @@
                     </p:cTn>
                   </p:par>
                   <p:par>
-                    <p:cTn id="6" presetID="10" presetClass="entr" presetSubtype="0" fill="hold" grpId="1" nodeType="withEffect">
+                    <p:cTn id="13" presetID="26" presetClass="emph" presetSubtype="0" fill="hold" grpId="100" nodeType="afterEffect">
+                      <p:stCondLst>
+                        <p:cond delay="800"/>
+                      </p:stCondLst>
+                      <p:childTnLst>
+                        <p:animScale>
+                          <p:by x="115000" y="115000"/>
+                          <p:cBhvr autoRev="1">
+                            <p:cTn id="14" dur="200" autoRev="1"/>
+                            <p:tgtEl>
+                              <p:spTgt spid="2"/>
+                            </p:tgtEl>
+                          </p:cBhvr>
+                        </p:animScale>
+                      </p:childTnLst>
+                    </p:cTn>
+                  </p:par>
+                  <p:par>
+                    <p:cTn id="16" presetID="10" presetClass="entr" presetSubtype="0" fill="hold" grpId="1" nodeType="withEffect">
                       <p:stCondLst>
                         <p:cond delay="120"/>
                       </p:stCondLst>
                       <p:childTnLst>
                         <p:set>
                           <p:cBhvr>
-                            <p:cTn id="7" dur="1" fill="hold"/>
+                            <p:cTn id="17" dur="1" fill="hold"/>
                             <p:tgtEl>
                               <p:spTgt spid="3"/>
                             </p:tgtEl>
@@ -1807,7 +1881,7 @@
                         </p:set>
                         <p:animEffect transition="in" filter="fade">
                           <p:cBhvr>
-                            <p:cTn id="8" dur="700"/>
+                            <p:cTn id="18" dur="700"/>
                             <p:tgtEl>
                               <p:spTgt spid="3"/>
                             </p:tgtEl>
@@ -1817,14 +1891,14 @@
                     </p:cTn>
                   </p:par>
                   <p:par>
-                    <p:cTn id="9" presetID="10" presetClass="entr" presetSubtype="0" fill="hold" grpId="2" nodeType="withEffect">
+                    <p:cTn id="19" presetID="10" presetClass="entr" presetSubtype="0" fill="hold" grpId="2" nodeType="withEffect">
                       <p:stCondLst>
                         <p:cond delay="240"/>
                       </p:stCondLst>
                       <p:childTnLst>
                         <p:set>
                           <p:cBhvr>
-                            <p:cTn id="10" dur="1" fill="hold"/>
+                            <p:cTn id="20" dur="1" fill="hold"/>
                             <p:tgtEl>
                               <p:spTgt spid="4"/>
                             </p:tgtEl>
@@ -1838,7 +1912,7 @@
                         </p:set>
                         <p:animEffect transition="in" filter="zoom(inCenter)">
                           <p:cBhvr>
-                            <p:cTn id="11" dur="700"/>
+                            <p:cTn id="21" dur="700"/>
                             <p:tgtEl>
                               <p:spTgt spid="4"/>
                             </p:tgtEl>
@@ -1848,14 +1922,32 @@
                     </p:cTn>
                   </p:par>
                   <p:par>
-                    <p:cTn id="12" presetID="10" presetClass="entr" presetSubtype="0" fill="hold" grpId="3" nodeType="withEffect">
+                    <p:cTn id="22" presetID="26" presetClass="emph" presetSubtype="0" fill="hold" grpId="102" nodeType="afterEffect">
+                      <p:stCondLst>
+                        <p:cond delay="1040"/>
+                      </p:stCondLst>
+                      <p:childTnLst>
+                        <p:animScale>
+                          <p:by x="115000" y="115000"/>
+                          <p:cBhvr autoRev="1">
+                            <p:cTn id="23" dur="200" autoRev="1"/>
+                            <p:tgtEl>
+                              <p:spTgt spid="4"/>
+                            </p:tgtEl>
+                          </p:cBhvr>
+                        </p:animScale>
+                      </p:childTnLst>
+                    </p:cTn>
+                  </p:par>
+                  <p:par>
+                    <p:cTn id="25" presetID="10" presetClass="entr" presetSubtype="0" fill="hold" grpId="3" nodeType="withEffect">
                       <p:stCondLst>
                         <p:cond delay="360"/>
                       </p:stCondLst>
                       <p:childTnLst>
                         <p:set>
                           <p:cBhvr>
-                            <p:cTn id="13" dur="1" fill="hold"/>
+                            <p:cTn id="26" dur="1" fill="hold"/>
                             <p:tgtEl>
                               <p:spTgt spid="5"/>
                             </p:tgtEl>
@@ -1869,7 +1961,7 @@
                         </p:set>
                         <p:animEffect transition="in" filter="fade">
                           <p:cBhvr>
-                            <p:cTn id="14" dur="700"/>
+                            <p:cTn id="27" dur="700"/>
                             <p:tgtEl>
                               <p:spTgt spid="5"/>
                             </p:tgtEl>
@@ -1879,14 +1971,14 @@
                     </p:cTn>
                   </p:par>
                   <p:par>
-                    <p:cTn id="15" presetID="10" presetClass="entr" presetSubtype="0" fill="hold" grpId="4" nodeType="withEffect">
+                    <p:cTn id="28" presetID="10" presetClass="entr" presetSubtype="0" fill="hold" grpId="4" nodeType="withEffect">
                       <p:stCondLst>
                         <p:cond delay="480"/>
                       </p:stCondLst>
                       <p:childTnLst>
                         <p:set>
                           <p:cBhvr>
-                            <p:cTn id="16" dur="1" fill="hold"/>
+                            <p:cTn id="29" dur="1" fill="hold"/>
                             <p:tgtEl>
                               <p:spTgt spid="6"/>
                             </p:tgtEl>
@@ -1900,7 +1992,7 @@
                         </p:set>
                         <p:animEffect transition="in" filter="zoom(inCenter)">
                           <p:cBhvr>
-                            <p:cTn id="17" dur="700"/>
+                            <p:cTn id="30" dur="700"/>
                             <p:tgtEl>
                               <p:spTgt spid="6"/>
                             </p:tgtEl>
@@ -1910,14 +2002,14 @@
                     </p:cTn>
                   </p:par>
                   <p:par>
-                    <p:cTn id="18" presetID="10" presetClass="entr" presetSubtype="0" fill="hold" grpId="5" nodeType="withEffect">
+                    <p:cTn id="31" presetID="10" presetClass="entr" presetSubtype="0" fill="hold" grpId="5" nodeType="withEffect">
                       <p:stCondLst>
                         <p:cond delay="600"/>
                       </p:stCondLst>
                       <p:childTnLst>
                         <p:set>
                           <p:cBhvr>
-                            <p:cTn id="19" dur="1" fill="hold"/>
+                            <p:cTn id="32" dur="1" fill="hold"/>
                             <p:tgtEl>
                               <p:spTgt spid="7"/>
                             </p:tgtEl>
@@ -1931,7 +2023,7 @@
                         </p:set>
                         <p:animEffect transition="in" filter="fade">
                           <p:cBhvr>
-                            <p:cTn id="20" dur="700"/>
+                            <p:cTn id="33" dur="700"/>
                             <p:tgtEl>
                               <p:spTgt spid="7"/>
                             </p:tgtEl>
@@ -1941,14 +2033,14 @@
                     </p:cTn>
                   </p:par>
                   <p:par>
-                    <p:cTn id="21" presetID="10" presetClass="entr" presetSubtype="0" fill="hold" grpId="6" nodeType="withEffect">
+                    <p:cTn id="34" presetID="10" presetClass="entr" presetSubtype="0" fill="hold" grpId="6" nodeType="withEffect">
                       <p:stCondLst>
                         <p:cond delay="720"/>
                       </p:stCondLst>
                       <p:childTnLst>
                         <p:set>
                           <p:cBhvr>
-                            <p:cTn id="22" dur="1" fill="hold"/>
+                            <p:cTn id="35" dur="1" fill="hold"/>
                             <p:tgtEl>
                               <p:spTgt spid="8"/>
                             </p:tgtEl>
@@ -1962,7 +2054,7 @@
                         </p:set>
                         <p:animEffect transition="in" filter="zoom(inCenter)">
                           <p:cBhvr>
-                            <p:cTn id="23" dur="700"/>
+                            <p:cTn id="36" dur="700"/>
                             <p:tgtEl>
                               <p:spTgt spid="8"/>
                             </p:tgtEl>
@@ -1972,14 +2064,14 @@
                     </p:cTn>
                   </p:par>
                   <p:par>
-                    <p:cTn id="24" presetID="10" presetClass="entr" presetSubtype="0" fill="hold" grpId="7" nodeType="withEffect">
+                    <p:cTn id="37" presetID="10" presetClass="entr" presetSubtype="0" fill="hold" grpId="7" nodeType="withEffect">
                       <p:stCondLst>
                         <p:cond delay="840"/>
                       </p:stCondLst>
                       <p:childTnLst>
                         <p:set>
                           <p:cBhvr>
-                            <p:cTn id="25" dur="1" fill="hold"/>
+                            <p:cTn id="38" dur="1" fill="hold"/>
                             <p:tgtEl>
                               <p:spTgt spid="9"/>
                             </p:tgtEl>
@@ -1993,7 +2085,7 @@
                         </p:set>
                         <p:animEffect transition="in" filter="fade">
                           <p:cBhvr>
-                            <p:cTn id="26" dur="700"/>
+                            <p:cTn id="39" dur="700"/>
                             <p:tgtEl>
                               <p:spTgt spid="9"/>
                             </p:tgtEl>
@@ -2659,18 +2751,18 @@
             <p:par>
               <p:cTn id="2" fill="hold">
                 <p:stCondLst>
-                  <p:cond delay="300"/>
+                  <p:cond delay="200"/>
                 </p:stCondLst>
                 <p:childTnLst>
                   <p:par>
-                    <p:cTn id="3" presetID="10" presetClass="entr" presetSubtype="0" fill="hold" grpId="0" nodeType="withEffect">
+                    <p:cTn id="10" presetID="10" presetClass="entr" presetSubtype="0" fill="hold" grpId="0" nodeType="withEffect">
                       <p:stCondLst>
                         <p:cond delay="0"/>
                       </p:stCondLst>
                       <p:childTnLst>
                         <p:set>
                           <p:cBhvr>
-                            <p:cTn id="4" dur="1" fill="hold"/>
+                            <p:cTn id="11" dur="1" fill="hold"/>
                             <p:tgtEl>
                               <p:spTgt spid="2"/>
                             </p:tgtEl>
@@ -2684,7 +2776,7 @@
                         </p:set>
                         <p:animEffect transition="in" filter="slide(fromLeft)">
                           <p:cBhvr>
-                            <p:cTn id="5" dur="500"/>
+                            <p:cTn id="12" dur="500"/>
                             <p:tgtEl>
                               <p:spTgt spid="2"/>
                             </p:tgtEl>
@@ -2694,14 +2786,32 @@
                     </p:cTn>
                   </p:par>
                   <p:par>
-                    <p:cTn id="6" presetID="10" presetClass="entr" presetSubtype="0" fill="hold" grpId="1" nodeType="withEffect">
+                    <p:cTn id="13" presetID="26" presetClass="emph" presetSubtype="0" fill="hold" grpId="100" nodeType="afterEffect">
+                      <p:stCondLst>
+                        <p:cond delay="600"/>
+                      </p:stCondLst>
+                      <p:childTnLst>
+                        <p:animScale>
+                          <p:by x="115000" y="115000"/>
+                          <p:cBhvr autoRev="1">
+                            <p:cTn id="14" dur="200" autoRev="1"/>
+                            <p:tgtEl>
+                              <p:spTgt spid="2"/>
+                            </p:tgtEl>
+                          </p:cBhvr>
+                        </p:animScale>
+                      </p:childTnLst>
+                    </p:cTn>
+                  </p:par>
+                  <p:par>
+                    <p:cTn id="16" presetID="10" presetClass="entr" presetSubtype="0" fill="hold" grpId="1" nodeType="withEffect">
                       <p:stCondLst>
                         <p:cond delay="100"/>
                       </p:stCondLst>
                       <p:childTnLst>
                         <p:set>
                           <p:cBhvr>
-                            <p:cTn id="7" dur="1" fill="hold"/>
+                            <p:cTn id="17" dur="1" fill="hold"/>
                             <p:tgtEl>
                               <p:spTgt spid="3"/>
                             </p:tgtEl>
@@ -2715,7 +2825,7 @@
                         </p:set>
                         <p:animEffect transition="in" filter="slide(fromRight)">
                           <p:cBhvr>
-                            <p:cTn id="8" dur="500"/>
+                            <p:cTn id="18" dur="500"/>
                             <p:tgtEl>
                               <p:spTgt spid="3"/>
                             </p:tgtEl>
@@ -2725,14 +2835,14 @@
                     </p:cTn>
                   </p:par>
                   <p:par>
-                    <p:cTn id="9" presetID="10" presetClass="entr" presetSubtype="0" fill="hold" grpId="2" nodeType="withEffect">
+                    <p:cTn id="19" presetID="10" presetClass="entr" presetSubtype="0" fill="hold" grpId="2" nodeType="withEffect">
                       <p:stCondLst>
                         <p:cond delay="200"/>
                       </p:stCondLst>
                       <p:childTnLst>
                         <p:set>
                           <p:cBhvr>
-                            <p:cTn id="10" dur="1" fill="hold"/>
+                            <p:cTn id="20" dur="1" fill="hold"/>
                             <p:tgtEl>
                               <p:spTgt spid="4"/>
                             </p:tgtEl>
@@ -2746,7 +2856,7 @@
                         </p:set>
                         <p:animEffect transition="in" filter="slide(fromLeft)">
                           <p:cBhvr>
-                            <p:cTn id="11" dur="500"/>
+                            <p:cTn id="21" dur="500"/>
                             <p:tgtEl>
                               <p:spTgt spid="4"/>
                             </p:tgtEl>
@@ -2756,14 +2866,32 @@
                     </p:cTn>
                   </p:par>
                   <p:par>
-                    <p:cTn id="12" presetID="10" presetClass="entr" presetSubtype="0" fill="hold" grpId="3" nodeType="withEffect">
+                    <p:cTn id="22" presetID="26" presetClass="emph" presetSubtype="0" fill="hold" grpId="102" nodeType="afterEffect">
+                      <p:stCondLst>
+                        <p:cond delay="800"/>
+                      </p:stCondLst>
+                      <p:childTnLst>
+                        <p:animScale>
+                          <p:by x="115000" y="115000"/>
+                          <p:cBhvr autoRev="1">
+                            <p:cTn id="23" dur="200" autoRev="1"/>
+                            <p:tgtEl>
+                              <p:spTgt spid="4"/>
+                            </p:tgtEl>
+                          </p:cBhvr>
+                        </p:animScale>
+                      </p:childTnLst>
+                    </p:cTn>
+                  </p:par>
+                  <p:par>
+                    <p:cTn id="25" presetID="10" presetClass="entr" presetSubtype="0" fill="hold" grpId="3" nodeType="withEffect">
                       <p:stCondLst>
                         <p:cond delay="300"/>
                       </p:stCondLst>
                       <p:childTnLst>
                         <p:set>
                           <p:cBhvr>
-                            <p:cTn id="13" dur="1" fill="hold"/>
+                            <p:cTn id="26" dur="1" fill="hold"/>
                             <p:tgtEl>
                               <p:spTgt spid="5"/>
                             </p:tgtEl>
@@ -2777,7 +2905,7 @@
                         </p:set>
                         <p:animEffect transition="in" filter="slide(fromRight)">
                           <p:cBhvr>
-                            <p:cTn id="14" dur="500"/>
+                            <p:cTn id="27" dur="500"/>
                             <p:tgtEl>
                               <p:spTgt spid="5"/>
                             </p:tgtEl>
@@ -2787,14 +2915,14 @@
                     </p:cTn>
                   </p:par>
                   <p:par>
-                    <p:cTn id="15" presetID="10" presetClass="entr" presetSubtype="0" fill="hold" grpId="4" nodeType="withEffect">
+                    <p:cTn id="28" presetID="10" presetClass="entr" presetSubtype="0" fill="hold" grpId="4" nodeType="withEffect">
                       <p:stCondLst>
                         <p:cond delay="400"/>
                       </p:stCondLst>
                       <p:childTnLst>
                         <p:set>
                           <p:cBhvr>
-                            <p:cTn id="16" dur="1" fill="hold"/>
+                            <p:cTn id="29" dur="1" fill="hold"/>
                             <p:tgtEl>
                               <p:spTgt spid="6"/>
                             </p:tgtEl>
@@ -2808,7 +2936,7 @@
                         </p:set>
                         <p:animEffect transition="in" filter="slide(fromLeft)">
                           <p:cBhvr>
-                            <p:cTn id="17" dur="500"/>
+                            <p:cTn id="30" dur="500"/>
                             <p:tgtEl>
                               <p:spTgt spid="6"/>
                             </p:tgtEl>
@@ -2818,14 +2946,14 @@
                     </p:cTn>
                   </p:par>
                   <p:par>
-                    <p:cTn id="18" presetID="10" presetClass="entr" presetSubtype="0" fill="hold" grpId="5" nodeType="withEffect">
+                    <p:cTn id="31" presetID="10" presetClass="entr" presetSubtype="0" fill="hold" grpId="5" nodeType="withEffect">
                       <p:stCondLst>
                         <p:cond delay="500"/>
                       </p:stCondLst>
                       <p:childTnLst>
                         <p:set>
                           <p:cBhvr>
-                            <p:cTn id="19" dur="1" fill="hold"/>
+                            <p:cTn id="32" dur="1" fill="hold"/>
                             <p:tgtEl>
                               <p:spTgt spid="7"/>
                             </p:tgtEl>
@@ -2839,7 +2967,7 @@
                         </p:set>
                         <p:animEffect transition="in" filter="slide(fromRight)">
                           <p:cBhvr>
-                            <p:cTn id="20" dur="500"/>
+                            <p:cTn id="33" dur="500"/>
                             <p:tgtEl>
                               <p:spTgt spid="7"/>
                             </p:tgtEl>
@@ -2849,14 +2977,14 @@
                     </p:cTn>
                   </p:par>
                   <p:par>
-                    <p:cTn id="21" presetID="10" presetClass="entr" presetSubtype="0" fill="hold" grpId="6" nodeType="withEffect">
+                    <p:cTn id="34" presetID="10" presetClass="entr" presetSubtype="0" fill="hold" grpId="6" nodeType="withEffect">
                       <p:stCondLst>
                         <p:cond delay="600"/>
                       </p:stCondLst>
                       <p:childTnLst>
                         <p:set>
                           <p:cBhvr>
-                            <p:cTn id="22" dur="1" fill="hold"/>
+                            <p:cTn id="35" dur="1" fill="hold"/>
                             <p:tgtEl>
                               <p:spTgt spid="8"/>
                             </p:tgtEl>
@@ -2870,7 +2998,7 @@
                         </p:set>
                         <p:animEffect transition="in" filter="slide(fromLeft)">
                           <p:cBhvr>
-                            <p:cTn id="23" dur="500"/>
+                            <p:cTn id="36" dur="500"/>
                             <p:tgtEl>
                               <p:spTgt spid="8"/>
                             </p:tgtEl>
@@ -2880,14 +3008,14 @@
                     </p:cTn>
                   </p:par>
                   <p:par>
-                    <p:cTn id="24" presetID="10" presetClass="entr" presetSubtype="0" fill="hold" grpId="7" nodeType="withEffect">
+                    <p:cTn id="37" presetID="10" presetClass="entr" presetSubtype="0" fill="hold" grpId="7" nodeType="withEffect">
                       <p:stCondLst>
                         <p:cond delay="700"/>
                       </p:stCondLst>
                       <p:childTnLst>
                         <p:set>
                           <p:cBhvr>
-                            <p:cTn id="25" dur="1" fill="hold"/>
+                            <p:cTn id="38" dur="1" fill="hold"/>
                             <p:tgtEl>
                               <p:spTgt spid="9"/>
                             </p:tgtEl>
@@ -2901,7 +3029,7 @@
                         </p:set>
                         <p:animEffect transition="in" filter="slide(fromRight)">
                           <p:cBhvr>
-                            <p:cTn id="26" dur="500"/>
+                            <p:cTn id="39" dur="500"/>
                             <p:tgtEl>
                               <p:spTgt spid="9"/>
                             </p:tgtEl>
@@ -2911,14 +3039,14 @@
                     </p:cTn>
                   </p:par>
                   <p:par>
-                    <p:cTn id="27" presetID="10" presetClass="entr" presetSubtype="0" fill="hold" grpId="8" nodeType="withEffect">
+                    <p:cTn id="40" presetID="10" presetClass="entr" presetSubtype="0" fill="hold" grpId="8" nodeType="withEffect">
                       <p:stCondLst>
                         <p:cond delay="800"/>
                       </p:stCondLst>
                       <p:childTnLst>
                         <p:set>
                           <p:cBhvr>
-                            <p:cTn id="28" dur="1" fill="hold"/>
+                            <p:cTn id="41" dur="1" fill="hold"/>
                             <p:tgtEl>
                               <p:spTgt spid="10"/>
                             </p:tgtEl>
@@ -2932,7 +3060,7 @@
                         </p:set>
                         <p:animEffect transition="in" filter="slide(fromLeft)">
                           <p:cBhvr>
-                            <p:cTn id="29" dur="500"/>
+                            <p:cTn id="42" dur="500"/>
                             <p:tgtEl>
                               <p:spTgt spid="10"/>
                             </p:tgtEl>
@@ -2942,14 +3070,14 @@
                     </p:cTn>
                   </p:par>
                   <p:par>
-                    <p:cTn id="30" presetID="10" presetClass="entr" presetSubtype="0" fill="hold" grpId="9" nodeType="withEffect">
+                    <p:cTn id="43" presetID="10" presetClass="entr" presetSubtype="0" fill="hold" grpId="9" nodeType="withEffect">
                       <p:stCondLst>
                         <p:cond delay="900"/>
                       </p:stCondLst>
                       <p:childTnLst>
                         <p:set>
                           <p:cBhvr>
-                            <p:cTn id="31" dur="1" fill="hold"/>
+                            <p:cTn id="44" dur="1" fill="hold"/>
                             <p:tgtEl>
                               <p:spTgt spid="11"/>
                             </p:tgtEl>
@@ -2963,7 +3091,7 @@
                         </p:set>
                         <p:animEffect transition="in" filter="slide(fromRight)">
                           <p:cBhvr>
-                            <p:cTn id="32" dur="500"/>
+                            <p:cTn id="45" dur="500"/>
                             <p:tgtEl>
                               <p:spTgt spid="11"/>
                             </p:tgtEl>
@@ -2973,14 +3101,14 @@
                     </p:cTn>
                   </p:par>
                   <p:par>
-                    <p:cTn id="33" presetID="10" presetClass="entr" presetSubtype="0" fill="hold" grpId="10" nodeType="withEffect">
+                    <p:cTn id="46" presetID="10" presetClass="entr" presetSubtype="0" fill="hold" grpId="10" nodeType="withEffect">
                       <p:stCondLst>
                         <p:cond delay="1000"/>
                       </p:stCondLst>
                       <p:childTnLst>
                         <p:set>
                           <p:cBhvr>
-                            <p:cTn id="34" dur="1" fill="hold"/>
+                            <p:cTn id="47" dur="1" fill="hold"/>
                             <p:tgtEl>
                               <p:spTgt spid="12"/>
                             </p:tgtEl>
@@ -2994,7 +3122,7 @@
                         </p:set>
                         <p:animEffect transition="in" filter="slide(fromLeft)">
                           <p:cBhvr>
-                            <p:cTn id="35" dur="500"/>
+                            <p:cTn id="48" dur="500"/>
                             <p:tgtEl>
                               <p:spTgt spid="12"/>
                             </p:tgtEl>
@@ -3004,14 +3132,14 @@
                     </p:cTn>
                   </p:par>
                   <p:par>
-                    <p:cTn id="36" presetID="10" presetClass="entr" presetSubtype="0" fill="hold" grpId="11" nodeType="withEffect">
+                    <p:cTn id="49" presetID="10" presetClass="entr" presetSubtype="0" fill="hold" grpId="11" nodeType="withEffect">
                       <p:stCondLst>
                         <p:cond delay="1100"/>
                       </p:stCondLst>
                       <p:childTnLst>
                         <p:set>
                           <p:cBhvr>
-                            <p:cTn id="37" dur="1" fill="hold"/>
+                            <p:cTn id="50" dur="1" fill="hold"/>
                             <p:tgtEl>
                               <p:spTgt spid="13"/>
                             </p:tgtEl>
@@ -3025,7 +3153,7 @@
                         </p:set>
                         <p:animEffect transition="in" filter="slide(fromRight)">
                           <p:cBhvr>
-                            <p:cTn id="38" dur="500"/>
+                            <p:cTn id="51" dur="500"/>
                             <p:tgtEl>
                               <p:spTgt spid="13"/>
                             </p:tgtEl>
@@ -3035,14 +3163,14 @@
                     </p:cTn>
                   </p:par>
                   <p:par>
-                    <p:cTn id="39" presetID="10" presetClass="entr" presetSubtype="0" fill="hold" grpId="12" nodeType="withEffect">
+                    <p:cTn id="52" presetID="10" presetClass="entr" presetSubtype="0" fill="hold" grpId="12" nodeType="withEffect">
                       <p:stCondLst>
                         <p:cond delay="1200"/>
                       </p:stCondLst>
                       <p:childTnLst>
                         <p:set>
                           <p:cBhvr>
-                            <p:cTn id="40" dur="1" fill="hold"/>
+                            <p:cTn id="53" dur="1" fill="hold"/>
                             <p:tgtEl>
                               <p:spTgt spid="14"/>
                             </p:tgtEl>
@@ -3056,7 +3184,7 @@
                         </p:set>
                         <p:animEffect transition="in" filter="slide(fromLeft)">
                           <p:cBhvr>
-                            <p:cTn id="41" dur="500"/>
+                            <p:cTn id="54" dur="500"/>
                             <p:tgtEl>
                               <p:spTgt spid="14"/>
                             </p:tgtEl>
@@ -3066,14 +3194,14 @@
                     </p:cTn>
                   </p:par>
                   <p:par>
-                    <p:cTn id="42" presetID="10" presetClass="entr" presetSubtype="0" fill="hold" grpId="13" nodeType="withEffect">
+                    <p:cTn id="55" presetID="10" presetClass="entr" presetSubtype="0" fill="hold" grpId="13" nodeType="withEffect">
                       <p:stCondLst>
                         <p:cond delay="1300"/>
                       </p:stCondLst>
                       <p:childTnLst>
                         <p:set>
                           <p:cBhvr>
-                            <p:cTn id="43" dur="1" fill="hold"/>
+                            <p:cTn id="56" dur="1" fill="hold"/>
                             <p:tgtEl>
                               <p:spTgt spid="15"/>
                             </p:tgtEl>
@@ -3087,7 +3215,7 @@
                         </p:set>
                         <p:animEffect transition="in" filter="slide(fromRight)">
                           <p:cBhvr>
-                            <p:cTn id="44" dur="500"/>
+                            <p:cTn id="57" dur="500"/>
                             <p:tgtEl>
                               <p:spTgt spid="15"/>
                             </p:tgtEl>
@@ -3097,14 +3225,14 @@
                     </p:cTn>
                   </p:par>
                   <p:par>
-                    <p:cTn id="45" presetID="10" presetClass="entr" presetSubtype="0" fill="hold" grpId="14" nodeType="withEffect">
+                    <p:cTn id="58" presetID="10" presetClass="entr" presetSubtype="0" fill="hold" grpId="14" nodeType="withEffect">
                       <p:stCondLst>
                         <p:cond delay="1400"/>
                       </p:stCondLst>
                       <p:childTnLst>
                         <p:set>
                           <p:cBhvr>
-                            <p:cTn id="46" dur="1" fill="hold"/>
+                            <p:cTn id="59" dur="1" fill="hold"/>
                             <p:tgtEl>
                               <p:spTgt spid="16"/>
                             </p:tgtEl>
@@ -3118,7 +3246,7 @@
                         </p:set>
                         <p:animEffect transition="in" filter="slide(fromLeft)">
                           <p:cBhvr>
-                            <p:cTn id="47" dur="500"/>
+                            <p:cTn id="60" dur="500"/>
                             <p:tgtEl>
                               <p:spTgt spid="16"/>
                             </p:tgtEl>
@@ -3128,14 +3256,14 @@
                     </p:cTn>
                   </p:par>
                   <p:par>
-                    <p:cTn id="48" presetID="10" presetClass="entr" presetSubtype="0" fill="hold" grpId="15" nodeType="withEffect">
+                    <p:cTn id="61" presetID="10" presetClass="entr" presetSubtype="0" fill="hold" grpId="15" nodeType="withEffect">
                       <p:stCondLst>
                         <p:cond delay="1500"/>
                       </p:stCondLst>
                       <p:childTnLst>
                         <p:set>
                           <p:cBhvr>
-                            <p:cTn id="49" dur="1" fill="hold"/>
+                            <p:cTn id="62" dur="1" fill="hold"/>
                             <p:tgtEl>
                               <p:spTgt spid="17"/>
                             </p:tgtEl>
@@ -3149,7 +3277,7 @@
                         </p:set>
                         <p:animEffect transition="in" filter="slide(fromRight)">
                           <p:cBhvr>
-                            <p:cTn id="50" dur="500"/>
+                            <p:cTn id="63" dur="500"/>
                             <p:tgtEl>
                               <p:spTgt spid="17"/>
                             </p:tgtEl>
@@ -3159,14 +3287,14 @@
                     </p:cTn>
                   </p:par>
                   <p:par>
-                    <p:cTn id="51" presetID="10" presetClass="entr" presetSubtype="0" fill="hold" grpId="16" nodeType="withEffect">
+                    <p:cTn id="64" presetID="10" presetClass="entr" presetSubtype="0" fill="hold" grpId="16" nodeType="withEffect">
                       <p:stCondLst>
                         <p:cond delay="1600"/>
                       </p:stCondLst>
                       <p:childTnLst>
                         <p:set>
                           <p:cBhvr>
-                            <p:cTn id="52" dur="1" fill="hold"/>
+                            <p:cTn id="65" dur="1" fill="hold"/>
                             <p:tgtEl>
                               <p:spTgt spid="18"/>
                             </p:tgtEl>
@@ -3180,7 +3308,7 @@
                         </p:set>
                         <p:animEffect transition="in" filter="slide(fromLeft)">
                           <p:cBhvr>
-                            <p:cTn id="53" dur="500"/>
+                            <p:cTn id="66" dur="500"/>
                             <p:tgtEl>
                               <p:spTgt spid="18"/>
                             </p:tgtEl>
@@ -3190,14 +3318,14 @@
                     </p:cTn>
                   </p:par>
                   <p:par>
-                    <p:cTn id="54" presetID="10" presetClass="entr" presetSubtype="0" fill="hold" grpId="17" nodeType="withEffect">
+                    <p:cTn id="67" presetID="10" presetClass="entr" presetSubtype="0" fill="hold" grpId="17" nodeType="withEffect">
                       <p:stCondLst>
                         <p:cond delay="1700"/>
                       </p:stCondLst>
                       <p:childTnLst>
                         <p:set>
                           <p:cBhvr>
-                            <p:cTn id="55" dur="1" fill="hold"/>
+                            <p:cTn id="68" dur="1" fill="hold"/>
                             <p:tgtEl>
                               <p:spTgt spid="19"/>
                             </p:tgtEl>
@@ -3211,7 +3339,7 @@
                         </p:set>
                         <p:animEffect transition="in" filter="slide(fromRight)">
                           <p:cBhvr>
-                            <p:cTn id="56" dur="500"/>
+                            <p:cTn id="69" dur="500"/>
                             <p:tgtEl>
                               <p:spTgt spid="19"/>
                             </p:tgtEl>
@@ -3609,7 +3737,7 @@
     <a:masterClrMapping/>
   </p:clrMapOvr>
   <p:transition spd="med">
-    <p:wipe dir="l"/>
+    <p:strips dir="lu"/>
   </p:transition>
   <p:timing>
     <p:tnLst>
@@ -3623,14 +3751,14 @@
                 </p:stCondLst>
                 <p:childTnLst>
                   <p:par>
-                    <p:cTn id="3" presetID="10" presetClass="entr" presetSubtype="0" fill="hold" grpId="0" nodeType="withEffect">
+                    <p:cTn id="10" presetID="10" presetClass="entr" presetSubtype="0" fill="hold" grpId="0" nodeType="withEffect">
                       <p:stCondLst>
                         <p:cond delay="0"/>
                       </p:stCondLst>
                       <p:childTnLst>
                         <p:set>
                           <p:cBhvr>
-                            <p:cTn id="4" dur="1" fill="hold"/>
+                            <p:cTn id="11" dur="1" fill="hold"/>
                             <p:tgtEl>
                               <p:spTgt spid="2"/>
                             </p:tgtEl>
@@ -3642,9 +3770,9 @@
                             <p:strVal val="visible"/>
                           </p:to>
                         </p:set>
-                        <p:animEffect transition="in" filter="wipe(left)">
-                          <p:cBhvr>
-                            <p:cTn id="5" dur="400"/>
+                        <p:animEffect transition="in" filter="randomBar(horz)">
+                          <p:cBhvr>
+                            <p:cTn id="12" dur="400"/>
                             <p:tgtEl>
                               <p:spTgt spid="2"/>
                             </p:tgtEl>
@@ -3654,14 +3782,32 @@
                     </p:cTn>
                   </p:par>
                   <p:par>
-                    <p:cTn id="6" presetID="10" presetClass="entr" presetSubtype="0" fill="hold" grpId="1" nodeType="withEffect">
+                    <p:cTn id="13" presetID="26" presetClass="emph" presetSubtype="0" fill="hold" grpId="100" nodeType="afterEffect">
+                      <p:stCondLst>
+                        <p:cond delay="500"/>
+                      </p:stCondLst>
+                      <p:childTnLst>
+                        <p:animScale>
+                          <p:by x="115000" y="115000"/>
+                          <p:cBhvr autoRev="1">
+                            <p:cTn id="14" dur="200" autoRev="1"/>
+                            <p:tgtEl>
+                              <p:spTgt spid="2"/>
+                            </p:tgtEl>
+                          </p:cBhvr>
+                        </p:animScale>
+                      </p:childTnLst>
+                    </p:cTn>
+                  </p:par>
+                  <p:par>
+                    <p:cTn id="16" presetID="10" presetClass="entr" presetSubtype="0" fill="hold" grpId="1" nodeType="withEffect">
                       <p:stCondLst>
                         <p:cond delay="80"/>
                       </p:stCondLst>
                       <p:childTnLst>
                         <p:set>
                           <p:cBhvr>
-                            <p:cTn id="7" dur="1" fill="hold"/>
+                            <p:cTn id="17" dur="1" fill="hold"/>
                             <p:tgtEl>
                               <p:spTgt spid="3"/>
                             </p:tgtEl>
@@ -3673,9 +3819,9 @@
                             <p:strVal val="visible"/>
                           </p:to>
                         </p:set>
-                        <p:animEffect transition="in" filter="wipe(right)">
-                          <p:cBhvr>
-                            <p:cTn id="8" dur="400"/>
+                        <p:animEffect transition="in" filter="randomBar(vert)">
+                          <p:cBhvr>
+                            <p:cTn id="18" dur="400"/>
                             <p:tgtEl>
                               <p:spTgt spid="3"/>
                             </p:tgtEl>
@@ -4347,7 +4493,7 @@
     <a:masterClrMapping/>
   </p:clrMapOvr>
   <p:transition spd="fast">
-    <p:wheel spokes="4"/>
+    <p:wheel spokes="8"/>
   </p:transition>
   <p:timing>
     <p:tnLst>
@@ -4361,14 +4507,14 @@
                 </p:stCondLst>
                 <p:childTnLst>
                   <p:par>
-                    <p:cTn id="3" presetID="10" presetClass="entr" presetSubtype="0" fill="hold" grpId="0" nodeType="withEffect">
+                    <p:cTn id="10" presetID="10" presetClass="entr" presetSubtype="0" fill="hold" grpId="0" nodeType="withEffect">
                       <p:stCondLst>
                         <p:cond delay="0"/>
                       </p:stCondLst>
                       <p:childTnLst>
                         <p:set>
                           <p:cBhvr>
-                            <p:cTn id="4" dur="1" fill="hold"/>
+                            <p:cTn id="11" dur="1" fill="hold"/>
                             <p:tgtEl>
                               <p:spTgt spid="2"/>
                             </p:tgtEl>
@@ -4380,9 +4526,9 @@
                             <p:strVal val="visible"/>
                           </p:to>
                         </p:set>
-                        <p:animEffect transition="in" filter="zoom(inCenter)">
-                          <p:cBhvr>
-                            <p:cTn id="5" dur="600"/>
+                        <p:animEffect transition="in" filter="wheel(4)">
+                          <p:cBhvr>
+                            <p:cTn id="12" dur="600"/>
                             <p:tgtEl>
                               <p:spTgt spid="2"/>
                             </p:tgtEl>
@@ -4392,14 +4538,32 @@
                     </p:cTn>
                   </p:par>
                   <p:par>
-                    <p:cTn id="6" presetID="10" presetClass="entr" presetSubtype="0" fill="hold" grpId="1" nodeType="withEffect">
+                    <p:cTn id="13" presetID="26" presetClass="emph" presetSubtype="0" fill="hold" grpId="100" nodeType="afterEffect">
+                      <p:stCondLst>
+                        <p:cond delay="700"/>
+                      </p:stCondLst>
+                      <p:childTnLst>
+                        <p:animScale>
+                          <p:by x="115000" y="115000"/>
+                          <p:cBhvr autoRev="1">
+                            <p:cTn id="14" dur="200" autoRev="1"/>
+                            <p:tgtEl>
+                              <p:spTgt spid="2"/>
+                            </p:tgtEl>
+                          </p:cBhvr>
+                        </p:animScale>
+                      </p:childTnLst>
+                    </p:cTn>
+                  </p:par>
+                  <p:par>
+                    <p:cTn id="16" presetID="10" presetClass="entr" presetSubtype="0" fill="hold" grpId="1" nodeType="withEffect">
                       <p:stCondLst>
                         <p:cond delay="100"/>
                       </p:stCondLst>
                       <p:childTnLst>
                         <p:set>
                           <p:cBhvr>
-                            <p:cTn id="7" dur="1" fill="hold"/>
+                            <p:cTn id="17" dur="1" fill="hold"/>
                             <p:tgtEl>
                               <p:spTgt spid="3"/>
                             </p:tgtEl>
@@ -4413,7 +4577,7 @@
                         </p:set>
                         <p:animEffect transition="in" filter="dissolve">
                           <p:cBhvr>
-                            <p:cTn id="8" dur="600"/>
+                            <p:cTn id="18" dur="600"/>
                             <p:tgtEl>
                               <p:spTgt spid="3"/>
                             </p:tgtEl>
@@ -4423,14 +4587,14 @@
                     </p:cTn>
                   </p:par>
                   <p:par>
-                    <p:cTn id="9" presetID="10" presetClass="entr" presetSubtype="0" fill="hold" grpId="2" nodeType="withEffect">
+                    <p:cTn id="19" presetID="10" presetClass="entr" presetSubtype="0" fill="hold" grpId="2" nodeType="withEffect">
                       <p:stCondLst>
                         <p:cond delay="200"/>
                       </p:stCondLst>
                       <p:childTnLst>
                         <p:set>
                           <p:cBhvr>
-                            <p:cTn id="10" dur="1" fill="hold"/>
+                            <p:cTn id="20" dur="1" fill="hold"/>
                             <p:tgtEl>
                               <p:spTgt spid="4"/>
                             </p:tgtEl>
@@ -4442,9 +4606,9 @@
                             <p:strVal val="visible"/>
                           </p:to>
                         </p:set>
-                        <p:animEffect transition="in" filter="zoom(inCenter)">
-                          <p:cBhvr>
-                            <p:cTn id="11" dur="600"/>
+                        <p:animEffect transition="in" filter="wheel(4)">
+                          <p:cBhvr>
+                            <p:cTn id="21" dur="600"/>
                             <p:tgtEl>
                               <p:spTgt spid="4"/>
                             </p:tgtEl>
@@ -4454,14 +4618,32 @@
                     </p:cTn>
                   </p:par>
                   <p:par>
-                    <p:cTn id="12" presetID="10" presetClass="entr" presetSubtype="0" fill="hold" grpId="3" nodeType="withEffect">
+                    <p:cTn id="22" presetID="26" presetClass="emph" presetSubtype="0" fill="hold" grpId="102" nodeType="afterEffect">
+                      <p:stCondLst>
+                        <p:cond delay="900"/>
+                      </p:stCondLst>
+                      <p:childTnLst>
+                        <p:animScale>
+                          <p:by x="115000" y="115000"/>
+                          <p:cBhvr autoRev="1">
+                            <p:cTn id="23" dur="200" autoRev="1"/>
+                            <p:tgtEl>
+                              <p:spTgt spid="4"/>
+                            </p:tgtEl>
+                          </p:cBhvr>
+                        </p:animScale>
+                      </p:childTnLst>
+                    </p:cTn>
+                  </p:par>
+                  <p:par>
+                    <p:cTn id="25" presetID="10" presetClass="entr" presetSubtype="0" fill="hold" grpId="3" nodeType="withEffect">
                       <p:stCondLst>
                         <p:cond delay="300"/>
                       </p:stCondLst>
                       <p:childTnLst>
                         <p:set>
                           <p:cBhvr>
-                            <p:cTn id="13" dur="1" fill="hold"/>
+                            <p:cTn id="26" dur="1" fill="hold"/>
                             <p:tgtEl>
                               <p:spTgt spid="5"/>
                             </p:tgtEl>
@@ -4475,7 +4657,7 @@
                         </p:set>
                         <p:animEffect transition="in" filter="dissolve">
                           <p:cBhvr>
-                            <p:cTn id="14" dur="600"/>
+                            <p:cTn id="27" dur="600"/>
                             <p:tgtEl>
                               <p:spTgt spid="5"/>
                             </p:tgtEl>
@@ -4485,14 +4667,14 @@
                     </p:cTn>
                   </p:par>
                   <p:par>
-                    <p:cTn id="15" presetID="10" presetClass="entr" presetSubtype="0" fill="hold" grpId="4" nodeType="withEffect">
+                    <p:cTn id="28" presetID="10" presetClass="entr" presetSubtype="0" fill="hold" grpId="4" nodeType="withEffect">
                       <p:stCondLst>
                         <p:cond delay="400"/>
                       </p:stCondLst>
                       <p:childTnLst>
                         <p:set>
                           <p:cBhvr>
-                            <p:cTn id="16" dur="1" fill="hold"/>
+                            <p:cTn id="29" dur="1" fill="hold"/>
                             <p:tgtEl>
                               <p:spTgt spid="6"/>
                             </p:tgtEl>
@@ -4504,9 +4686,9 @@
                             <p:strVal val="visible"/>
                           </p:to>
                         </p:set>
-                        <p:animEffect transition="in" filter="zoom(inCenter)">
-                          <p:cBhvr>
-                            <p:cTn id="17" dur="600"/>
+                        <p:animEffect transition="in" filter="wheel(4)">
+                          <p:cBhvr>
+                            <p:cTn id="30" dur="600"/>
                             <p:tgtEl>
                               <p:spTgt spid="6"/>
                             </p:tgtEl>
@@ -4516,14 +4698,14 @@
                     </p:cTn>
                   </p:par>
                   <p:par>
-                    <p:cTn id="18" presetID="10" presetClass="entr" presetSubtype="0" fill="hold" grpId="5" nodeType="withEffect">
+                    <p:cTn id="31" presetID="10" presetClass="entr" presetSubtype="0" fill="hold" grpId="5" nodeType="withEffect">
                       <p:stCondLst>
                         <p:cond delay="500"/>
                       </p:stCondLst>
                       <p:childTnLst>
                         <p:set>
                           <p:cBhvr>
-                            <p:cTn id="19" dur="1" fill="hold"/>
+                            <p:cTn id="32" dur="1" fill="hold"/>
                             <p:tgtEl>
                               <p:spTgt spid="7"/>
                             </p:tgtEl>
@@ -4537,7 +4719,7 @@
                         </p:set>
                         <p:animEffect transition="in" filter="dissolve">
                           <p:cBhvr>
-                            <p:cTn id="20" dur="600"/>
+                            <p:cTn id="33" dur="600"/>
                             <p:tgtEl>
                               <p:spTgt spid="7"/>
                             </p:tgtEl>
@@ -4547,14 +4729,14 @@
                     </p:cTn>
                   </p:par>
                   <p:par>
-                    <p:cTn id="21" presetID="10" presetClass="entr" presetSubtype="0" fill="hold" grpId="6" nodeType="withEffect">
+                    <p:cTn id="34" presetID="10" presetClass="entr" presetSubtype="0" fill="hold" grpId="6" nodeType="withEffect">
                       <p:stCondLst>
                         <p:cond delay="600"/>
                       </p:stCondLst>
                       <p:childTnLst>
                         <p:set>
                           <p:cBhvr>
-                            <p:cTn id="22" dur="1" fill="hold"/>
+                            <p:cTn id="35" dur="1" fill="hold"/>
                             <p:tgtEl>
                               <p:spTgt spid="8"/>
                             </p:tgtEl>
@@ -4566,9 +4748,9 @@
                             <p:strVal val="visible"/>
                           </p:to>
                         </p:set>
-                        <p:animEffect transition="in" filter="zoom(inCenter)">
-                          <p:cBhvr>
-                            <p:cTn id="23" dur="600"/>
+                        <p:animEffect transition="in" filter="wheel(4)">
+                          <p:cBhvr>
+                            <p:cTn id="36" dur="600"/>
                             <p:tgtEl>
                               <p:spTgt spid="8"/>
                             </p:tgtEl>
@@ -4578,14 +4760,14 @@
                     </p:cTn>
                   </p:par>
                   <p:par>
-                    <p:cTn id="24" presetID="10" presetClass="entr" presetSubtype="0" fill="hold" grpId="7" nodeType="withEffect">
+                    <p:cTn id="37" presetID="10" presetClass="entr" presetSubtype="0" fill="hold" grpId="7" nodeType="withEffect">
                       <p:stCondLst>
                         <p:cond delay="700"/>
                       </p:stCondLst>
                       <p:childTnLst>
                         <p:set>
                           <p:cBhvr>
-                            <p:cTn id="25" dur="1" fill="hold"/>
+                            <p:cTn id="38" dur="1" fill="hold"/>
                             <p:tgtEl>
                               <p:spTgt spid="9"/>
                             </p:tgtEl>
@@ -4599,7 +4781,7 @@
                         </p:set>
                         <p:animEffect transition="in" filter="dissolve">
                           <p:cBhvr>
-                            <p:cTn id="26" dur="600"/>
+                            <p:cTn id="39" dur="600"/>
                             <p:tgtEl>
                               <p:spTgt spid="9"/>
                             </p:tgtEl>
@@ -4609,14 +4791,14 @@
                     </p:cTn>
                   </p:par>
                   <p:par>
-                    <p:cTn id="27" presetID="10" presetClass="entr" presetSubtype="0" fill="hold" grpId="8" nodeType="withEffect">
+                    <p:cTn id="40" presetID="10" presetClass="entr" presetSubtype="0" fill="hold" grpId="8" nodeType="withEffect">
                       <p:stCondLst>
                         <p:cond delay="800"/>
                       </p:stCondLst>
                       <p:childTnLst>
                         <p:set>
                           <p:cBhvr>
-                            <p:cTn id="28" dur="1" fill="hold"/>
+                            <p:cTn id="41" dur="1" fill="hold"/>
                             <p:tgtEl>
                               <p:spTgt spid="10"/>
                             </p:tgtEl>
@@ -4628,9 +4810,9 @@
                             <p:strVal val="visible"/>
                           </p:to>
                         </p:set>
-                        <p:animEffect transition="in" filter="zoom(inCenter)">
-                          <p:cBhvr>
-                            <p:cTn id="29" dur="600"/>
+                        <p:animEffect transition="in" filter="wheel(4)">
+                          <p:cBhvr>
+                            <p:cTn id="42" dur="600"/>
                             <p:tgtEl>
                               <p:spTgt spid="10"/>
                             </p:tgtEl>
@@ -4640,14 +4822,14 @@
                     </p:cTn>
                   </p:par>
                   <p:par>
-                    <p:cTn id="30" presetID="10" presetClass="entr" presetSubtype="0" fill="hold" grpId="9" nodeType="withEffect">
+                    <p:cTn id="43" presetID="10" presetClass="entr" presetSubtype="0" fill="hold" grpId="9" nodeType="withEffect">
                       <p:stCondLst>
                         <p:cond delay="900"/>
                       </p:stCondLst>
                       <p:childTnLst>
                         <p:set>
                           <p:cBhvr>
-                            <p:cTn id="31" dur="1" fill="hold"/>
+                            <p:cTn id="44" dur="1" fill="hold"/>
                             <p:tgtEl>
                               <p:spTgt spid="11"/>
                             </p:tgtEl>
@@ -4661,7 +4843,7 @@
                         </p:set>
                         <p:animEffect transition="in" filter="dissolve">
                           <p:cBhvr>
-                            <p:cTn id="32" dur="600"/>
+                            <p:cTn id="45" dur="600"/>
                             <p:tgtEl>
                               <p:spTgt spid="11"/>
                             </p:tgtEl>
@@ -4671,14 +4853,14 @@
                     </p:cTn>
                   </p:par>
                   <p:par>
-                    <p:cTn id="33" presetID="10" presetClass="entr" presetSubtype="0" fill="hold" grpId="10" nodeType="withEffect">
+                    <p:cTn id="46" presetID="10" presetClass="entr" presetSubtype="0" fill="hold" grpId="10" nodeType="withEffect">
                       <p:stCondLst>
                         <p:cond delay="1000"/>
                       </p:stCondLst>
                       <p:childTnLst>
                         <p:set>
                           <p:cBhvr>
-                            <p:cTn id="34" dur="1" fill="hold"/>
+                            <p:cTn id="47" dur="1" fill="hold"/>
                             <p:tgtEl>
                               <p:spTgt spid="12"/>
                             </p:tgtEl>
@@ -4690,9 +4872,9 @@
                             <p:strVal val="visible"/>
                           </p:to>
                         </p:set>
-                        <p:animEffect transition="in" filter="zoom(inCenter)">
-                          <p:cBhvr>
-                            <p:cTn id="35" dur="600"/>
+                        <p:animEffect transition="in" filter="wheel(4)">
+                          <p:cBhvr>
+                            <p:cTn id="48" dur="600"/>
                             <p:tgtEl>
                               <p:spTgt spid="12"/>
                             </p:tgtEl>
@@ -4702,14 +4884,14 @@
                     </p:cTn>
                   </p:par>
                   <p:par>
-                    <p:cTn id="36" presetID="10" presetClass="entr" presetSubtype="0" fill="hold" grpId="11" nodeType="withEffect">
+                    <p:cTn id="49" presetID="10" presetClass="entr" presetSubtype="0" fill="hold" grpId="11" nodeType="withEffect">
                       <p:stCondLst>
                         <p:cond delay="1100"/>
                       </p:stCondLst>
                       <p:childTnLst>
                         <p:set>
                           <p:cBhvr>
-                            <p:cTn id="37" dur="1" fill="hold"/>
+                            <p:cTn id="50" dur="1" fill="hold"/>
                             <p:tgtEl>
                               <p:spTgt spid="13"/>
                             </p:tgtEl>
@@ -4723,7 +4905,7 @@
                         </p:set>
                         <p:animEffect transition="in" filter="dissolve">
                           <p:cBhvr>
-                            <p:cTn id="38" dur="600"/>
+                            <p:cTn id="51" dur="600"/>
                             <p:tgtEl>
                               <p:spTgt spid="13"/>
                             </p:tgtEl>
@@ -4733,14 +4915,14 @@
                     </p:cTn>
                   </p:par>
                   <p:par>
-                    <p:cTn id="39" presetID="10" presetClass="entr" presetSubtype="0" fill="hold" grpId="12" nodeType="withEffect">
+                    <p:cTn id="52" presetID="10" presetClass="entr" presetSubtype="0" fill="hold" grpId="12" nodeType="withEffect">
                       <p:stCondLst>
                         <p:cond delay="1200"/>
                       </p:stCondLst>
                       <p:childTnLst>
                         <p:set>
                           <p:cBhvr>
-                            <p:cTn id="40" dur="1" fill="hold"/>
+                            <p:cTn id="53" dur="1" fill="hold"/>
                             <p:tgtEl>
                               <p:spTgt spid="14"/>
                             </p:tgtEl>
@@ -4752,9 +4934,9 @@
                             <p:strVal val="visible"/>
                           </p:to>
                         </p:set>
-                        <p:animEffect transition="in" filter="zoom(inCenter)">
-                          <p:cBhvr>
-                            <p:cTn id="41" dur="600"/>
+                        <p:animEffect transition="in" filter="wheel(4)">
+                          <p:cBhvr>
+                            <p:cTn id="54" dur="600"/>
                             <p:tgtEl>
                               <p:spTgt spid="14"/>
                             </p:tgtEl>
@@ -4764,14 +4946,14 @@
                     </p:cTn>
                   </p:par>
                   <p:par>
-                    <p:cTn id="42" presetID="10" presetClass="entr" presetSubtype="0" fill="hold" grpId="13" nodeType="withEffect">
+                    <p:cTn id="55" presetID="10" presetClass="entr" presetSubtype="0" fill="hold" grpId="13" nodeType="withEffect">
                       <p:stCondLst>
                         <p:cond delay="1300"/>
                       </p:stCondLst>
                       <p:childTnLst>
                         <p:set>
                           <p:cBhvr>
-                            <p:cTn id="43" dur="1" fill="hold"/>
+                            <p:cTn id="56" dur="1" fill="hold"/>
                             <p:tgtEl>
                               <p:spTgt spid="15"/>
                             </p:tgtEl>
@@ -4785,7 +4967,7 @@
                         </p:set>
                         <p:animEffect transition="in" filter="dissolve">
                           <p:cBhvr>
-                            <p:cTn id="44" dur="600"/>
+                            <p:cTn id="57" dur="600"/>
                             <p:tgtEl>
                               <p:spTgt spid="15"/>
                             </p:tgtEl>
@@ -4795,14 +4977,14 @@
                     </p:cTn>
                   </p:par>
                   <p:par>
-                    <p:cTn id="45" presetID="10" presetClass="entr" presetSubtype="0" fill="hold" grpId="14" nodeType="withEffect">
+                    <p:cTn id="58" presetID="10" presetClass="entr" presetSubtype="0" fill="hold" grpId="14" nodeType="withEffect">
                       <p:stCondLst>
                         <p:cond delay="1400"/>
                       </p:stCondLst>
                       <p:childTnLst>
                         <p:set>
                           <p:cBhvr>
-                            <p:cTn id="46" dur="1" fill="hold"/>
+                            <p:cTn id="59" dur="1" fill="hold"/>
                             <p:tgtEl>
                               <p:spTgt spid="16"/>
                             </p:tgtEl>
@@ -4814,9 +4996,9 @@
                             <p:strVal val="visible"/>
                           </p:to>
                         </p:set>
-                        <p:animEffect transition="in" filter="zoom(inCenter)">
-                          <p:cBhvr>
-                            <p:cTn id="47" dur="600"/>
+                        <p:animEffect transition="in" filter="wheel(4)">
+                          <p:cBhvr>
+                            <p:cTn id="60" dur="600"/>
                             <p:tgtEl>
                               <p:spTgt spid="16"/>
                             </p:tgtEl>
@@ -4826,14 +5008,14 @@
                     </p:cTn>
                   </p:par>
                   <p:par>
-                    <p:cTn id="48" presetID="10" presetClass="entr" presetSubtype="0" fill="hold" grpId="15" nodeType="withEffect">
+                    <p:cTn id="61" presetID="10" presetClass="entr" presetSubtype="0" fill="hold" grpId="15" nodeType="withEffect">
                       <p:stCondLst>
                         <p:cond delay="1500"/>
                       </p:stCondLst>
                       <p:childTnLst>
                         <p:set>
                           <p:cBhvr>
-                            <p:cTn id="49" dur="1" fill="hold"/>
+                            <p:cTn id="62" dur="1" fill="hold"/>
                             <p:tgtEl>
                               <p:spTgt spid="17"/>
                             </p:tgtEl>
@@ -4847,7 +5029,7 @@
                         </p:set>
                         <p:animEffect transition="in" filter="dissolve">
                           <p:cBhvr>
-                            <p:cTn id="50" dur="600"/>
+                            <p:cTn id="63" dur="600"/>
                             <p:tgtEl>
                               <p:spTgt spid="17"/>
                             </p:tgtEl>
@@ -5829,7 +6011,7 @@
     <a:masterClrMapping/>
   </p:clrMapOvr>
   <p:transition spd="med">
-    <p:split dir="horz" orient="out"/>
+    <p:split dir="vert" orient="out"/>
   </p:transition>
   <p:timing>
     <p:tnLst>
@@ -5843,14 +6025,14 @@
                 </p:stCondLst>
                 <p:childTnLst>
                   <p:par>
-                    <p:cTn id="3" presetID="10" presetClass="entr" presetSubtype="0" fill="hold" grpId="0" nodeType="withEffect">
+                    <p:cTn id="10" presetID="10" presetClass="entr" presetSubtype="0" fill="hold" grpId="0" nodeType="withEffect">
                       <p:stCondLst>
                         <p:cond delay="0"/>
                       </p:stCondLst>
                       <p:childTnLst>
                         <p:set>
                           <p:cBhvr>
-                            <p:cTn id="4" dur="1" fill="hold"/>
+                            <p:cTn id="11" dur="1" fill="hold"/>
                             <p:tgtEl>
                               <p:spTgt spid="2"/>
                             </p:tgtEl>
@@ -5864,7 +6046,7 @@
                         </p:set>
                         <p:animEffect transition="in" filter="wipe(left)">
                           <p:cBhvr>
-                            <p:cTn id="5" dur="350"/>
+                            <p:cTn id="12" dur="350"/>
                             <p:tgtEl>
                               <p:spTgt spid="2"/>
                             </p:tgtEl>
@@ -5874,14 +6056,32 @@
                     </p:cTn>
                   </p:par>
                   <p:par>
-                    <p:cTn id="6" presetID="10" presetClass="entr" presetSubtype="0" fill="hold" grpId="1" nodeType="withEffect">
+                    <p:cTn id="13" presetID="26" presetClass="emph" presetSubtype="0" fill="hold" grpId="100" nodeType="afterEffect">
+                      <p:stCondLst>
+                        <p:cond delay="450"/>
+                      </p:stCondLst>
+                      <p:childTnLst>
+                        <p:animScale>
+                          <p:by x="115000" y="115000"/>
+                          <p:cBhvr autoRev="1">
+                            <p:cTn id="14" dur="200" autoRev="1"/>
+                            <p:tgtEl>
+                              <p:spTgt spid="2"/>
+                            </p:tgtEl>
+                          </p:cBhvr>
+                        </p:animScale>
+                      </p:childTnLst>
+                    </p:cTn>
+                  </p:par>
+                  <p:par>
+                    <p:cTn id="16" presetID="10" presetClass="entr" presetSubtype="0" fill="hold" grpId="1" nodeType="withEffect">
                       <p:stCondLst>
                         <p:cond delay="70"/>
                       </p:stCondLst>
                       <p:childTnLst>
                         <p:set>
                           <p:cBhvr>
-                            <p:cTn id="7" dur="1" fill="hold"/>
+                            <p:cTn id="17" dur="1" fill="hold"/>
                             <p:tgtEl>
                               <p:spTgt spid="3"/>
                             </p:tgtEl>
@@ -5895,7 +6095,7 @@
                         </p:set>
                         <p:animEffect transition="in" filter="wipe(right)">
                           <p:cBhvr>
-                            <p:cTn id="8" dur="350"/>
+                            <p:cTn id="18" dur="350"/>
                             <p:tgtEl>
                               <p:spTgt spid="3"/>
                             </p:tgtEl>
@@ -5905,14 +6105,14 @@
                     </p:cTn>
                   </p:par>
                   <p:par>
-                    <p:cTn id="9" presetID="10" presetClass="entr" presetSubtype="0" fill="hold" grpId="2" nodeType="withEffect">
+                    <p:cTn id="19" presetID="10" presetClass="entr" presetSubtype="0" fill="hold" grpId="2" nodeType="withEffect">
                       <p:stCondLst>
                         <p:cond delay="140"/>
                       </p:stCondLst>
                       <p:childTnLst>
                         <p:set>
                           <p:cBhvr>
-                            <p:cTn id="10" dur="1" fill="hold"/>
+                            <p:cTn id="20" dur="1" fill="hold"/>
                             <p:tgtEl>
                               <p:spTgt spid="4"/>
                             </p:tgtEl>
@@ -5926,7 +6126,7 @@
                         </p:set>
                         <p:animEffect transition="in" filter="wipe(left)">
                           <p:cBhvr>
-                            <p:cTn id="11" dur="350"/>
+                            <p:cTn id="21" dur="350"/>
                             <p:tgtEl>
                               <p:spTgt spid="4"/>
                             </p:tgtEl>
@@ -5936,14 +6136,32 @@
                     </p:cTn>
                   </p:par>
                   <p:par>
-                    <p:cTn id="12" presetID="10" presetClass="entr" presetSubtype="0" fill="hold" grpId="3" nodeType="withEffect">
+                    <p:cTn id="22" presetID="26" presetClass="emph" presetSubtype="0" fill="hold" grpId="102" nodeType="afterEffect">
+                      <p:stCondLst>
+                        <p:cond delay="590"/>
+                      </p:stCondLst>
+                      <p:childTnLst>
+                        <p:animScale>
+                          <p:by x="115000" y="115000"/>
+                          <p:cBhvr autoRev="1">
+                            <p:cTn id="23" dur="200" autoRev="1"/>
+                            <p:tgtEl>
+                              <p:spTgt spid="4"/>
+                            </p:tgtEl>
+                          </p:cBhvr>
+                        </p:animScale>
+                      </p:childTnLst>
+                    </p:cTn>
+                  </p:par>
+                  <p:par>
+                    <p:cTn id="25" presetID="10" presetClass="entr" presetSubtype="0" fill="hold" grpId="3" nodeType="withEffect">
                       <p:stCondLst>
                         <p:cond delay="210"/>
                       </p:stCondLst>
                       <p:childTnLst>
                         <p:set>
                           <p:cBhvr>
-                            <p:cTn id="13" dur="1" fill="hold"/>
+                            <p:cTn id="26" dur="1" fill="hold"/>
                             <p:tgtEl>
                               <p:spTgt spid="5"/>
                             </p:tgtEl>
@@ -5957,7 +6175,7 @@
                         </p:set>
                         <p:animEffect transition="in" filter="wipe(right)">
                           <p:cBhvr>
-                            <p:cTn id="14" dur="350"/>
+                            <p:cTn id="27" dur="350"/>
                             <p:tgtEl>
                               <p:spTgt spid="5"/>
                             </p:tgtEl>
@@ -5967,14 +6185,14 @@
                     </p:cTn>
                   </p:par>
                   <p:par>
-                    <p:cTn id="15" presetID="10" presetClass="entr" presetSubtype="0" fill="hold" grpId="4" nodeType="withEffect">
+                    <p:cTn id="28" presetID="10" presetClass="entr" presetSubtype="0" fill="hold" grpId="4" nodeType="withEffect">
                       <p:stCondLst>
                         <p:cond delay="280"/>
                       </p:stCondLst>
                       <p:childTnLst>
                         <p:set>
                           <p:cBhvr>
-                            <p:cTn id="16" dur="1" fill="hold"/>
+                            <p:cTn id="29" dur="1" fill="hold"/>
                             <p:tgtEl>
                               <p:spTgt spid="6"/>
                             </p:tgtEl>
@@ -5988,7 +6206,7 @@
                         </p:set>
                         <p:animEffect transition="in" filter="wipe(left)">
                           <p:cBhvr>
-                            <p:cTn id="17" dur="350"/>
+                            <p:cTn id="30" dur="350"/>
                             <p:tgtEl>
                               <p:spTgt spid="6"/>
                             </p:tgtEl>
@@ -5998,14 +6216,14 @@
                     </p:cTn>
                   </p:par>
                   <p:par>
-                    <p:cTn id="18" presetID="10" presetClass="entr" presetSubtype="0" fill="hold" grpId="5" nodeType="withEffect">
+                    <p:cTn id="31" presetID="10" presetClass="entr" presetSubtype="0" fill="hold" grpId="5" nodeType="withEffect">
                       <p:stCondLst>
                         <p:cond delay="350"/>
                       </p:stCondLst>
                       <p:childTnLst>
                         <p:set>
                           <p:cBhvr>
-                            <p:cTn id="19" dur="1" fill="hold"/>
+                            <p:cTn id="32" dur="1" fill="hold"/>
                             <p:tgtEl>
                               <p:spTgt spid="7"/>
                             </p:tgtEl>
@@ -6019,7 +6237,7 @@
                         </p:set>
                         <p:animEffect transition="in" filter="wipe(right)">
                           <p:cBhvr>
-                            <p:cTn id="20" dur="350"/>
+                            <p:cTn id="33" dur="350"/>
                             <p:tgtEl>
                               <p:spTgt spid="7"/>
                             </p:tgtEl>
@@ -6029,14 +6247,14 @@
                     </p:cTn>
                   </p:par>
                   <p:par>
-                    <p:cTn id="21" presetID="10" presetClass="entr" presetSubtype="0" fill="hold" grpId="6" nodeType="withEffect">
+                    <p:cTn id="34" presetID="10" presetClass="entr" presetSubtype="0" fill="hold" grpId="6" nodeType="withEffect">
                       <p:stCondLst>
                         <p:cond delay="420"/>
                       </p:stCondLst>
                       <p:childTnLst>
                         <p:set>
                           <p:cBhvr>
-                            <p:cTn id="22" dur="1" fill="hold"/>
+                            <p:cTn id="35" dur="1" fill="hold"/>
                             <p:tgtEl>
                               <p:spTgt spid="8"/>
                             </p:tgtEl>
@@ -6050,7 +6268,7 @@
                         </p:set>
                         <p:animEffect transition="in" filter="wipe(left)">
                           <p:cBhvr>
-                            <p:cTn id="23" dur="350"/>
+                            <p:cTn id="36" dur="350"/>
                             <p:tgtEl>
                               <p:spTgt spid="8"/>
                             </p:tgtEl>
@@ -6060,14 +6278,14 @@
                     </p:cTn>
                   </p:par>
                   <p:par>
-                    <p:cTn id="24" presetID="10" presetClass="entr" presetSubtype="0" fill="hold" grpId="7" nodeType="withEffect">
+                    <p:cTn id="37" presetID="10" presetClass="entr" presetSubtype="0" fill="hold" grpId="7" nodeType="withEffect">
                       <p:stCondLst>
                         <p:cond delay="490"/>
                       </p:stCondLst>
                       <p:childTnLst>
                         <p:set>
                           <p:cBhvr>
-                            <p:cTn id="25" dur="1" fill="hold"/>
+                            <p:cTn id="38" dur="1" fill="hold"/>
                             <p:tgtEl>
                               <p:spTgt spid="9"/>
                             </p:tgtEl>
@@ -6081,7 +6299,7 @@
                         </p:set>
                         <p:animEffect transition="in" filter="wipe(right)">
                           <p:cBhvr>
-                            <p:cTn id="26" dur="350"/>
+                            <p:cTn id="39" dur="350"/>
                             <p:tgtEl>
                               <p:spTgt spid="9"/>
                             </p:tgtEl>
@@ -6091,14 +6309,14 @@
                     </p:cTn>
                   </p:par>
                   <p:par>
-                    <p:cTn id="27" presetID="10" presetClass="entr" presetSubtype="0" fill="hold" grpId="8" nodeType="withEffect">
+                    <p:cTn id="40" presetID="10" presetClass="entr" presetSubtype="0" fill="hold" grpId="8" nodeType="withEffect">
                       <p:stCondLst>
                         <p:cond delay="560"/>
                       </p:stCondLst>
                       <p:childTnLst>
                         <p:set>
                           <p:cBhvr>
-                            <p:cTn id="28" dur="1" fill="hold"/>
+                            <p:cTn id="41" dur="1" fill="hold"/>
                             <p:tgtEl>
                               <p:spTgt spid="10"/>
                             </p:tgtEl>
@@ -6112,7 +6330,7 @@
                         </p:set>
                         <p:animEffect transition="in" filter="wipe(left)">
                           <p:cBhvr>
-                            <p:cTn id="29" dur="350"/>
+                            <p:cTn id="42" dur="350"/>
                             <p:tgtEl>
                               <p:spTgt spid="10"/>
                             </p:tgtEl>
@@ -6122,14 +6340,14 @@
                     </p:cTn>
                   </p:par>
                   <p:par>
-                    <p:cTn id="30" presetID="10" presetClass="entr" presetSubtype="0" fill="hold" grpId="9" nodeType="withEffect">
+                    <p:cTn id="43" presetID="10" presetClass="entr" presetSubtype="0" fill="hold" grpId="9" nodeType="withEffect">
                       <p:stCondLst>
                         <p:cond delay="630"/>
                       </p:stCondLst>
                       <p:childTnLst>
                         <p:set>
                           <p:cBhvr>
-                            <p:cTn id="31" dur="1" fill="hold"/>
+                            <p:cTn id="44" dur="1" fill="hold"/>
                             <p:tgtEl>
                               <p:spTgt spid="11"/>
                             </p:tgtEl>
@@ -6143,7 +6361,7 @@
                         </p:set>
                         <p:animEffect transition="in" filter="wipe(right)">
                           <p:cBhvr>
-                            <p:cTn id="32" dur="350"/>
+                            <p:cTn id="45" dur="350"/>
                             <p:tgtEl>
                               <p:spTgt spid="11"/>
                             </p:tgtEl>
@@ -6153,14 +6371,14 @@
                     </p:cTn>
                   </p:par>
                   <p:par>
-                    <p:cTn id="33" presetID="10" presetClass="entr" presetSubtype="0" fill="hold" grpId="10" nodeType="withEffect">
+                    <p:cTn id="46" presetID="10" presetClass="entr" presetSubtype="0" fill="hold" grpId="10" nodeType="withEffect">
                       <p:stCondLst>
                         <p:cond delay="700"/>
                       </p:stCondLst>
                       <p:childTnLst>
                         <p:set>
                           <p:cBhvr>
-                            <p:cTn id="34" dur="1" fill="hold"/>
+                            <p:cTn id="47" dur="1" fill="hold"/>
                             <p:tgtEl>
                               <p:spTgt spid="16"/>
                             </p:tgtEl>
@@ -6174,7 +6392,7 @@
                         </p:set>
                         <p:animEffect transition="in" filter="wipe(left)">
                           <p:cBhvr>
-                            <p:cTn id="35" dur="350"/>
+                            <p:cTn id="48" dur="350"/>
                             <p:tgtEl>
                               <p:spTgt spid="16"/>
                             </p:tgtEl>
@@ -6184,14 +6402,14 @@
                     </p:cTn>
                   </p:par>
                   <p:par>
-                    <p:cTn id="36" presetID="10" presetClass="entr" presetSubtype="0" fill="hold" grpId="11" nodeType="withEffect">
+                    <p:cTn id="49" presetID="10" presetClass="entr" presetSubtype="0" fill="hold" grpId="11" nodeType="withEffect">
                       <p:stCondLst>
                         <p:cond delay="770"/>
                       </p:stCondLst>
                       <p:childTnLst>
                         <p:set>
                           <p:cBhvr>
-                            <p:cTn id="37" dur="1" fill="hold"/>
+                            <p:cTn id="50" dur="1" fill="hold"/>
                             <p:tgtEl>
                               <p:spTgt spid="17"/>
                             </p:tgtEl>
@@ -6205,7 +6423,7 @@
                         </p:set>
                         <p:animEffect transition="in" filter="wipe(right)">
                           <p:cBhvr>
-                            <p:cTn id="38" dur="350"/>
+                            <p:cTn id="51" dur="350"/>
                             <p:tgtEl>
                               <p:spTgt spid="17"/>
                             </p:tgtEl>
@@ -6215,14 +6433,14 @@
                     </p:cTn>
                   </p:par>
                   <p:par>
-                    <p:cTn id="39" presetID="10" presetClass="entr" presetSubtype="0" fill="hold" grpId="12" nodeType="withEffect">
+                    <p:cTn id="52" presetID="10" presetClass="entr" presetSubtype="0" fill="hold" grpId="12" nodeType="withEffect">
                       <p:stCondLst>
                         <p:cond delay="840"/>
                       </p:stCondLst>
                       <p:childTnLst>
                         <p:set>
                           <p:cBhvr>
-                            <p:cTn id="40" dur="1" fill="hold"/>
+                            <p:cTn id="53" dur="1" fill="hold"/>
                             <p:tgtEl>
                               <p:spTgt spid="18"/>
                             </p:tgtEl>
@@ -6236,7 +6454,7 @@
                         </p:set>
                         <p:animEffect transition="in" filter="wipe(left)">
                           <p:cBhvr>
-                            <p:cTn id="41" dur="350"/>
+                            <p:cTn id="54" dur="350"/>
                             <p:tgtEl>
                               <p:spTgt spid="18"/>
                             </p:tgtEl>
@@ -6246,14 +6464,14 @@
                     </p:cTn>
                   </p:par>
                   <p:par>
-                    <p:cTn id="42" presetID="10" presetClass="entr" presetSubtype="0" fill="hold" grpId="13" nodeType="withEffect">
+                    <p:cTn id="55" presetID="10" presetClass="entr" presetSubtype="0" fill="hold" grpId="13" nodeType="withEffect">
                       <p:stCondLst>
                         <p:cond delay="910"/>
                       </p:stCondLst>
                       <p:childTnLst>
                         <p:set>
                           <p:cBhvr>
-                            <p:cTn id="43" dur="1" fill="hold"/>
+                            <p:cTn id="56" dur="1" fill="hold"/>
                             <p:tgtEl>
                               <p:spTgt spid="19"/>
                             </p:tgtEl>
@@ -6267,7 +6485,7 @@
                         </p:set>
                         <p:animEffect transition="in" filter="wipe(right)">
                           <p:cBhvr>
-                            <p:cTn id="44" dur="350"/>
+                            <p:cTn id="57" dur="350"/>
                             <p:tgtEl>
                               <p:spTgt spid="19"/>
                             </p:tgtEl>
@@ -6277,14 +6495,14 @@
                     </p:cTn>
                   </p:par>
                   <p:par>
-                    <p:cTn id="45" presetID="10" presetClass="entr" presetSubtype="0" fill="hold" grpId="14" nodeType="withEffect">
+                    <p:cTn id="58" presetID="10" presetClass="entr" presetSubtype="0" fill="hold" grpId="14" nodeType="withEffect">
                       <p:stCondLst>
                         <p:cond delay="980"/>
                       </p:stCondLst>
                       <p:childTnLst>
                         <p:set>
                           <p:cBhvr>
-                            <p:cTn id="46" dur="1" fill="hold"/>
+                            <p:cTn id="59" dur="1" fill="hold"/>
                             <p:tgtEl>
                               <p:spTgt spid="20"/>
                             </p:tgtEl>
@@ -6298,7 +6516,7 @@
                         </p:set>
                         <p:animEffect transition="in" filter="wipe(left)">
                           <p:cBhvr>
-                            <p:cTn id="47" dur="350"/>
+                            <p:cTn id="60" dur="350"/>
                             <p:tgtEl>
                               <p:spTgt spid="20"/>
                             </p:tgtEl>
@@ -6308,14 +6526,14 @@
                     </p:cTn>
                   </p:par>
                   <p:par>
-                    <p:cTn id="48" presetID="10" presetClass="entr" presetSubtype="0" fill="hold" grpId="15" nodeType="withEffect">
+                    <p:cTn id="61" presetID="10" presetClass="entr" presetSubtype="0" fill="hold" grpId="15" nodeType="withEffect">
                       <p:stCondLst>
                         <p:cond delay="1050"/>
                       </p:stCondLst>
                       <p:childTnLst>
                         <p:set>
                           <p:cBhvr>
-                            <p:cTn id="49" dur="1" fill="hold"/>
+                            <p:cTn id="62" dur="1" fill="hold"/>
                             <p:tgtEl>
                               <p:spTgt spid="21"/>
                             </p:tgtEl>
@@ -6329,7 +6547,7 @@
                         </p:set>
                         <p:animEffect transition="in" filter="wipe(right)">
                           <p:cBhvr>
-                            <p:cTn id="50" dur="350"/>
+                            <p:cTn id="63" dur="350"/>
                             <p:tgtEl>
                               <p:spTgt spid="21"/>
                             </p:tgtEl>
@@ -6339,14 +6557,14 @@
                     </p:cTn>
                   </p:par>
                   <p:par>
-                    <p:cTn id="51" presetID="10" presetClass="entr" presetSubtype="0" fill="hold" grpId="16" nodeType="withEffect">
+                    <p:cTn id="64" presetID="10" presetClass="entr" presetSubtype="0" fill="hold" grpId="16" nodeType="withEffect">
                       <p:stCondLst>
                         <p:cond delay="1120"/>
                       </p:stCondLst>
                       <p:childTnLst>
                         <p:set>
                           <p:cBhvr>
-                            <p:cTn id="52" dur="1" fill="hold"/>
+                            <p:cTn id="65" dur="1" fill="hold"/>
                             <p:tgtEl>
                               <p:spTgt spid="22"/>
                             </p:tgtEl>
@@ -6360,7 +6578,7 @@
                         </p:set>
                         <p:animEffect transition="in" filter="wipe(left)">
                           <p:cBhvr>
-                            <p:cTn id="53" dur="350"/>
+                            <p:cTn id="66" dur="350"/>
                             <p:tgtEl>
                               <p:spTgt spid="22"/>
                             </p:tgtEl>
@@ -6370,14 +6588,14 @@
                     </p:cTn>
                   </p:par>
                   <p:par>
-                    <p:cTn id="54" presetID="10" presetClass="entr" presetSubtype="0" fill="hold" grpId="17" nodeType="withEffect">
+                    <p:cTn id="67" presetID="10" presetClass="entr" presetSubtype="0" fill="hold" grpId="17" nodeType="withEffect">
                       <p:stCondLst>
                         <p:cond delay="1190"/>
                       </p:stCondLst>
                       <p:childTnLst>
                         <p:set>
                           <p:cBhvr>
-                            <p:cTn id="55" dur="1" fill="hold"/>
+                            <p:cTn id="68" dur="1" fill="hold"/>
                             <p:tgtEl>
                               <p:spTgt spid="23"/>
                             </p:tgtEl>
@@ -6391,7 +6609,7 @@
                         </p:set>
                         <p:animEffect transition="in" filter="wipe(right)">
                           <p:cBhvr>
-                            <p:cTn id="56" dur="350"/>
+                            <p:cTn id="69" dur="350"/>
                             <p:tgtEl>
                               <p:spTgt spid="23"/>
                             </p:tgtEl>
@@ -6401,14 +6619,14 @@
                     </p:cTn>
                   </p:par>
                   <p:par>
-                    <p:cTn id="57" presetID="10" presetClass="entr" presetSubtype="0" fill="hold" grpId="18" nodeType="withEffect">
+                    <p:cTn id="70" presetID="10" presetClass="entr" presetSubtype="0" fill="hold" grpId="18" nodeType="withEffect">
                       <p:stCondLst>
                         <p:cond delay="1260"/>
                       </p:stCondLst>
                       <p:childTnLst>
                         <p:set>
                           <p:cBhvr>
-                            <p:cTn id="58" dur="1" fill="hold"/>
+                            <p:cTn id="71" dur="1" fill="hold"/>
                             <p:tgtEl>
                               <p:spTgt spid="24"/>
                             </p:tgtEl>
@@ -6422,7 +6640,7 @@
                         </p:set>
                         <p:animEffect transition="in" filter="wipe(left)">
                           <p:cBhvr>
-                            <p:cTn id="59" dur="350"/>
+                            <p:cTn id="72" dur="350"/>
                             <p:tgtEl>
                               <p:spTgt spid="24"/>
                             </p:tgtEl>
@@ -6432,14 +6650,14 @@
                     </p:cTn>
                   </p:par>
                   <p:par>
-                    <p:cTn id="60" presetID="10" presetClass="entr" presetSubtype="0" fill="hold" grpId="19" nodeType="withEffect">
+                    <p:cTn id="73" presetID="10" presetClass="entr" presetSubtype="0" fill="hold" grpId="19" nodeType="withEffect">
                       <p:stCondLst>
                         <p:cond delay="1330"/>
                       </p:stCondLst>
                       <p:childTnLst>
                         <p:set>
                           <p:cBhvr>
-                            <p:cTn id="61" dur="1" fill="hold"/>
+                            <p:cTn id="74" dur="1" fill="hold"/>
                             <p:tgtEl>
                               <p:spTgt spid="25"/>
                             </p:tgtEl>
@@ -6453,7 +6671,7 @@
                         </p:set>
                         <p:animEffect transition="in" filter="wipe(right)">
                           <p:cBhvr>
-                            <p:cTn id="62" dur="350"/>
+                            <p:cTn id="75" dur="350"/>
                             <p:tgtEl>
                               <p:spTgt spid="25"/>
                             </p:tgtEl>
@@ -6463,14 +6681,14 @@
                     </p:cTn>
                   </p:par>
                   <p:par>
-                    <p:cTn id="63" presetID="10" presetClass="entr" presetSubtype="0" fill="hold" grpId="20" nodeType="withEffect">
+                    <p:cTn id="76" presetID="10" presetClass="entr" presetSubtype="0" fill="hold" grpId="20" nodeType="withEffect">
                       <p:stCondLst>
                         <p:cond delay="1400"/>
                       </p:stCondLst>
                       <p:childTnLst>
                         <p:set>
                           <p:cBhvr>
-                            <p:cTn id="64" dur="1" fill="hold"/>
+                            <p:cTn id="77" dur="1" fill="hold"/>
                             <p:tgtEl>
                               <p:spTgt spid="26"/>
                             </p:tgtEl>
@@ -6484,7 +6702,7 @@
                         </p:set>
                         <p:animEffect transition="in" filter="wipe(left)">
                           <p:cBhvr>
-                            <p:cTn id="65" dur="350"/>
+                            <p:cTn id="78" dur="350"/>
                             <p:tgtEl>
                               <p:spTgt spid="26"/>
                             </p:tgtEl>
@@ -6494,14 +6712,14 @@
                     </p:cTn>
                   </p:par>
                   <p:par>
-                    <p:cTn id="66" presetID="10" presetClass="entr" presetSubtype="0" fill="hold" grpId="21" nodeType="withEffect">
+                    <p:cTn id="79" presetID="10" presetClass="entr" presetSubtype="0" fill="hold" grpId="21" nodeType="withEffect">
                       <p:stCondLst>
                         <p:cond delay="1470"/>
                       </p:stCondLst>
                       <p:childTnLst>
                         <p:set>
                           <p:cBhvr>
-                            <p:cTn id="67" dur="1" fill="hold"/>
+                            <p:cTn id="80" dur="1" fill="hold"/>
                             <p:tgtEl>
                               <p:spTgt spid="27"/>
                             </p:tgtEl>
@@ -6515,7 +6733,7 @@
                         </p:set>
                         <p:animEffect transition="in" filter="wipe(right)">
                           <p:cBhvr>
-                            <p:cTn id="68" dur="350"/>
+                            <p:cTn id="81" dur="350"/>
                             <p:tgtEl>
                               <p:spTgt spid="27"/>
                             </p:tgtEl>
@@ -6525,14 +6743,14 @@
                     </p:cTn>
                   </p:par>
                   <p:par>
-                    <p:cTn id="69" presetID="10" presetClass="entr" presetSubtype="0" fill="hold" grpId="22" nodeType="withEffect">
+                    <p:cTn id="82" presetID="10" presetClass="entr" presetSubtype="0" fill="hold" grpId="22" nodeType="withEffect">
                       <p:stCondLst>
                         <p:cond delay="1540"/>
                       </p:stCondLst>
                       <p:childTnLst>
                         <p:set>
                           <p:cBhvr>
-                            <p:cTn id="70" dur="1" fill="hold"/>
+                            <p:cTn id="83" dur="1" fill="hold"/>
                             <p:tgtEl>
                               <p:spTgt spid="28"/>
                             </p:tgtEl>
@@ -6546,7 +6764,7 @@
                         </p:set>
                         <p:animEffect transition="in" filter="wipe(left)">
                           <p:cBhvr>
-                            <p:cTn id="71" dur="350"/>
+                            <p:cTn id="84" dur="350"/>
                             <p:tgtEl>
                               <p:spTgt spid="28"/>
                             </p:tgtEl>
@@ -6556,14 +6774,14 @@
                     </p:cTn>
                   </p:par>
                   <p:par>
-                    <p:cTn id="72" presetID="10" presetClass="entr" presetSubtype="0" fill="hold" grpId="23" nodeType="withEffect">
+                    <p:cTn id="85" presetID="10" presetClass="entr" presetSubtype="0" fill="hold" grpId="23" nodeType="withEffect">
                       <p:stCondLst>
                         <p:cond delay="1610"/>
                       </p:stCondLst>
                       <p:childTnLst>
                         <p:set>
                           <p:cBhvr>
-                            <p:cTn id="73" dur="1" fill="hold"/>
+                            <p:cTn id="86" dur="1" fill="hold"/>
                             <p:tgtEl>
                               <p:spTgt spid="29"/>
                             </p:tgtEl>
@@ -6577,7 +6795,7 @@
                         </p:set>
                         <p:animEffect transition="in" filter="wipe(right)">
                           <p:cBhvr>
-                            <p:cTn id="74" dur="350"/>
+                            <p:cTn id="87" dur="350"/>
                             <p:tgtEl>
                               <p:spTgt spid="29"/>
                             </p:tgtEl>
@@ -6587,14 +6805,14 @@
                     </p:cTn>
                   </p:par>
                   <p:par>
-                    <p:cTn id="75" presetID="10" presetClass="entr" presetSubtype="0" fill="hold" grpId="24" nodeType="withEffect">
+                    <p:cTn id="88" presetID="10" presetClass="entr" presetSubtype="0" fill="hold" grpId="24" nodeType="withEffect">
                       <p:stCondLst>
                         <p:cond delay="1680"/>
                       </p:stCondLst>
                       <p:childTnLst>
                         <p:set>
                           <p:cBhvr>
-                            <p:cTn id="76" dur="1" fill="hold"/>
+                            <p:cTn id="89" dur="1" fill="hold"/>
                             <p:tgtEl>
                               <p:spTgt spid="30"/>
                             </p:tgtEl>
@@ -6608,7 +6826,7 @@
                         </p:set>
                         <p:animEffect transition="in" filter="wipe(left)">
                           <p:cBhvr>
-                            <p:cTn id="77" dur="350"/>
+                            <p:cTn id="90" dur="350"/>
                             <p:tgtEl>
                               <p:spTgt spid="30"/>
                             </p:tgtEl>
@@ -6618,14 +6836,14 @@
                     </p:cTn>
                   </p:par>
                   <p:par>
-                    <p:cTn id="78" presetID="10" presetClass="entr" presetSubtype="0" fill="hold" grpId="25" nodeType="withEffect">
+                    <p:cTn id="91" presetID="10" presetClass="entr" presetSubtype="0" fill="hold" grpId="25" nodeType="withEffect">
                       <p:stCondLst>
                         <p:cond delay="1750"/>
                       </p:stCondLst>
                       <p:childTnLst>
                         <p:set>
                           <p:cBhvr>
-                            <p:cTn id="79" dur="1" fill="hold"/>
+                            <p:cTn id="92" dur="1" fill="hold"/>
                             <p:tgtEl>
                               <p:spTgt spid="31"/>
                             </p:tgtEl>
@@ -6639,7 +6857,7 @@
                         </p:set>
                         <p:animEffect transition="in" filter="wipe(right)">
                           <p:cBhvr>
-                            <p:cTn id="80" dur="350"/>
+                            <p:cTn id="93" dur="350"/>
                             <p:tgtEl>
                               <p:spTgt spid="31"/>
                             </p:tgtEl>
@@ -6649,14 +6867,14 @@
                     </p:cTn>
                   </p:par>
                   <p:par>
-                    <p:cTn id="81" presetID="10" presetClass="entr" presetSubtype="0" fill="hold" grpId="26" nodeType="withEffect">
+                    <p:cTn id="94" presetID="10" presetClass="entr" presetSubtype="0" fill="hold" grpId="26" nodeType="withEffect">
                       <p:stCondLst>
                         <p:cond delay="1820"/>
                       </p:stCondLst>
                       <p:childTnLst>
                         <p:set>
                           <p:cBhvr>
-                            <p:cTn id="82" dur="1" fill="hold"/>
+                            <p:cTn id="95" dur="1" fill="hold"/>
                             <p:tgtEl>
                               <p:spTgt spid="32"/>
                             </p:tgtEl>
@@ -6670,7 +6888,7 @@
                         </p:set>
                         <p:animEffect transition="in" filter="wipe(left)">
                           <p:cBhvr>
-                            <p:cTn id="83" dur="350"/>
+                            <p:cTn id="96" dur="350"/>
                             <p:tgtEl>
                               <p:spTgt spid="32"/>
                             </p:tgtEl>
@@ -6680,14 +6898,14 @@
                     </p:cTn>
                   </p:par>
                   <p:par>
-                    <p:cTn id="84" presetID="10" presetClass="entr" presetSubtype="0" fill="hold" grpId="27" nodeType="withEffect">
+                    <p:cTn id="97" presetID="10" presetClass="entr" presetSubtype="0" fill="hold" grpId="27" nodeType="withEffect">
                       <p:stCondLst>
                         <p:cond delay="1890"/>
                       </p:stCondLst>
                       <p:childTnLst>
                         <p:set>
                           <p:cBhvr>
-                            <p:cTn id="85" dur="1" fill="hold"/>
+                            <p:cTn id="98" dur="1" fill="hold"/>
                             <p:tgtEl>
                               <p:spTgt spid="33"/>
                             </p:tgtEl>
@@ -6701,7 +6919,7 @@
                         </p:set>
                         <p:animEffect transition="in" filter="wipe(right)">
                           <p:cBhvr>
-                            <p:cTn id="86" dur="350"/>
+                            <p:cTn id="99" dur="350"/>
                             <p:tgtEl>
                               <p:spTgt spid="33"/>
                             </p:tgtEl>
@@ -6711,14 +6929,14 @@
                     </p:cTn>
                   </p:par>
                   <p:par>
-                    <p:cTn id="87" presetID="10" presetClass="entr" presetSubtype="0" fill="hold" grpId="28" nodeType="withEffect">
+                    <p:cTn id="100" presetID="10" presetClass="entr" presetSubtype="0" fill="hold" grpId="28" nodeType="withEffect">
                       <p:stCondLst>
                         <p:cond delay="1960"/>
                       </p:stCondLst>
                       <p:childTnLst>
                         <p:set>
                           <p:cBhvr>
-                            <p:cTn id="88" dur="1" fill="hold"/>
+                            <p:cTn id="101" dur="1" fill="hold"/>
                             <p:tgtEl>
                               <p:spTgt spid="34"/>
                             </p:tgtEl>
@@ -6732,7 +6950,7 @@
                         </p:set>
                         <p:animEffect transition="in" filter="wipe(left)">
                           <p:cBhvr>
-                            <p:cTn id="89" dur="350"/>
+                            <p:cTn id="102" dur="350"/>
                             <p:tgtEl>
                               <p:spTgt spid="34"/>
                             </p:tgtEl>
@@ -6742,14 +6960,14 @@
                     </p:cTn>
                   </p:par>
                   <p:par>
-                    <p:cTn id="90" presetID="10" presetClass="entr" presetSubtype="0" fill="hold" grpId="29" nodeType="withEffect">
+                    <p:cTn id="103" presetID="10" presetClass="entr" presetSubtype="0" fill="hold" grpId="29" nodeType="withEffect">
                       <p:stCondLst>
                         <p:cond delay="2030"/>
                       </p:stCondLst>
                       <p:childTnLst>
                         <p:set>
                           <p:cBhvr>
-                            <p:cTn id="91" dur="1" fill="hold"/>
+                            <p:cTn id="104" dur="1" fill="hold"/>
                             <p:tgtEl>
                               <p:spTgt spid="35"/>
                             </p:tgtEl>
@@ -6763,7 +6981,7 @@
                         </p:set>
                         <p:animEffect transition="in" filter="wipe(right)">
                           <p:cBhvr>
-                            <p:cTn id="92" dur="350"/>
+                            <p:cTn id="105" dur="350"/>
                             <p:tgtEl>
                               <p:spTgt spid="35"/>
                             </p:tgtEl>
@@ -7525,7 +7743,7 @@
     <a:masterClrMapping/>
   </p:clrMapOvr>
   <p:transition spd="fast">
-    <p:blinds dir="vert"/>
+    <p:checker dir="horz"/>
   </p:transition>
   <p:timing>
     <p:tnLst>
@@ -7535,18 +7753,18 @@
             <p:par>
               <p:cTn id="2" fill="hold">
                 <p:stCondLst>
-                  <p:cond delay="400"/>
+                  <p:cond delay="300"/>
                 </p:stCondLst>
                 <p:childTnLst>
                   <p:par>
-                    <p:cTn id="3" presetID="10" presetClass="entr" presetSubtype="0" fill="hold" grpId="0" nodeType="withEffect">
+                    <p:cTn id="10" presetID="10" presetClass="entr" presetSubtype="0" fill="hold" grpId="0" nodeType="withEffect">
                       <p:stCondLst>
                         <p:cond delay="0"/>
                       </p:stCondLst>
                       <p:childTnLst>
                         <p:set>
                           <p:cBhvr>
-                            <p:cTn id="4" dur="1" fill="hold"/>
+                            <p:cTn id="11" dur="1" fill="hold"/>
                             <p:tgtEl>
                               <p:spTgt spid="2"/>
                             </p:tgtEl>
@@ -7560,7 +7778,7 @@
                         </p:set>
                         <p:animEffect transition="in" filter="slide(fromBottom)">
                           <p:cBhvr>
-                            <p:cTn id="5" dur="600"/>
+                            <p:cTn id="12" dur="600"/>
                             <p:tgtEl>
                               <p:spTgt spid="2"/>
                             </p:tgtEl>
@@ -7570,14 +7788,32 @@
                     </p:cTn>
                   </p:par>
                   <p:par>
-                    <p:cTn id="6" presetID="10" presetClass="entr" presetSubtype="0" fill="hold" grpId="1" nodeType="withEffect">
-                      <p:stCondLst>
-                        <p:cond delay="120"/>
-                      </p:stCondLst>
-                      <p:childTnLst>
-                        <p:set>
-                          <p:cBhvr>
-                            <p:cTn id="7" dur="1" fill="hold"/>
+                    <p:cTn id="13" presetID="26" presetClass="emph" presetSubtype="0" fill="hold" grpId="100" nodeType="afterEffect">
+                      <p:stCondLst>
+                        <p:cond delay="700"/>
+                      </p:stCondLst>
+                      <p:childTnLst>
+                        <p:animScale>
+                          <p:by x="115000" y="115000"/>
+                          <p:cBhvr autoRev="1">
+                            <p:cTn id="14" dur="200" autoRev="1"/>
+                            <p:tgtEl>
+                              <p:spTgt spid="2"/>
+                            </p:tgtEl>
+                          </p:cBhvr>
+                        </p:animScale>
+                      </p:childTnLst>
+                    </p:cTn>
+                  </p:par>
+                  <p:par>
+                    <p:cTn id="16" presetID="10" presetClass="entr" presetSubtype="0" fill="hold" grpId="1" nodeType="withEffect">
+                      <p:stCondLst>
+                        <p:cond delay="110"/>
+                      </p:stCondLst>
+                      <p:childTnLst>
+                        <p:set>
+                          <p:cBhvr>
+                            <p:cTn id="17" dur="1" fill="hold"/>
                             <p:tgtEl>
                               <p:spTgt spid="3"/>
                             </p:tgtEl>
@@ -7591,7 +7827,7 @@
                         </p:set>
                         <p:animEffect transition="in" filter="slide(fromLeft)">
                           <p:cBhvr>
-                            <p:cTn id="8" dur="600"/>
+                            <p:cTn id="18" dur="600"/>
                             <p:tgtEl>
                               <p:spTgt spid="3"/>
                             </p:tgtEl>
@@ -7601,14 +7837,14 @@
                     </p:cTn>
                   </p:par>
                   <p:par>
-                    <p:cTn id="9" presetID="10" presetClass="entr" presetSubtype="0" fill="hold" grpId="2" nodeType="withEffect">
-                      <p:stCondLst>
-                        <p:cond delay="240"/>
-                      </p:stCondLst>
-                      <p:childTnLst>
-                        <p:set>
-                          <p:cBhvr>
-                            <p:cTn id="10" dur="1" fill="hold"/>
+                    <p:cTn id="19" presetID="10" presetClass="entr" presetSubtype="0" fill="hold" grpId="2" nodeType="withEffect">
+                      <p:stCondLst>
+                        <p:cond delay="220"/>
+                      </p:stCondLst>
+                      <p:childTnLst>
+                        <p:set>
+                          <p:cBhvr>
+                            <p:cTn id="20" dur="1" fill="hold"/>
                             <p:tgtEl>
                               <p:spTgt spid="4"/>
                             </p:tgtEl>
@@ -7622,7 +7858,7 @@
                         </p:set>
                         <p:animEffect transition="in" filter="slide(fromBottom)">
                           <p:cBhvr>
-                            <p:cTn id="11" dur="600"/>
+                            <p:cTn id="21" dur="600"/>
                             <p:tgtEl>
                               <p:spTgt spid="4"/>
                             </p:tgtEl>
@@ -7632,14 +7868,32 @@
                     </p:cTn>
                   </p:par>
                   <p:par>
-                    <p:cTn id="12" presetID="10" presetClass="entr" presetSubtype="0" fill="hold" grpId="3" nodeType="withEffect">
-                      <p:stCondLst>
-                        <p:cond delay="360"/>
-                      </p:stCondLst>
-                      <p:childTnLst>
-                        <p:set>
-                          <p:cBhvr>
-                            <p:cTn id="13" dur="1" fill="hold"/>
+                    <p:cTn id="22" presetID="26" presetClass="emph" presetSubtype="0" fill="hold" grpId="102" nodeType="afterEffect">
+                      <p:stCondLst>
+                        <p:cond delay="920"/>
+                      </p:stCondLst>
+                      <p:childTnLst>
+                        <p:animScale>
+                          <p:by x="115000" y="115000"/>
+                          <p:cBhvr autoRev="1">
+                            <p:cTn id="23" dur="200" autoRev="1"/>
+                            <p:tgtEl>
+                              <p:spTgt spid="4"/>
+                            </p:tgtEl>
+                          </p:cBhvr>
+                        </p:animScale>
+                      </p:childTnLst>
+                    </p:cTn>
+                  </p:par>
+                  <p:par>
+                    <p:cTn id="25" presetID="10" presetClass="entr" presetSubtype="0" fill="hold" grpId="3" nodeType="withEffect">
+                      <p:stCondLst>
+                        <p:cond delay="330"/>
+                      </p:stCondLst>
+                      <p:childTnLst>
+                        <p:set>
+                          <p:cBhvr>
+                            <p:cTn id="26" dur="1" fill="hold"/>
                             <p:tgtEl>
                               <p:spTgt spid="5"/>
                             </p:tgtEl>
@@ -7653,7 +7907,7 @@
                         </p:set>
                         <p:animEffect transition="in" filter="slide(fromLeft)">
                           <p:cBhvr>
-                            <p:cTn id="14" dur="600"/>
+                            <p:cTn id="27" dur="600"/>
                             <p:tgtEl>
                               <p:spTgt spid="5"/>
                             </p:tgtEl>
@@ -7663,14 +7917,14 @@
                     </p:cTn>
                   </p:par>
                   <p:par>
-                    <p:cTn id="15" presetID="10" presetClass="entr" presetSubtype="0" fill="hold" grpId="4" nodeType="withEffect">
-                      <p:stCondLst>
-                        <p:cond delay="480"/>
-                      </p:stCondLst>
-                      <p:childTnLst>
-                        <p:set>
-                          <p:cBhvr>
-                            <p:cTn id="16" dur="1" fill="hold"/>
+                    <p:cTn id="28" presetID="10" presetClass="entr" presetSubtype="0" fill="hold" grpId="4" nodeType="withEffect">
+                      <p:stCondLst>
+                        <p:cond delay="440"/>
+                      </p:stCondLst>
+                      <p:childTnLst>
+                        <p:set>
+                          <p:cBhvr>
+                            <p:cTn id="29" dur="1" fill="hold"/>
                             <p:tgtEl>
                               <p:spTgt spid="6"/>
                             </p:tgtEl>
@@ -7684,7 +7938,7 @@
                         </p:set>
                         <p:animEffect transition="in" filter="slide(fromBottom)">
                           <p:cBhvr>
-                            <p:cTn id="17" dur="600"/>
+                            <p:cTn id="30" dur="600"/>
                             <p:tgtEl>
                               <p:spTgt spid="6"/>
                             </p:tgtEl>
@@ -7694,14 +7948,14 @@
                     </p:cTn>
                   </p:par>
                   <p:par>
-                    <p:cTn id="18" presetID="10" presetClass="entr" presetSubtype="0" fill="hold" grpId="5" nodeType="withEffect">
-                      <p:stCondLst>
-                        <p:cond delay="600"/>
-                      </p:stCondLst>
-                      <p:childTnLst>
-                        <p:set>
-                          <p:cBhvr>
-                            <p:cTn id="19" dur="1" fill="hold"/>
+                    <p:cTn id="31" presetID="10" presetClass="entr" presetSubtype="0" fill="hold" grpId="5" nodeType="withEffect">
+                      <p:stCondLst>
+                        <p:cond delay="550"/>
+                      </p:stCondLst>
+                      <p:childTnLst>
+                        <p:set>
+                          <p:cBhvr>
+                            <p:cTn id="32" dur="1" fill="hold"/>
                             <p:tgtEl>
                               <p:spTgt spid="7"/>
                             </p:tgtEl>
@@ -7715,7 +7969,7 @@
                         </p:set>
                         <p:animEffect transition="in" filter="slide(fromLeft)">
                           <p:cBhvr>
-                            <p:cTn id="20" dur="600"/>
+                            <p:cTn id="33" dur="600"/>
                             <p:tgtEl>
                               <p:spTgt spid="7"/>
                             </p:tgtEl>
@@ -7725,14 +7979,14 @@
                     </p:cTn>
                   </p:par>
                   <p:par>
-                    <p:cTn id="21" presetID="10" presetClass="entr" presetSubtype="0" fill="hold" grpId="6" nodeType="withEffect">
-                      <p:stCondLst>
-                        <p:cond delay="720"/>
-                      </p:stCondLst>
-                      <p:childTnLst>
-                        <p:set>
-                          <p:cBhvr>
-                            <p:cTn id="22" dur="1" fill="hold"/>
+                    <p:cTn id="34" presetID="10" presetClass="entr" presetSubtype="0" fill="hold" grpId="6" nodeType="withEffect">
+                      <p:stCondLst>
+                        <p:cond delay="660"/>
+                      </p:stCondLst>
+                      <p:childTnLst>
+                        <p:set>
+                          <p:cBhvr>
+                            <p:cTn id="35" dur="1" fill="hold"/>
                             <p:tgtEl>
                               <p:spTgt spid="8"/>
                             </p:tgtEl>
@@ -7746,7 +8000,7 @@
                         </p:set>
                         <p:animEffect transition="in" filter="slide(fromBottom)">
                           <p:cBhvr>
-                            <p:cTn id="23" dur="600"/>
+                            <p:cTn id="36" dur="600"/>
                             <p:tgtEl>
                               <p:spTgt spid="8"/>
                             </p:tgtEl>
@@ -7756,14 +8010,14 @@
                     </p:cTn>
                   </p:par>
                   <p:par>
-                    <p:cTn id="24" presetID="10" presetClass="entr" presetSubtype="0" fill="hold" grpId="7" nodeType="withEffect">
-                      <p:stCondLst>
-                        <p:cond delay="840"/>
-                      </p:stCondLst>
-                      <p:childTnLst>
-                        <p:set>
-                          <p:cBhvr>
-                            <p:cTn id="25" dur="1" fill="hold"/>
+                    <p:cTn id="37" presetID="10" presetClass="entr" presetSubtype="0" fill="hold" grpId="7" nodeType="withEffect">
+                      <p:stCondLst>
+                        <p:cond delay="770"/>
+                      </p:stCondLst>
+                      <p:childTnLst>
+                        <p:set>
+                          <p:cBhvr>
+                            <p:cTn id="38" dur="1" fill="hold"/>
                             <p:tgtEl>
                               <p:spTgt spid="9"/>
                             </p:tgtEl>
@@ -7777,7 +8031,7 @@
                         </p:set>
                         <p:animEffect transition="in" filter="slide(fromLeft)">
                           <p:cBhvr>
-                            <p:cTn id="26" dur="600"/>
+                            <p:cTn id="39" dur="600"/>
                             <p:tgtEl>
                               <p:spTgt spid="9"/>
                             </p:tgtEl>
@@ -7787,14 +8041,14 @@
                     </p:cTn>
                   </p:par>
                   <p:par>
-                    <p:cTn id="27" presetID="10" presetClass="entr" presetSubtype="0" fill="hold" grpId="8" nodeType="withEffect">
-                      <p:stCondLst>
-                        <p:cond delay="960"/>
-                      </p:stCondLst>
-                      <p:childTnLst>
-                        <p:set>
-                          <p:cBhvr>
-                            <p:cTn id="28" dur="1" fill="hold"/>
+                    <p:cTn id="40" presetID="10" presetClass="entr" presetSubtype="0" fill="hold" grpId="8" nodeType="withEffect">
+                      <p:stCondLst>
+                        <p:cond delay="880"/>
+                      </p:stCondLst>
+                      <p:childTnLst>
+                        <p:set>
+                          <p:cBhvr>
+                            <p:cTn id="41" dur="1" fill="hold"/>
                             <p:tgtEl>
                               <p:spTgt spid="10"/>
                             </p:tgtEl>
@@ -7808,7 +8062,7 @@
                         </p:set>
                         <p:animEffect transition="in" filter="slide(fromBottom)">
                           <p:cBhvr>
-                            <p:cTn id="29" dur="600"/>
+                            <p:cTn id="42" dur="600"/>
                             <p:tgtEl>
                               <p:spTgt spid="10"/>
                             </p:tgtEl>
@@ -7818,14 +8072,14 @@
                     </p:cTn>
                   </p:par>
                   <p:par>
-                    <p:cTn id="30" presetID="10" presetClass="entr" presetSubtype="0" fill="hold" grpId="9" nodeType="withEffect">
-                      <p:stCondLst>
-                        <p:cond delay="1080"/>
-                      </p:stCondLst>
-                      <p:childTnLst>
-                        <p:set>
-                          <p:cBhvr>
-                            <p:cTn id="31" dur="1" fill="hold"/>
+                    <p:cTn id="43" presetID="10" presetClass="entr" presetSubtype="0" fill="hold" grpId="9" nodeType="withEffect">
+                      <p:stCondLst>
+                        <p:cond delay="990"/>
+                      </p:stCondLst>
+                      <p:childTnLst>
+                        <p:set>
+                          <p:cBhvr>
+                            <p:cTn id="44" dur="1" fill="hold"/>
                             <p:tgtEl>
                               <p:spTgt spid="11"/>
                             </p:tgtEl>
@@ -7839,7 +8093,7 @@
                         </p:set>
                         <p:animEffect transition="in" filter="slide(fromLeft)">
                           <p:cBhvr>
-                            <p:cTn id="32" dur="600"/>
+                            <p:cTn id="45" dur="600"/>
                             <p:tgtEl>
                               <p:spTgt spid="11"/>
                             </p:tgtEl>
@@ -7849,14 +8103,14 @@
                     </p:cTn>
                   </p:par>
                   <p:par>
-                    <p:cTn id="33" presetID="10" presetClass="entr" presetSubtype="0" fill="hold" grpId="10" nodeType="withEffect">
-                      <p:stCondLst>
-                        <p:cond delay="1200"/>
-                      </p:stCondLst>
-                      <p:childTnLst>
-                        <p:set>
-                          <p:cBhvr>
-                            <p:cTn id="34" dur="1" fill="hold"/>
+                    <p:cTn id="46" presetID="10" presetClass="entr" presetSubtype="0" fill="hold" grpId="10" nodeType="withEffect">
+                      <p:stCondLst>
+                        <p:cond delay="1100"/>
+                      </p:stCondLst>
+                      <p:childTnLst>
+                        <p:set>
+                          <p:cBhvr>
+                            <p:cTn id="47" dur="1" fill="hold"/>
                             <p:tgtEl>
                               <p:spTgt spid="12"/>
                             </p:tgtEl>
@@ -7870,7 +8124,7 @@
                         </p:set>
                         <p:animEffect transition="in" filter="slide(fromBottom)">
                           <p:cBhvr>
-                            <p:cTn id="35" dur="600"/>
+                            <p:cTn id="48" dur="600"/>
                             <p:tgtEl>
                               <p:spTgt spid="12"/>
                             </p:tgtEl>
@@ -7880,16 +8134,78 @@
                     </p:cTn>
                   </p:par>
                   <p:par>
-                    <p:cTn id="36" presetID="10" presetClass="entr" presetSubtype="0" fill="hold" grpId="11" nodeType="withEffect">
+                    <p:cTn id="49" presetID="10" presetClass="entr" presetSubtype="0" fill="hold" grpId="11" nodeType="withEffect">
+                      <p:stCondLst>
+                        <p:cond delay="1210"/>
+                      </p:stCondLst>
+                      <p:childTnLst>
+                        <p:set>
+                          <p:cBhvr>
+                            <p:cTn id="50" dur="1" fill="hold"/>
+                            <p:tgtEl>
+                              <p:spTgt spid="15"/>
+                            </p:tgtEl>
+                            <p:attrNameLst>
+                              <p:attrName>style.visibility</p:attrName>
+                            </p:attrNameLst>
+                          </p:cBhvr>
+                          <p:to>
+                            <p:strVal val="visible"/>
+                          </p:to>
+                        </p:set>
+                        <p:animEffect transition="in" filter="slide(fromLeft)">
+                          <p:cBhvr>
+                            <p:cTn id="51" dur="600"/>
+                            <p:tgtEl>
+                              <p:spTgt spid="15"/>
+                            </p:tgtEl>
+                          </p:cBhvr>
+                        </p:animEffect>
+                      </p:childTnLst>
+                    </p:cTn>
+                  </p:par>
+                  <p:par>
+                    <p:cTn id="52" presetID="10" presetClass="entr" presetSubtype="0" fill="hold" grpId="12" nodeType="withEffect">
                       <p:stCondLst>
                         <p:cond delay="1320"/>
                       </p:stCondLst>
                       <p:childTnLst>
                         <p:set>
                           <p:cBhvr>
-                            <p:cTn id="37" dur="1" fill="hold"/>
-                            <p:tgtEl>
-                              <p:spTgt spid="15"/>
+                            <p:cTn id="53" dur="1" fill="hold"/>
+                            <p:tgtEl>
+                              <p:spTgt spid="16"/>
+                            </p:tgtEl>
+                            <p:attrNameLst>
+                              <p:attrName>style.visibility</p:attrName>
+                            </p:attrNameLst>
+                          </p:cBhvr>
+                          <p:to>
+                            <p:strVal val="visible"/>
+                          </p:to>
+                        </p:set>
+                        <p:animEffect transition="in" filter="slide(fromBottom)">
+                          <p:cBhvr>
+                            <p:cTn id="54" dur="600"/>
+                            <p:tgtEl>
+                              <p:spTgt spid="16"/>
+                            </p:tgtEl>
+                          </p:cBhvr>
+                        </p:animEffect>
+                      </p:childTnLst>
+                    </p:cTn>
+                  </p:par>
+                  <p:par>
+                    <p:cTn id="55" presetID="10" presetClass="entr" presetSubtype="0" fill="hold" grpId="13" nodeType="withEffect">
+                      <p:stCondLst>
+                        <p:cond delay="1430"/>
+                      </p:stCondLst>
+                      <p:childTnLst>
+                        <p:set>
+                          <p:cBhvr>
+                            <p:cTn id="56" dur="1" fill="hold"/>
+                            <p:tgtEl>
+                              <p:spTgt spid="17"/>
                             </p:tgtEl>
                             <p:attrNameLst>
                               <p:attrName>style.visibility</p:attrName>
@@ -7901,26 +8217,26 @@
                         </p:set>
                         <p:animEffect transition="in" filter="slide(fromLeft)">
                           <p:cBhvr>
-                            <p:cTn id="38" dur="600"/>
-                            <p:tgtEl>
-                              <p:spTgt spid="15"/>
-                            </p:tgtEl>
-                          </p:cBhvr>
-                        </p:animEffect>
-                      </p:childTnLst>
-                    </p:cTn>
-                  </p:par>
-                  <p:par>
-                    <p:cTn id="39" presetID="10" presetClass="entr" presetSubtype="0" fill="hold" grpId="12" nodeType="withEffect">
-                      <p:stCondLst>
-                        <p:cond delay="1440"/>
-                      </p:stCondLst>
-                      <p:childTnLst>
-                        <p:set>
-                          <p:cBhvr>
-                            <p:cTn id="40" dur="1" fill="hold"/>
-                            <p:tgtEl>
-                              <p:spTgt spid="16"/>
+                            <p:cTn id="57" dur="600"/>
+                            <p:tgtEl>
+                              <p:spTgt spid="17"/>
+                            </p:tgtEl>
+                          </p:cBhvr>
+                        </p:animEffect>
+                      </p:childTnLst>
+                    </p:cTn>
+                  </p:par>
+                  <p:par>
+                    <p:cTn id="58" presetID="10" presetClass="entr" presetSubtype="0" fill="hold" grpId="14" nodeType="withEffect">
+                      <p:stCondLst>
+                        <p:cond delay="1540"/>
+                      </p:stCondLst>
+                      <p:childTnLst>
+                        <p:set>
+                          <p:cBhvr>
+                            <p:cTn id="59" dur="1" fill="hold"/>
+                            <p:tgtEl>
+                              <p:spTgt spid="18"/>
                             </p:tgtEl>
                             <p:attrNameLst>
                               <p:attrName>style.visibility</p:attrName>
@@ -7932,26 +8248,26 @@
                         </p:set>
                         <p:animEffect transition="in" filter="slide(fromBottom)">
                           <p:cBhvr>
-                            <p:cTn id="41" dur="600"/>
-                            <p:tgtEl>
-                              <p:spTgt spid="16"/>
-                            </p:tgtEl>
-                          </p:cBhvr>
-                        </p:animEffect>
-                      </p:childTnLst>
-                    </p:cTn>
-                  </p:par>
-                  <p:par>
-                    <p:cTn id="42" presetID="10" presetClass="entr" presetSubtype="0" fill="hold" grpId="13" nodeType="withEffect">
-                      <p:stCondLst>
-                        <p:cond delay="1560"/>
-                      </p:stCondLst>
-                      <p:childTnLst>
-                        <p:set>
-                          <p:cBhvr>
-                            <p:cTn id="43" dur="1" fill="hold"/>
-                            <p:tgtEl>
-                              <p:spTgt spid="17"/>
+                            <p:cTn id="60" dur="600"/>
+                            <p:tgtEl>
+                              <p:spTgt spid="18"/>
+                            </p:tgtEl>
+                          </p:cBhvr>
+                        </p:animEffect>
+                      </p:childTnLst>
+                    </p:cTn>
+                  </p:par>
+                  <p:par>
+                    <p:cTn id="61" presetID="10" presetClass="entr" presetSubtype="0" fill="hold" grpId="15" nodeType="withEffect">
+                      <p:stCondLst>
+                        <p:cond delay="1650"/>
+                      </p:stCondLst>
+                      <p:childTnLst>
+                        <p:set>
+                          <p:cBhvr>
+                            <p:cTn id="62" dur="1" fill="hold"/>
+                            <p:tgtEl>
+                              <p:spTgt spid="19"/>
                             </p:tgtEl>
                             <p:attrNameLst>
                               <p:attrName>style.visibility</p:attrName>
@@ -7963,26 +8279,26 @@
                         </p:set>
                         <p:animEffect transition="in" filter="slide(fromLeft)">
                           <p:cBhvr>
-                            <p:cTn id="44" dur="600"/>
-                            <p:tgtEl>
-                              <p:spTgt spid="17"/>
-                            </p:tgtEl>
-                          </p:cBhvr>
-                        </p:animEffect>
-                      </p:childTnLst>
-                    </p:cTn>
-                  </p:par>
-                  <p:par>
-                    <p:cTn id="45" presetID="10" presetClass="entr" presetSubtype="0" fill="hold" grpId="14" nodeType="withEffect">
-                      <p:stCondLst>
-                        <p:cond delay="1680"/>
-                      </p:stCondLst>
-                      <p:childTnLst>
-                        <p:set>
-                          <p:cBhvr>
-                            <p:cTn id="46" dur="1" fill="hold"/>
-                            <p:tgtEl>
-                              <p:spTgt spid="18"/>
+                            <p:cTn id="63" dur="600"/>
+                            <p:tgtEl>
+                              <p:spTgt spid="19"/>
+                            </p:tgtEl>
+                          </p:cBhvr>
+                        </p:animEffect>
+                      </p:childTnLst>
+                    </p:cTn>
+                  </p:par>
+                  <p:par>
+                    <p:cTn id="64" presetID="10" presetClass="entr" presetSubtype="0" fill="hold" grpId="16" nodeType="withEffect">
+                      <p:stCondLst>
+                        <p:cond delay="1760"/>
+                      </p:stCondLst>
+                      <p:childTnLst>
+                        <p:set>
+                          <p:cBhvr>
+                            <p:cTn id="65" dur="1" fill="hold"/>
+                            <p:tgtEl>
+                              <p:spTgt spid="20"/>
                             </p:tgtEl>
                             <p:attrNameLst>
                               <p:attrName>style.visibility</p:attrName>
@@ -7994,26 +8310,26 @@
                         </p:set>
                         <p:animEffect transition="in" filter="slide(fromBottom)">
                           <p:cBhvr>
-                            <p:cTn id="47" dur="600"/>
-                            <p:tgtEl>
-                              <p:spTgt spid="18"/>
-                            </p:tgtEl>
-                          </p:cBhvr>
-                        </p:animEffect>
-                      </p:childTnLst>
-                    </p:cTn>
-                  </p:par>
-                  <p:par>
-                    <p:cTn id="48" presetID="10" presetClass="entr" presetSubtype="0" fill="hold" grpId="15" nodeType="withEffect">
-                      <p:stCondLst>
-                        <p:cond delay="1800"/>
-                      </p:stCondLst>
-                      <p:childTnLst>
-                        <p:set>
-                          <p:cBhvr>
-                            <p:cTn id="49" dur="1" fill="hold"/>
-                            <p:tgtEl>
-                              <p:spTgt spid="19"/>
+                            <p:cTn id="66" dur="600"/>
+                            <p:tgtEl>
+                              <p:spTgt spid="20"/>
+                            </p:tgtEl>
+                          </p:cBhvr>
+                        </p:animEffect>
+                      </p:childTnLst>
+                    </p:cTn>
+                  </p:par>
+                  <p:par>
+                    <p:cTn id="67" presetID="10" presetClass="entr" presetSubtype="0" fill="hold" grpId="17" nodeType="withEffect">
+                      <p:stCondLst>
+                        <p:cond delay="1870"/>
+                      </p:stCondLst>
+                      <p:childTnLst>
+                        <p:set>
+                          <p:cBhvr>
+                            <p:cTn id="68" dur="1" fill="hold"/>
+                            <p:tgtEl>
+                              <p:spTgt spid="21"/>
                             </p:tgtEl>
                             <p:attrNameLst>
                               <p:attrName>style.visibility</p:attrName>
@@ -8025,26 +8341,26 @@
                         </p:set>
                         <p:animEffect transition="in" filter="slide(fromLeft)">
                           <p:cBhvr>
-                            <p:cTn id="50" dur="600"/>
-                            <p:tgtEl>
-                              <p:spTgt spid="19"/>
-                            </p:tgtEl>
-                          </p:cBhvr>
-                        </p:animEffect>
-                      </p:childTnLst>
-                    </p:cTn>
-                  </p:par>
-                  <p:par>
-                    <p:cTn id="51" presetID="10" presetClass="entr" presetSubtype="0" fill="hold" grpId="16" nodeType="withEffect">
-                      <p:stCondLst>
-                        <p:cond delay="1920"/>
-                      </p:stCondLst>
-                      <p:childTnLst>
-                        <p:set>
-                          <p:cBhvr>
-                            <p:cTn id="52" dur="1" fill="hold"/>
-                            <p:tgtEl>
-                              <p:spTgt spid="20"/>
+                            <p:cTn id="69" dur="600"/>
+                            <p:tgtEl>
+                              <p:spTgt spid="21"/>
+                            </p:tgtEl>
+                          </p:cBhvr>
+                        </p:animEffect>
+                      </p:childTnLst>
+                    </p:cTn>
+                  </p:par>
+                  <p:par>
+                    <p:cTn id="70" presetID="10" presetClass="entr" presetSubtype="0" fill="hold" grpId="18" nodeType="withEffect">
+                      <p:stCondLst>
+                        <p:cond delay="1980"/>
+                      </p:stCondLst>
+                      <p:childTnLst>
+                        <p:set>
+                          <p:cBhvr>
+                            <p:cTn id="71" dur="1" fill="hold"/>
+                            <p:tgtEl>
+                              <p:spTgt spid="22"/>
                             </p:tgtEl>
                             <p:attrNameLst>
                               <p:attrName>style.visibility</p:attrName>
@@ -8056,26 +8372,26 @@
                         </p:set>
                         <p:animEffect transition="in" filter="slide(fromBottom)">
                           <p:cBhvr>
-                            <p:cTn id="53" dur="600"/>
-                            <p:tgtEl>
-                              <p:spTgt spid="20"/>
-                            </p:tgtEl>
-                          </p:cBhvr>
-                        </p:animEffect>
-                      </p:childTnLst>
-                    </p:cTn>
-                  </p:par>
-                  <p:par>
-                    <p:cTn id="54" presetID="10" presetClass="entr" presetSubtype="0" fill="hold" grpId="17" nodeType="withEffect">
-                      <p:stCondLst>
-                        <p:cond delay="2040"/>
-                      </p:stCondLst>
-                      <p:childTnLst>
-                        <p:set>
-                          <p:cBhvr>
-                            <p:cTn id="55" dur="1" fill="hold"/>
-                            <p:tgtEl>
-                              <p:spTgt spid="21"/>
+                            <p:cTn id="72" dur="600"/>
+                            <p:tgtEl>
+                              <p:spTgt spid="22"/>
+                            </p:tgtEl>
+                          </p:cBhvr>
+                        </p:animEffect>
+                      </p:childTnLst>
+                    </p:cTn>
+                  </p:par>
+                  <p:par>
+                    <p:cTn id="73" presetID="10" presetClass="entr" presetSubtype="0" fill="hold" grpId="19" nodeType="withEffect">
+                      <p:stCondLst>
+                        <p:cond delay="2090"/>
+                      </p:stCondLst>
+                      <p:childTnLst>
+                        <p:set>
+                          <p:cBhvr>
+                            <p:cTn id="74" dur="1" fill="hold"/>
+                            <p:tgtEl>
+                              <p:spTgt spid="23"/>
                             </p:tgtEl>
                             <p:attrNameLst>
                               <p:attrName>style.visibility</p:attrName>
@@ -8087,69 +8403,7 @@
                         </p:set>
                         <p:animEffect transition="in" filter="slide(fromLeft)">
                           <p:cBhvr>
-                            <p:cTn id="56" dur="600"/>
-                            <p:tgtEl>
-                              <p:spTgt spid="21"/>
-                            </p:tgtEl>
-                          </p:cBhvr>
-                        </p:animEffect>
-                      </p:childTnLst>
-                    </p:cTn>
-                  </p:par>
-                  <p:par>
-                    <p:cTn id="57" presetID="10" presetClass="entr" presetSubtype="0" fill="hold" grpId="18" nodeType="withEffect">
-                      <p:stCondLst>
-                        <p:cond delay="2160"/>
-                      </p:stCondLst>
-                      <p:childTnLst>
-                        <p:set>
-                          <p:cBhvr>
-                            <p:cTn id="58" dur="1" fill="hold"/>
-                            <p:tgtEl>
-                              <p:spTgt spid="22"/>
-                            </p:tgtEl>
-                            <p:attrNameLst>
-                              <p:attrName>style.visibility</p:attrName>
-                            </p:attrNameLst>
-                          </p:cBhvr>
-                          <p:to>
-                            <p:strVal val="visible"/>
-                          </p:to>
-                        </p:set>
-                        <p:animEffect transition="in" filter="slide(fromBottom)">
-                          <p:cBhvr>
-                            <p:cTn id="59" dur="600"/>
-                            <p:tgtEl>
-                              <p:spTgt spid="22"/>
-                            </p:tgtEl>
-                          </p:cBhvr>
-                        </p:animEffect>
-                      </p:childTnLst>
-                    </p:cTn>
-                  </p:par>
-                  <p:par>
-                    <p:cTn id="60" presetID="10" presetClass="entr" presetSubtype="0" fill="hold" grpId="19" nodeType="withEffect">
-                      <p:stCondLst>
-                        <p:cond delay="2280"/>
-                      </p:stCondLst>
-                      <p:childTnLst>
-                        <p:set>
-                          <p:cBhvr>
-                            <p:cTn id="61" dur="1" fill="hold"/>
-                            <p:tgtEl>
-                              <p:spTgt spid="23"/>
-                            </p:tgtEl>
-                            <p:attrNameLst>
-                              <p:attrName>style.visibility</p:attrName>
-                            </p:attrNameLst>
-                          </p:cBhvr>
-                          <p:to>
-                            <p:strVal val="visible"/>
-                          </p:to>
-                        </p:set>
-                        <p:animEffect transition="in" filter="slide(fromLeft)">
-                          <p:cBhvr>
-                            <p:cTn id="62" dur="600"/>
+                            <p:cTn id="75" dur="600"/>
                             <p:tgtEl>
                               <p:spTgt spid="23"/>
                             </p:tgtEl>
@@ -8508,14 +8762,14 @@
                 </p:stCondLst>
                 <p:childTnLst>
                   <p:par>
-                    <p:cTn id="3" presetID="10" presetClass="entr" presetSubtype="0" fill="hold" grpId="0" nodeType="withEffect">
+                    <p:cTn id="10" presetID="10" presetClass="entr" presetSubtype="0" fill="hold" grpId="0" nodeType="withEffect">
                       <p:stCondLst>
                         <p:cond delay="0"/>
                       </p:stCondLst>
                       <p:childTnLst>
                         <p:set>
                           <p:cBhvr>
-                            <p:cTn id="4" dur="1" fill="hold"/>
+                            <p:cTn id="11" dur="1" fill="hold"/>
                             <p:tgtEl>
                               <p:spTgt spid="2"/>
                             </p:tgtEl>
@@ -8529,7 +8783,7 @@
                         </p:set>
                         <p:animEffect transition="in" filter="zoom(inCenter)">
                           <p:cBhvr>
-                            <p:cTn id="5" dur="600"/>
+                            <p:cTn id="12" dur="600"/>
                             <p:tgtEl>
                               <p:spTgt spid="2"/>
                             </p:tgtEl>
@@ -8539,14 +8793,32 @@
                     </p:cTn>
                   </p:par>
                   <p:par>
-                    <p:cTn id="6" presetID="10" presetClass="entr" presetSubtype="0" fill="hold" grpId="1" nodeType="withEffect">
+                    <p:cTn id="13" presetID="26" presetClass="emph" presetSubtype="0" fill="hold" grpId="100" nodeType="afterEffect">
+                      <p:stCondLst>
+                        <p:cond delay="700"/>
+                      </p:stCondLst>
+                      <p:childTnLst>
+                        <p:animScale>
+                          <p:by x="115000" y="115000"/>
+                          <p:cBhvr autoRev="1">
+                            <p:cTn id="14" dur="200" autoRev="1"/>
+                            <p:tgtEl>
+                              <p:spTgt spid="2"/>
+                            </p:tgtEl>
+                          </p:cBhvr>
+                        </p:animScale>
+                      </p:childTnLst>
+                    </p:cTn>
+                  </p:par>
+                  <p:par>
+                    <p:cTn id="16" presetID="10" presetClass="entr" presetSubtype="0" fill="hold" grpId="1" nodeType="withEffect">
                       <p:stCondLst>
                         <p:cond delay="120"/>
                       </p:stCondLst>
                       <p:childTnLst>
                         <p:set>
                           <p:cBhvr>
-                            <p:cTn id="7" dur="1" fill="hold"/>
+                            <p:cTn id="17" dur="1" fill="hold"/>
                             <p:tgtEl>
                               <p:spTgt spid="3"/>
                             </p:tgtEl>
@@ -8558,9 +8830,9 @@
                             <p:strVal val="visible"/>
                           </p:to>
                         </p:set>
-                        <p:animEffect transition="in" filter="fade">
-                          <p:cBhvr>
-                            <p:cTn id="8" dur="600"/>
+                        <p:animEffect transition="in" filter="zoom(inCenter)">
+                          <p:cBhvr>
+                            <p:cTn id="18" dur="600"/>
                             <p:tgtEl>
                               <p:spTgt spid="3"/>
                             </p:tgtEl>
@@ -8570,14 +8842,14 @@
                     </p:cTn>
                   </p:par>
                   <p:par>
-                    <p:cTn id="9" presetID="10" presetClass="entr" presetSubtype="0" fill="hold" grpId="2" nodeType="withEffect">
+                    <p:cTn id="19" presetID="10" presetClass="entr" presetSubtype="0" fill="hold" grpId="2" nodeType="withEffect">
                       <p:stCondLst>
                         <p:cond delay="240"/>
                       </p:stCondLst>
                       <p:childTnLst>
                         <p:set>
                           <p:cBhvr>
-                            <p:cTn id="10" dur="1" fill="hold"/>
+                            <p:cTn id="20" dur="1" fill="hold"/>
                             <p:tgtEl>
                               <p:spTgt spid="4"/>
                             </p:tgtEl>
@@ -8591,7 +8863,7 @@
                         </p:set>
                         <p:animEffect transition="in" filter="zoom(inCenter)">
                           <p:cBhvr>
-                            <p:cTn id="11" dur="600"/>
+                            <p:cTn id="21" dur="600"/>
                             <p:tgtEl>
                               <p:spTgt spid="4"/>
                             </p:tgtEl>
@@ -8601,14 +8873,32 @@
                     </p:cTn>
                   </p:par>
                   <p:par>
-                    <p:cTn id="12" presetID="10" presetClass="entr" presetSubtype="0" fill="hold" grpId="3" nodeType="withEffect">
+                    <p:cTn id="22" presetID="26" presetClass="emph" presetSubtype="0" fill="hold" grpId="102" nodeType="afterEffect">
+                      <p:stCondLst>
+                        <p:cond delay="940"/>
+                      </p:stCondLst>
+                      <p:childTnLst>
+                        <p:animScale>
+                          <p:by x="115000" y="115000"/>
+                          <p:cBhvr autoRev="1">
+                            <p:cTn id="23" dur="200" autoRev="1"/>
+                            <p:tgtEl>
+                              <p:spTgt spid="4"/>
+                            </p:tgtEl>
+                          </p:cBhvr>
+                        </p:animScale>
+                      </p:childTnLst>
+                    </p:cTn>
+                  </p:par>
+                  <p:par>
+                    <p:cTn id="25" presetID="10" presetClass="entr" presetSubtype="0" fill="hold" grpId="3" nodeType="withEffect">
                       <p:stCondLst>
                         <p:cond delay="360"/>
                       </p:stCondLst>
                       <p:childTnLst>
                         <p:set>
                           <p:cBhvr>
-                            <p:cTn id="13" dur="1" fill="hold"/>
+                            <p:cTn id="26" dur="1" fill="hold"/>
                             <p:tgtEl>
                               <p:spTgt spid="5"/>
                             </p:tgtEl>
@@ -8620,9 +8910,9 @@
                             <p:strVal val="visible"/>
                           </p:to>
                         </p:set>
-                        <p:animEffect transition="in" filter="fade">
-                          <p:cBhvr>
-                            <p:cTn id="14" dur="600"/>
+                        <p:animEffect transition="in" filter="zoom(inCenter)">
+                          <p:cBhvr>
+                            <p:cTn id="27" dur="600"/>
                             <p:tgtEl>
                               <p:spTgt spid="5"/>
                             </p:tgtEl>
@@ -8632,14 +8922,14 @@
                     </p:cTn>
                   </p:par>
                   <p:par>
-                    <p:cTn id="15" presetID="10" presetClass="entr" presetSubtype="0" fill="hold" grpId="4" nodeType="withEffect">
+                    <p:cTn id="28" presetID="10" presetClass="entr" presetSubtype="0" fill="hold" grpId="4" nodeType="withEffect">
                       <p:stCondLst>
                         <p:cond delay="480"/>
                       </p:stCondLst>
                       <p:childTnLst>
                         <p:set>
                           <p:cBhvr>
-                            <p:cTn id="16" dur="1" fill="hold"/>
+                            <p:cTn id="29" dur="1" fill="hold"/>
                             <p:tgtEl>
                               <p:spTgt spid="6"/>
                             </p:tgtEl>
@@ -8653,7 +8943,7 @@
                         </p:set>
                         <p:animEffect transition="in" filter="zoom(inCenter)">
                           <p:cBhvr>
-                            <p:cTn id="17" dur="600"/>
+                            <p:cTn id="30" dur="600"/>
                             <p:tgtEl>
                               <p:spTgt spid="6"/>
                             </p:tgtEl>
@@ -8663,14 +8953,14 @@
                     </p:cTn>
                   </p:par>
                   <p:par>
-                    <p:cTn id="18" presetID="10" presetClass="entr" presetSubtype="0" fill="hold" grpId="5" nodeType="withEffect">
+                    <p:cTn id="31" presetID="10" presetClass="entr" presetSubtype="0" fill="hold" grpId="5" nodeType="withEffect">
                       <p:stCondLst>
                         <p:cond delay="600"/>
                       </p:stCondLst>
                       <p:childTnLst>
                         <p:set>
                           <p:cBhvr>
-                            <p:cTn id="19" dur="1" fill="hold"/>
+                            <p:cTn id="32" dur="1" fill="hold"/>
                             <p:tgtEl>
                               <p:spTgt spid="7"/>
                             </p:tgtEl>
@@ -8682,9 +8972,9 @@
                             <p:strVal val="visible"/>
                           </p:to>
                         </p:set>
-                        <p:animEffect transition="in" filter="fade">
-                          <p:cBhvr>
-                            <p:cTn id="20" dur="600"/>
+                        <p:animEffect transition="in" filter="zoom(inCenter)">
+                          <p:cBhvr>
+                            <p:cTn id="33" dur="600"/>
                             <p:tgtEl>
                               <p:spTgt spid="7"/>
                             </p:tgtEl>
@@ -9758,7 +10048,7 @@
     <a:masterClrMapping/>
   </p:clrMapOvr>
   <p:transition spd="med">
-    <p:circle/>
+    <p:diamond/>
   </p:transition>
   <p:timing>
     <p:tnLst>
@@ -9772,14 +10062,14 @@
                 </p:stCondLst>
                 <p:childTnLst>
                   <p:par>
-                    <p:cTn id="3" presetID="10" presetClass="entr" presetSubtype="0" fill="hold" grpId="0" nodeType="withEffect">
+                    <p:cTn id="10" presetID="10" presetClass="entr" presetSubtype="0" fill="hold" grpId="0" nodeType="withEffect">
                       <p:stCondLst>
                         <p:cond delay="0"/>
                       </p:stCondLst>
                       <p:childTnLst>
                         <p:set>
                           <p:cBhvr>
-                            <p:cTn id="4" dur="1" fill="hold"/>
+                            <p:cTn id="11" dur="1" fill="hold"/>
                             <p:tgtEl>
                               <p:spTgt spid="2"/>
                             </p:tgtEl>
@@ -9793,7 +10083,7 @@
                         </p:set>
                         <p:animEffect transition="in" filter="wipe(left)">
                           <p:cBhvr>
-                            <p:cTn id="5" dur="350"/>
+                            <p:cTn id="12" dur="350"/>
                             <p:tgtEl>
                               <p:spTgt spid="2"/>
                             </p:tgtEl>
@@ -9803,14 +10093,32 @@
                     </p:cTn>
                   </p:par>
                   <p:par>
-                    <p:cTn id="6" presetID="10" presetClass="entr" presetSubtype="0" fill="hold" grpId="1" nodeType="withEffect">
+                    <p:cTn id="13" presetID="26" presetClass="emph" presetSubtype="0" fill="hold" grpId="100" nodeType="afterEffect">
+                      <p:stCondLst>
+                        <p:cond delay="450"/>
+                      </p:stCondLst>
+                      <p:childTnLst>
+                        <p:animScale>
+                          <p:by x="115000" y="115000"/>
+                          <p:cBhvr autoRev="1">
+                            <p:cTn id="14" dur="200" autoRev="1"/>
+                            <p:tgtEl>
+                              <p:spTgt spid="2"/>
+                            </p:tgtEl>
+                          </p:cBhvr>
+                        </p:animScale>
+                      </p:childTnLst>
+                    </p:cTn>
+                  </p:par>
+                  <p:par>
+                    <p:cTn id="16" presetID="10" presetClass="entr" presetSubtype="0" fill="hold" grpId="1" nodeType="withEffect">
                       <p:stCondLst>
                         <p:cond delay="70"/>
                       </p:stCondLst>
                       <p:childTnLst>
                         <p:set>
                           <p:cBhvr>
-                            <p:cTn id="7" dur="1" fill="hold"/>
+                            <p:cTn id="17" dur="1" fill="hold"/>
                             <p:tgtEl>
                               <p:spTgt spid="3"/>
                             </p:tgtEl>
@@ -9824,7 +10132,7 @@
                         </p:set>
                         <p:animEffect transition="in" filter="wipe(right)">
                           <p:cBhvr>
-                            <p:cTn id="8" dur="350"/>
+                            <p:cTn id="18" dur="350"/>
                             <p:tgtEl>
                               <p:spTgt spid="3"/>
                             </p:tgtEl>
@@ -9834,14 +10142,14 @@
                     </p:cTn>
                   </p:par>
                   <p:par>
-                    <p:cTn id="9" presetID="10" presetClass="entr" presetSubtype="0" fill="hold" grpId="2" nodeType="withEffect">
+                    <p:cTn id="19" presetID="10" presetClass="entr" presetSubtype="0" fill="hold" grpId="2" nodeType="withEffect">
                       <p:stCondLst>
                         <p:cond delay="140"/>
                       </p:stCondLst>
                       <p:childTnLst>
                         <p:set>
                           <p:cBhvr>
-                            <p:cTn id="10" dur="1" fill="hold"/>
+                            <p:cTn id="20" dur="1" fill="hold"/>
                             <p:tgtEl>
                               <p:spTgt spid="4"/>
                             </p:tgtEl>
@@ -9855,7 +10163,7 @@
                         </p:set>
                         <p:animEffect transition="in" filter="wipe(left)">
                           <p:cBhvr>
-                            <p:cTn id="11" dur="350"/>
+                            <p:cTn id="21" dur="350"/>
                             <p:tgtEl>
                               <p:spTgt spid="4"/>
                             </p:tgtEl>
@@ -9865,14 +10173,32 @@
                     </p:cTn>
                   </p:par>
                   <p:par>
-                    <p:cTn id="12" presetID="10" presetClass="entr" presetSubtype="0" fill="hold" grpId="3" nodeType="withEffect">
+                    <p:cTn id="22" presetID="26" presetClass="emph" presetSubtype="0" fill="hold" grpId="102" nodeType="afterEffect">
+                      <p:stCondLst>
+                        <p:cond delay="590"/>
+                      </p:stCondLst>
+                      <p:childTnLst>
+                        <p:animScale>
+                          <p:by x="115000" y="115000"/>
+                          <p:cBhvr autoRev="1">
+                            <p:cTn id="23" dur="200" autoRev="1"/>
+                            <p:tgtEl>
+                              <p:spTgt spid="4"/>
+                            </p:tgtEl>
+                          </p:cBhvr>
+                        </p:animScale>
+                      </p:childTnLst>
+                    </p:cTn>
+                  </p:par>
+                  <p:par>
+                    <p:cTn id="25" presetID="10" presetClass="entr" presetSubtype="0" fill="hold" grpId="3" nodeType="withEffect">
                       <p:stCondLst>
                         <p:cond delay="210"/>
                       </p:stCondLst>
                       <p:childTnLst>
                         <p:set>
                           <p:cBhvr>
-                            <p:cTn id="13" dur="1" fill="hold"/>
+                            <p:cTn id="26" dur="1" fill="hold"/>
                             <p:tgtEl>
                               <p:spTgt spid="5"/>
                             </p:tgtEl>
@@ -9886,7 +10212,7 @@
                         </p:set>
                         <p:animEffect transition="in" filter="wipe(right)">
                           <p:cBhvr>
-                            <p:cTn id="14" dur="350"/>
+                            <p:cTn id="27" dur="350"/>
                             <p:tgtEl>
                               <p:spTgt spid="5"/>
                             </p:tgtEl>
@@ -9896,14 +10222,14 @@
                     </p:cTn>
                   </p:par>
                   <p:par>
-                    <p:cTn id="15" presetID="10" presetClass="entr" presetSubtype="0" fill="hold" grpId="4" nodeType="withEffect">
+                    <p:cTn id="28" presetID="10" presetClass="entr" presetSubtype="0" fill="hold" grpId="4" nodeType="withEffect">
                       <p:stCondLst>
                         <p:cond delay="280"/>
                       </p:stCondLst>
                       <p:childTnLst>
                         <p:set>
                           <p:cBhvr>
-                            <p:cTn id="16" dur="1" fill="hold"/>
+                            <p:cTn id="29" dur="1" fill="hold"/>
                             <p:tgtEl>
                               <p:spTgt spid="6"/>
                             </p:tgtEl>
@@ -9917,7 +10243,7 @@
                         </p:set>
                         <p:animEffect transition="in" filter="wipe(left)">
                           <p:cBhvr>
-                            <p:cTn id="17" dur="350"/>
+                            <p:cTn id="30" dur="350"/>
                             <p:tgtEl>
                               <p:spTgt spid="6"/>
                             </p:tgtEl>
@@ -9927,14 +10253,14 @@
                     </p:cTn>
                   </p:par>
                   <p:par>
-                    <p:cTn id="18" presetID="10" presetClass="entr" presetSubtype="0" fill="hold" grpId="5" nodeType="withEffect">
+                    <p:cTn id="31" presetID="10" presetClass="entr" presetSubtype="0" fill="hold" grpId="5" nodeType="withEffect">
                       <p:stCondLst>
                         <p:cond delay="350"/>
                       </p:stCondLst>
                       <p:childTnLst>
                         <p:set>
                           <p:cBhvr>
-                            <p:cTn id="19" dur="1" fill="hold"/>
+                            <p:cTn id="32" dur="1" fill="hold"/>
                             <p:tgtEl>
                               <p:spTgt spid="7"/>
                             </p:tgtEl>
@@ -9948,7 +10274,7 @@
                         </p:set>
                         <p:animEffect transition="in" filter="wipe(right)">
                           <p:cBhvr>
-                            <p:cTn id="20" dur="350"/>
+                            <p:cTn id="33" dur="350"/>
                             <p:tgtEl>
                               <p:spTgt spid="7"/>
                             </p:tgtEl>
@@ -9958,14 +10284,14 @@
                     </p:cTn>
                   </p:par>
                   <p:par>
-                    <p:cTn id="21" presetID="10" presetClass="entr" presetSubtype="0" fill="hold" grpId="6" nodeType="withEffect">
+                    <p:cTn id="34" presetID="10" presetClass="entr" presetSubtype="0" fill="hold" grpId="6" nodeType="withEffect">
                       <p:stCondLst>
                         <p:cond delay="420"/>
                       </p:stCondLst>
                       <p:childTnLst>
                         <p:set>
                           <p:cBhvr>
-                            <p:cTn id="22" dur="1" fill="hold"/>
+                            <p:cTn id="35" dur="1" fill="hold"/>
                             <p:tgtEl>
                               <p:spTgt spid="8"/>
                             </p:tgtEl>
@@ -9979,7 +10305,7 @@
                         </p:set>
                         <p:animEffect transition="in" filter="wipe(left)">
                           <p:cBhvr>
-                            <p:cTn id="23" dur="350"/>
+                            <p:cTn id="36" dur="350"/>
                             <p:tgtEl>
                               <p:spTgt spid="8"/>
                             </p:tgtEl>
@@ -9989,14 +10315,14 @@
                     </p:cTn>
                   </p:par>
                   <p:par>
-                    <p:cTn id="24" presetID="10" presetClass="entr" presetSubtype="0" fill="hold" grpId="7" nodeType="withEffect">
+                    <p:cTn id="37" presetID="10" presetClass="entr" presetSubtype="0" fill="hold" grpId="7" nodeType="withEffect">
                       <p:stCondLst>
                         <p:cond delay="490"/>
                       </p:stCondLst>
                       <p:childTnLst>
                         <p:set>
                           <p:cBhvr>
-                            <p:cTn id="25" dur="1" fill="hold"/>
+                            <p:cTn id="38" dur="1" fill="hold"/>
                             <p:tgtEl>
                               <p:spTgt spid="9"/>
                             </p:tgtEl>
@@ -10010,7 +10336,7 @@
                         </p:set>
                         <p:animEffect transition="in" filter="wipe(right)">
                           <p:cBhvr>
-                            <p:cTn id="26" dur="350"/>
+                            <p:cTn id="39" dur="350"/>
                             <p:tgtEl>
                               <p:spTgt spid="9"/>
                             </p:tgtEl>
@@ -10020,14 +10346,14 @@
                     </p:cTn>
                   </p:par>
                   <p:par>
-                    <p:cTn id="27" presetID="10" presetClass="entr" presetSubtype="0" fill="hold" grpId="8" nodeType="withEffect">
+                    <p:cTn id="40" presetID="10" presetClass="entr" presetSubtype="0" fill="hold" grpId="8" nodeType="withEffect">
                       <p:stCondLst>
                         <p:cond delay="560"/>
                       </p:stCondLst>
                       <p:childTnLst>
                         <p:set>
                           <p:cBhvr>
-                            <p:cTn id="28" dur="1" fill="hold"/>
+                            <p:cTn id="41" dur="1" fill="hold"/>
                             <p:tgtEl>
                               <p:spTgt spid="10"/>
                             </p:tgtEl>
@@ -10041,7 +10367,7 @@
                         </p:set>
                         <p:animEffect transition="in" filter="wipe(left)">
                           <p:cBhvr>
-                            <p:cTn id="29" dur="350"/>
+                            <p:cTn id="42" dur="350"/>
                             <p:tgtEl>
                               <p:spTgt spid="10"/>
                             </p:tgtEl>
@@ -10051,14 +10377,14 @@
                     </p:cTn>
                   </p:par>
                   <p:par>
-                    <p:cTn id="30" presetID="10" presetClass="entr" presetSubtype="0" fill="hold" grpId="9" nodeType="withEffect">
+                    <p:cTn id="43" presetID="10" presetClass="entr" presetSubtype="0" fill="hold" grpId="9" nodeType="withEffect">
                       <p:stCondLst>
                         <p:cond delay="630"/>
                       </p:stCondLst>
                       <p:childTnLst>
                         <p:set>
                           <p:cBhvr>
-                            <p:cTn id="31" dur="1" fill="hold"/>
+                            <p:cTn id="44" dur="1" fill="hold"/>
                             <p:tgtEl>
                               <p:spTgt spid="11"/>
                             </p:tgtEl>
@@ -10072,7 +10398,7 @@
                         </p:set>
                         <p:animEffect transition="in" filter="wipe(right)">
                           <p:cBhvr>
-                            <p:cTn id="32" dur="350"/>
+                            <p:cTn id="45" dur="350"/>
                             <p:tgtEl>
                               <p:spTgt spid="11"/>
                             </p:tgtEl>
@@ -10082,14 +10408,14 @@
                     </p:cTn>
                   </p:par>
                   <p:par>
-                    <p:cTn id="33" presetID="10" presetClass="entr" presetSubtype="0" fill="hold" grpId="10" nodeType="withEffect">
+                    <p:cTn id="46" presetID="10" presetClass="entr" presetSubtype="0" fill="hold" grpId="10" nodeType="withEffect">
                       <p:stCondLst>
                         <p:cond delay="700"/>
                       </p:stCondLst>
                       <p:childTnLst>
                         <p:set>
                           <p:cBhvr>
-                            <p:cTn id="34" dur="1" fill="hold"/>
+                            <p:cTn id="47" dur="1" fill="hold"/>
                             <p:tgtEl>
                               <p:spTgt spid="12"/>
                             </p:tgtEl>
@@ -10103,7 +10429,7 @@
                         </p:set>
                         <p:animEffect transition="in" filter="wipe(left)">
                           <p:cBhvr>
-                            <p:cTn id="35" dur="350"/>
+                            <p:cTn id="48" dur="350"/>
                             <p:tgtEl>
                               <p:spTgt spid="12"/>
                             </p:tgtEl>
@@ -10113,14 +10439,14 @@
                     </p:cTn>
                   </p:par>
                   <p:par>
-                    <p:cTn id="36" presetID="10" presetClass="entr" presetSubtype="0" fill="hold" grpId="11" nodeType="withEffect">
+                    <p:cTn id="49" presetID="10" presetClass="entr" presetSubtype="0" fill="hold" grpId="11" nodeType="withEffect">
                       <p:stCondLst>
                         <p:cond delay="770"/>
                       </p:stCondLst>
                       <p:childTnLst>
                         <p:set>
                           <p:cBhvr>
-                            <p:cTn id="37" dur="1" fill="hold"/>
+                            <p:cTn id="50" dur="1" fill="hold"/>
                             <p:tgtEl>
                               <p:spTgt spid="13"/>
                             </p:tgtEl>
@@ -10134,7 +10460,7 @@
                         </p:set>
                         <p:animEffect transition="in" filter="wipe(right)">
                           <p:cBhvr>
-                            <p:cTn id="38" dur="350"/>
+                            <p:cTn id="51" dur="350"/>
                             <p:tgtEl>
                               <p:spTgt spid="13"/>
                             </p:tgtEl>
@@ -10144,14 +10470,14 @@
                     </p:cTn>
                   </p:par>
                   <p:par>
-                    <p:cTn id="39" presetID="10" presetClass="entr" presetSubtype="0" fill="hold" grpId="12" nodeType="withEffect">
+                    <p:cTn id="52" presetID="10" presetClass="entr" presetSubtype="0" fill="hold" grpId="12" nodeType="withEffect">
                       <p:stCondLst>
                         <p:cond delay="840"/>
                       </p:stCondLst>
                       <p:childTnLst>
                         <p:set>
                           <p:cBhvr>
-                            <p:cTn id="40" dur="1" fill="hold"/>
+                            <p:cTn id="53" dur="1" fill="hold"/>
                             <p:tgtEl>
                               <p:spTgt spid="14"/>
                             </p:tgtEl>
@@ -10165,7 +10491,7 @@
                         </p:set>
                         <p:animEffect transition="in" filter="wipe(left)">
                           <p:cBhvr>
-                            <p:cTn id="41" dur="350"/>
+                            <p:cTn id="54" dur="350"/>
                             <p:tgtEl>
                               <p:spTgt spid="14"/>
                             </p:tgtEl>
@@ -10175,14 +10501,14 @@
                     </p:cTn>
                   </p:par>
                   <p:par>
-                    <p:cTn id="42" presetID="10" presetClass="entr" presetSubtype="0" fill="hold" grpId="13" nodeType="withEffect">
+                    <p:cTn id="55" presetID="10" presetClass="entr" presetSubtype="0" fill="hold" grpId="13" nodeType="withEffect">
                       <p:stCondLst>
                         <p:cond delay="910"/>
                       </p:stCondLst>
                       <p:childTnLst>
                         <p:set>
                           <p:cBhvr>
-                            <p:cTn id="43" dur="1" fill="hold"/>
+                            <p:cTn id="56" dur="1" fill="hold"/>
                             <p:tgtEl>
                               <p:spTgt spid="15"/>
                             </p:tgtEl>
@@ -10196,7 +10522,7 @@
                         </p:set>
                         <p:animEffect transition="in" filter="wipe(right)">
                           <p:cBhvr>
-                            <p:cTn id="44" dur="350"/>
+                            <p:cTn id="57" dur="350"/>
                             <p:tgtEl>
                               <p:spTgt spid="15"/>
                             </p:tgtEl>
@@ -10206,14 +10532,14 @@
                     </p:cTn>
                   </p:par>
                   <p:par>
-                    <p:cTn id="45" presetID="10" presetClass="entr" presetSubtype="0" fill="hold" grpId="14" nodeType="withEffect">
+                    <p:cTn id="58" presetID="10" presetClass="entr" presetSubtype="0" fill="hold" grpId="14" nodeType="withEffect">
                       <p:stCondLst>
                         <p:cond delay="980"/>
                       </p:stCondLst>
                       <p:childTnLst>
                         <p:set>
                           <p:cBhvr>
-                            <p:cTn id="46" dur="1" fill="hold"/>
+                            <p:cTn id="59" dur="1" fill="hold"/>
                             <p:tgtEl>
                               <p:spTgt spid="16"/>
                             </p:tgtEl>
@@ -10227,7 +10553,7 @@
                         </p:set>
                         <p:animEffect transition="in" filter="wipe(left)">
                           <p:cBhvr>
-                            <p:cTn id="47" dur="350"/>
+                            <p:cTn id="60" dur="350"/>
                             <p:tgtEl>
                               <p:spTgt spid="16"/>
                             </p:tgtEl>
@@ -10237,14 +10563,14 @@
                     </p:cTn>
                   </p:par>
                   <p:par>
-                    <p:cTn id="48" presetID="10" presetClass="entr" presetSubtype="0" fill="hold" grpId="15" nodeType="withEffect">
+                    <p:cTn id="61" presetID="10" presetClass="entr" presetSubtype="0" fill="hold" grpId="15" nodeType="withEffect">
                       <p:stCondLst>
                         <p:cond delay="1050"/>
                       </p:stCondLst>
                       <p:childTnLst>
                         <p:set>
                           <p:cBhvr>
-                            <p:cTn id="49" dur="1" fill="hold"/>
+                            <p:cTn id="62" dur="1" fill="hold"/>
                             <p:tgtEl>
                               <p:spTgt spid="17"/>
                             </p:tgtEl>
@@ -10258,7 +10584,7 @@
                         </p:set>
                         <p:animEffect transition="in" filter="wipe(right)">
                           <p:cBhvr>
-                            <p:cTn id="50" dur="350"/>
+                            <p:cTn id="63" dur="350"/>
                             <p:tgtEl>
                               <p:spTgt spid="17"/>
                             </p:tgtEl>
@@ -10268,14 +10594,14 @@
                     </p:cTn>
                   </p:par>
                   <p:par>
-                    <p:cTn id="51" presetID="10" presetClass="entr" presetSubtype="0" fill="hold" grpId="16" nodeType="withEffect">
+                    <p:cTn id="64" presetID="10" presetClass="entr" presetSubtype="0" fill="hold" grpId="16" nodeType="withEffect">
                       <p:stCondLst>
                         <p:cond delay="1120"/>
                       </p:stCondLst>
                       <p:childTnLst>
                         <p:set>
                           <p:cBhvr>
-                            <p:cTn id="52" dur="1" fill="hold"/>
+                            <p:cTn id="65" dur="1" fill="hold"/>
                             <p:tgtEl>
                               <p:spTgt spid="18"/>
                             </p:tgtEl>
@@ -10289,7 +10615,7 @@
                         </p:set>
                         <p:animEffect transition="in" filter="wipe(left)">
                           <p:cBhvr>
-                            <p:cTn id="53" dur="350"/>
+                            <p:cTn id="66" dur="350"/>
                             <p:tgtEl>
                               <p:spTgt spid="18"/>
                             </p:tgtEl>
@@ -10299,14 +10625,14 @@
                     </p:cTn>
                   </p:par>
                   <p:par>
-                    <p:cTn id="54" presetID="10" presetClass="entr" presetSubtype="0" fill="hold" grpId="17" nodeType="withEffect">
+                    <p:cTn id="67" presetID="10" presetClass="entr" presetSubtype="0" fill="hold" grpId="17" nodeType="withEffect">
                       <p:stCondLst>
                         <p:cond delay="1190"/>
                       </p:stCondLst>
                       <p:childTnLst>
                         <p:set>
                           <p:cBhvr>
-                            <p:cTn id="55" dur="1" fill="hold"/>
+                            <p:cTn id="68" dur="1" fill="hold"/>
                             <p:tgtEl>
                               <p:spTgt spid="19"/>
                             </p:tgtEl>
@@ -10320,7 +10646,7 @@
                         </p:set>
                         <p:animEffect transition="in" filter="wipe(right)">
                           <p:cBhvr>
-                            <p:cTn id="56" dur="350"/>
+                            <p:cTn id="69" dur="350"/>
                             <p:tgtEl>
                               <p:spTgt spid="19"/>
                             </p:tgtEl>
@@ -10330,14 +10656,14 @@
                     </p:cTn>
                   </p:par>
                   <p:par>
-                    <p:cTn id="57" presetID="10" presetClass="entr" presetSubtype="0" fill="hold" grpId="18" nodeType="withEffect">
+                    <p:cTn id="70" presetID="10" presetClass="entr" presetSubtype="0" fill="hold" grpId="18" nodeType="withEffect">
                       <p:stCondLst>
                         <p:cond delay="1260"/>
                       </p:stCondLst>
                       <p:childTnLst>
                         <p:set>
                           <p:cBhvr>
-                            <p:cTn id="58" dur="1" fill="hold"/>
+                            <p:cTn id="71" dur="1" fill="hold"/>
                             <p:tgtEl>
                               <p:spTgt spid="20"/>
                             </p:tgtEl>
@@ -10351,7 +10677,7 @@
                         </p:set>
                         <p:animEffect transition="in" filter="wipe(left)">
                           <p:cBhvr>
-                            <p:cTn id="59" dur="350"/>
+                            <p:cTn id="72" dur="350"/>
                             <p:tgtEl>
                               <p:spTgt spid="20"/>
                             </p:tgtEl>
@@ -10361,14 +10687,14 @@
                     </p:cTn>
                   </p:par>
                   <p:par>
-                    <p:cTn id="60" presetID="10" presetClass="entr" presetSubtype="0" fill="hold" grpId="19" nodeType="withEffect">
+                    <p:cTn id="73" presetID="10" presetClass="entr" presetSubtype="0" fill="hold" grpId="19" nodeType="withEffect">
                       <p:stCondLst>
                         <p:cond delay="1330"/>
                       </p:stCondLst>
                       <p:childTnLst>
                         <p:set>
                           <p:cBhvr>
-                            <p:cTn id="61" dur="1" fill="hold"/>
+                            <p:cTn id="74" dur="1" fill="hold"/>
                             <p:tgtEl>
                               <p:spTgt spid="21"/>
                             </p:tgtEl>
@@ -10382,7 +10708,7 @@
                         </p:set>
                         <p:animEffect transition="in" filter="wipe(right)">
                           <p:cBhvr>
-                            <p:cTn id="62" dur="350"/>
+                            <p:cTn id="75" dur="350"/>
                             <p:tgtEl>
                               <p:spTgt spid="21"/>
                             </p:tgtEl>
@@ -10392,14 +10718,14 @@
                     </p:cTn>
                   </p:par>
                   <p:par>
-                    <p:cTn id="63" presetID="10" presetClass="entr" presetSubtype="0" fill="hold" grpId="20" nodeType="withEffect">
+                    <p:cTn id="76" presetID="10" presetClass="entr" presetSubtype="0" fill="hold" grpId="20" nodeType="withEffect">
                       <p:stCondLst>
                         <p:cond delay="1400"/>
                       </p:stCondLst>
                       <p:childTnLst>
                         <p:set>
                           <p:cBhvr>
-                            <p:cTn id="64" dur="1" fill="hold"/>
+                            <p:cTn id="77" dur="1" fill="hold"/>
                             <p:tgtEl>
                               <p:spTgt spid="22"/>
                             </p:tgtEl>
@@ -10413,7 +10739,7 @@
                         </p:set>
                         <p:animEffect transition="in" filter="wipe(left)">
                           <p:cBhvr>
-                            <p:cTn id="65" dur="350"/>
+                            <p:cTn id="78" dur="350"/>
                             <p:tgtEl>
                               <p:spTgt spid="22"/>
                             </p:tgtEl>
@@ -10423,14 +10749,14 @@
                     </p:cTn>
                   </p:par>
                   <p:par>
-                    <p:cTn id="66" presetID="10" presetClass="entr" presetSubtype="0" fill="hold" grpId="21" nodeType="withEffect">
+                    <p:cTn id="79" presetID="10" presetClass="entr" presetSubtype="0" fill="hold" grpId="21" nodeType="withEffect">
                       <p:stCondLst>
                         <p:cond delay="1470"/>
                       </p:stCondLst>
                       <p:childTnLst>
                         <p:set>
                           <p:cBhvr>
-                            <p:cTn id="67" dur="1" fill="hold"/>
+                            <p:cTn id="80" dur="1" fill="hold"/>
                             <p:tgtEl>
                               <p:spTgt spid="23"/>
                             </p:tgtEl>
@@ -10444,7 +10770,7 @@
                         </p:set>
                         <p:animEffect transition="in" filter="wipe(right)">
                           <p:cBhvr>
-                            <p:cTn id="68" dur="350"/>
+                            <p:cTn id="81" dur="350"/>
                             <p:tgtEl>
                               <p:spTgt spid="23"/>
                             </p:tgtEl>
@@ -10454,14 +10780,14 @@
                     </p:cTn>
                   </p:par>
                   <p:par>
-                    <p:cTn id="69" presetID="10" presetClass="entr" presetSubtype="0" fill="hold" grpId="22" nodeType="withEffect">
+                    <p:cTn id="82" presetID="10" presetClass="entr" presetSubtype="0" fill="hold" grpId="22" nodeType="withEffect">
                       <p:stCondLst>
                         <p:cond delay="1540"/>
                       </p:stCondLst>
                       <p:childTnLst>
                         <p:set>
                           <p:cBhvr>
-                            <p:cTn id="70" dur="1" fill="hold"/>
+                            <p:cTn id="83" dur="1" fill="hold"/>
                             <p:tgtEl>
                               <p:spTgt spid="24"/>
                             </p:tgtEl>
@@ -10475,7 +10801,7 @@
                         </p:set>
                         <p:animEffect transition="in" filter="wipe(left)">
                           <p:cBhvr>
-                            <p:cTn id="71" dur="350"/>
+                            <p:cTn id="84" dur="350"/>
                             <p:tgtEl>
                               <p:spTgt spid="24"/>
                             </p:tgtEl>
@@ -10485,14 +10811,14 @@
                     </p:cTn>
                   </p:par>
                   <p:par>
-                    <p:cTn id="72" presetID="10" presetClass="entr" presetSubtype="0" fill="hold" grpId="23" nodeType="withEffect">
+                    <p:cTn id="85" presetID="10" presetClass="entr" presetSubtype="0" fill="hold" grpId="23" nodeType="withEffect">
                       <p:stCondLst>
                         <p:cond delay="1610"/>
                       </p:stCondLst>
                       <p:childTnLst>
                         <p:set>
                           <p:cBhvr>
-                            <p:cTn id="73" dur="1" fill="hold"/>
+                            <p:cTn id="86" dur="1" fill="hold"/>
                             <p:tgtEl>
                               <p:spTgt spid="25"/>
                             </p:tgtEl>
@@ -10506,7 +10832,7 @@
                         </p:set>
                         <p:animEffect transition="in" filter="wipe(right)">
                           <p:cBhvr>
-                            <p:cTn id="74" dur="350"/>
+                            <p:cTn id="87" dur="350"/>
                             <p:tgtEl>
                               <p:spTgt spid="25"/>
                             </p:tgtEl>
@@ -10516,14 +10842,14 @@
                     </p:cTn>
                   </p:par>
                   <p:par>
-                    <p:cTn id="75" presetID="10" presetClass="entr" presetSubtype="0" fill="hold" grpId="24" nodeType="withEffect">
+                    <p:cTn id="88" presetID="10" presetClass="entr" presetSubtype="0" fill="hold" grpId="24" nodeType="withEffect">
                       <p:stCondLst>
                         <p:cond delay="1680"/>
                       </p:stCondLst>
                       <p:childTnLst>
                         <p:set>
                           <p:cBhvr>
-                            <p:cTn id="76" dur="1" fill="hold"/>
+                            <p:cTn id="89" dur="1" fill="hold"/>
                             <p:tgtEl>
                               <p:spTgt spid="26"/>
                             </p:tgtEl>
@@ -10537,7 +10863,7 @@
                         </p:set>
                         <p:animEffect transition="in" filter="wipe(left)">
                           <p:cBhvr>
-                            <p:cTn id="77" dur="350"/>
+                            <p:cTn id="90" dur="350"/>
                             <p:tgtEl>
                               <p:spTgt spid="26"/>
                             </p:tgtEl>
@@ -10547,14 +10873,14 @@
                     </p:cTn>
                   </p:par>
                   <p:par>
-                    <p:cTn id="78" presetID="10" presetClass="entr" presetSubtype="0" fill="hold" grpId="25" nodeType="withEffect">
+                    <p:cTn id="91" presetID="10" presetClass="entr" presetSubtype="0" fill="hold" grpId="25" nodeType="withEffect">
                       <p:stCondLst>
                         <p:cond delay="1750"/>
                       </p:stCondLst>
                       <p:childTnLst>
                         <p:set>
                           <p:cBhvr>
-                            <p:cTn id="79" dur="1" fill="hold"/>
+                            <p:cTn id="92" dur="1" fill="hold"/>
                             <p:tgtEl>
                               <p:spTgt spid="27"/>
                             </p:tgtEl>
@@ -10568,7 +10894,7 @@
                         </p:set>
                         <p:animEffect transition="in" filter="wipe(right)">
                           <p:cBhvr>
-                            <p:cTn id="80" dur="350"/>
+                            <p:cTn id="93" dur="350"/>
                             <p:tgtEl>
                               <p:spTgt spid="27"/>
                             </p:tgtEl>
@@ -10578,14 +10904,14 @@
                     </p:cTn>
                   </p:par>
                   <p:par>
-                    <p:cTn id="81" presetID="10" presetClass="entr" presetSubtype="0" fill="hold" grpId="26" nodeType="withEffect">
+                    <p:cTn id="94" presetID="10" presetClass="entr" presetSubtype="0" fill="hold" grpId="26" nodeType="withEffect">
                       <p:stCondLst>
                         <p:cond delay="1820"/>
                       </p:stCondLst>
                       <p:childTnLst>
                         <p:set>
                           <p:cBhvr>
-                            <p:cTn id="82" dur="1" fill="hold"/>
+                            <p:cTn id="95" dur="1" fill="hold"/>
                             <p:tgtEl>
                               <p:spTgt spid="28"/>
                             </p:tgtEl>
@@ -10599,7 +10925,7 @@
                         </p:set>
                         <p:animEffect transition="in" filter="wipe(left)">
                           <p:cBhvr>
-                            <p:cTn id="83" dur="350"/>
+                            <p:cTn id="96" dur="350"/>
                             <p:tgtEl>
                               <p:spTgt spid="28"/>
                             </p:tgtEl>
@@ -10609,14 +10935,14 @@
                     </p:cTn>
                   </p:par>
                   <p:par>
-                    <p:cTn id="84" presetID="10" presetClass="entr" presetSubtype="0" fill="hold" grpId="27" nodeType="withEffect">
+                    <p:cTn id="97" presetID="10" presetClass="entr" presetSubtype="0" fill="hold" grpId="27" nodeType="withEffect">
                       <p:stCondLst>
                         <p:cond delay="1890"/>
                       </p:stCondLst>
                       <p:childTnLst>
                         <p:set>
                           <p:cBhvr>
-                            <p:cTn id="85" dur="1" fill="hold"/>
+                            <p:cTn id="98" dur="1" fill="hold"/>
                             <p:tgtEl>
                               <p:spTgt spid="29"/>
                             </p:tgtEl>
@@ -10630,7 +10956,7 @@
                         </p:set>
                         <p:animEffect transition="in" filter="wipe(right)">
                           <p:cBhvr>
-                            <p:cTn id="86" dur="350"/>
+                            <p:cTn id="99" dur="350"/>
                             <p:tgtEl>
                               <p:spTgt spid="29"/>
                             </p:tgtEl>
@@ -10640,14 +10966,14 @@
                     </p:cTn>
                   </p:par>
                   <p:par>
-                    <p:cTn id="87" presetID="10" presetClass="entr" presetSubtype="0" fill="hold" grpId="28" nodeType="withEffect">
+                    <p:cTn id="100" presetID="10" presetClass="entr" presetSubtype="0" fill="hold" grpId="28" nodeType="withEffect">
                       <p:stCondLst>
                         <p:cond delay="1960"/>
                       </p:stCondLst>
                       <p:childTnLst>
                         <p:set>
                           <p:cBhvr>
-                            <p:cTn id="88" dur="1" fill="hold"/>
+                            <p:cTn id="101" dur="1" fill="hold"/>
                             <p:tgtEl>
                               <p:spTgt spid="30"/>
                             </p:tgtEl>
@@ -10661,7 +10987,7 @@
                         </p:set>
                         <p:animEffect transition="in" filter="wipe(left)">
                           <p:cBhvr>
-                            <p:cTn id="89" dur="350"/>
+                            <p:cTn id="102" dur="350"/>
                             <p:tgtEl>
                               <p:spTgt spid="30"/>
                             </p:tgtEl>
@@ -10671,14 +10997,14 @@
                     </p:cTn>
                   </p:par>
                   <p:par>
-                    <p:cTn id="90" presetID="10" presetClass="entr" presetSubtype="0" fill="hold" grpId="29" nodeType="withEffect">
+                    <p:cTn id="103" presetID="10" presetClass="entr" presetSubtype="0" fill="hold" grpId="29" nodeType="withEffect">
                       <p:stCondLst>
                         <p:cond delay="2030"/>
                       </p:stCondLst>
                       <p:childTnLst>
                         <p:set>
                           <p:cBhvr>
-                            <p:cTn id="91" dur="1" fill="hold"/>
+                            <p:cTn id="104" dur="1" fill="hold"/>
                             <p:tgtEl>
                               <p:spTgt spid="31"/>
                             </p:tgtEl>
@@ -10692,7 +11018,7 @@
                         </p:set>
                         <p:animEffect transition="in" filter="wipe(right)">
                           <p:cBhvr>
-                            <p:cTn id="92" dur="350"/>
+                            <p:cTn id="105" dur="350"/>
                             <p:tgtEl>
                               <p:spTgt spid="31"/>
                             </p:tgtEl>
@@ -10702,14 +11028,14 @@
                     </p:cTn>
                   </p:par>
                   <p:par>
-                    <p:cTn id="93" presetID="10" presetClass="entr" presetSubtype="0" fill="hold" grpId="30" nodeType="withEffect">
+                    <p:cTn id="106" presetID="10" presetClass="entr" presetSubtype="0" fill="hold" grpId="30" nodeType="withEffect">
                       <p:stCondLst>
                         <p:cond delay="2100"/>
                       </p:stCondLst>
                       <p:childTnLst>
                         <p:set>
                           <p:cBhvr>
-                            <p:cTn id="94" dur="1" fill="hold"/>
+                            <p:cTn id="107" dur="1" fill="hold"/>
                             <p:tgtEl>
                               <p:spTgt spid="32"/>
                             </p:tgtEl>
@@ -10723,7 +11049,7 @@
                         </p:set>
                         <p:animEffect transition="in" filter="wipe(left)">
                           <p:cBhvr>
-                            <p:cTn id="95" dur="350"/>
+                            <p:cTn id="108" dur="350"/>
                             <p:tgtEl>
                               <p:spTgt spid="32"/>
                             </p:tgtEl>
@@ -10733,14 +11059,14 @@
                     </p:cTn>
                   </p:par>
                   <p:par>
-                    <p:cTn id="96" presetID="10" presetClass="entr" presetSubtype="0" fill="hold" grpId="31" nodeType="withEffect">
+                    <p:cTn id="109" presetID="10" presetClass="entr" presetSubtype="0" fill="hold" grpId="31" nodeType="withEffect">
                       <p:stCondLst>
                         <p:cond delay="2170"/>
                       </p:stCondLst>
                       <p:childTnLst>
                         <p:set>
                           <p:cBhvr>
-                            <p:cTn id="97" dur="1" fill="hold"/>
+                            <p:cTn id="110" dur="1" fill="hold"/>
                             <p:tgtEl>
                               <p:spTgt spid="33"/>
                             </p:tgtEl>
@@ -10754,7 +11080,7 @@
                         </p:set>
                         <p:animEffect transition="in" filter="wipe(right)">
                           <p:cBhvr>
-                            <p:cTn id="98" dur="350"/>
+                            <p:cTn id="111" dur="350"/>
                             <p:tgtEl>
                               <p:spTgt spid="33"/>
                             </p:tgtEl>
@@ -10764,14 +11090,14 @@
                     </p:cTn>
                   </p:par>
                   <p:par>
-                    <p:cTn id="99" presetID="10" presetClass="entr" presetSubtype="0" fill="hold" grpId="32" nodeType="withEffect">
+                    <p:cTn id="112" presetID="10" presetClass="entr" presetSubtype="0" fill="hold" grpId="32" nodeType="withEffect">
                       <p:stCondLst>
                         <p:cond delay="2240"/>
                       </p:stCondLst>
                       <p:childTnLst>
                         <p:set>
                           <p:cBhvr>
-                            <p:cTn id="100" dur="1" fill="hold"/>
+                            <p:cTn id="113" dur="1" fill="hold"/>
                             <p:tgtEl>
                               <p:spTgt spid="34"/>
                             </p:tgtEl>
@@ -10785,7 +11111,7 @@
                         </p:set>
                         <p:animEffect transition="in" filter="wipe(left)">
                           <p:cBhvr>
-                            <p:cTn id="101" dur="350"/>
+                            <p:cTn id="114" dur="350"/>
                             <p:tgtEl>
                               <p:spTgt spid="34"/>
                             </p:tgtEl>
@@ -11119,14 +11445,14 @@
                 </p:stCondLst>
                 <p:childTnLst>
                   <p:par>
-                    <p:cTn id="3" presetID="10" presetClass="entr" presetSubtype="0" fill="hold" grpId="0" nodeType="withEffect">
+                    <p:cTn id="10" presetID="10" presetClass="entr" presetSubtype="0" fill="hold" grpId="0" nodeType="withEffect">
                       <p:stCondLst>
                         <p:cond delay="0"/>
                       </p:stCondLst>
                       <p:childTnLst>
                         <p:set>
                           <p:cBhvr>
-                            <p:cTn id="4" dur="1" fill="hold"/>
+                            <p:cTn id="11" dur="1" fill="hold"/>
                             <p:tgtEl>
                               <p:spTgt spid="2"/>
                             </p:tgtEl>
@@ -11140,7 +11466,7 @@
                         </p:set>
                         <p:animEffect transition="in" filter="zoom(inCenter)">
                           <p:cBhvr>
-                            <p:cTn id="5" dur="900"/>
+                            <p:cTn id="12" dur="900"/>
                             <p:tgtEl>
                               <p:spTgt spid="2"/>
                             </p:tgtEl>
@@ -11150,14 +11476,32 @@
                     </p:cTn>
                   </p:par>
                   <p:par>
-                    <p:cTn id="6" presetID="10" presetClass="entr" presetSubtype="0" fill="hold" grpId="1" nodeType="withEffect">
+                    <p:cTn id="13" presetID="26" presetClass="emph" presetSubtype="0" fill="hold" grpId="100" nodeType="afterEffect">
+                      <p:stCondLst>
+                        <p:cond delay="1000"/>
+                      </p:stCondLst>
+                      <p:childTnLst>
+                        <p:animScale>
+                          <p:by x="115000" y="115000"/>
+                          <p:cBhvr autoRev="1">
+                            <p:cTn id="14" dur="200" autoRev="1"/>
+                            <p:tgtEl>
+                              <p:spTgt spid="2"/>
+                            </p:tgtEl>
+                          </p:cBhvr>
+                        </p:animScale>
+                      </p:childTnLst>
+                    </p:cTn>
+                  </p:par>
+                  <p:par>
+                    <p:cTn id="16" presetID="10" presetClass="entr" presetSubtype="0" fill="hold" grpId="1" nodeType="withEffect">
                       <p:stCondLst>
                         <p:cond delay="200"/>
                       </p:stCondLst>
                       <p:childTnLst>
                         <p:set>
                           <p:cBhvr>
-                            <p:cTn id="7" dur="1" fill="hold"/>
+                            <p:cTn id="17" dur="1" fill="hold"/>
                             <p:tgtEl>
                               <p:spTgt spid="3"/>
                             </p:tgtEl>
@@ -11171,7 +11515,7 @@
                         </p:set>
                         <p:animEffect transition="in" filter="dissolve">
                           <p:cBhvr>
-                            <p:cTn id="8" dur="900"/>
+                            <p:cTn id="18" dur="900"/>
                             <p:tgtEl>
                               <p:spTgt spid="3"/>
                             </p:tgtEl>
@@ -11181,14 +11525,14 @@
                     </p:cTn>
                   </p:par>
                   <p:par>
-                    <p:cTn id="9" presetID="10" presetClass="entr" presetSubtype="0" fill="hold" grpId="2" nodeType="withEffect">
+                    <p:cTn id="19" presetID="10" presetClass="entr" presetSubtype="0" fill="hold" grpId="2" nodeType="withEffect">
                       <p:stCondLst>
                         <p:cond delay="400"/>
                       </p:stCondLst>
                       <p:childTnLst>
                         <p:set>
                           <p:cBhvr>
-                            <p:cTn id="10" dur="1" fill="hold"/>
+                            <p:cTn id="20" dur="1" fill="hold"/>
                             <p:tgtEl>
                               <p:spTgt spid="4"/>
                             </p:tgtEl>
@@ -11202,7 +11546,7 @@
                         </p:set>
                         <p:animEffect transition="in" filter="zoom(inCenter)">
                           <p:cBhvr>
-                            <p:cTn id="11" dur="900"/>
+                            <p:cTn id="21" dur="900"/>
                             <p:tgtEl>
                               <p:spTgt spid="4"/>
                             </p:tgtEl>
@@ -11212,14 +11556,32 @@
                     </p:cTn>
                   </p:par>
                   <p:par>
-                    <p:cTn id="12" presetID="10" presetClass="entr" presetSubtype="0" fill="hold" grpId="3" nodeType="withEffect">
+                    <p:cTn id="22" presetID="26" presetClass="emph" presetSubtype="0" fill="hold" grpId="102" nodeType="afterEffect">
+                      <p:stCondLst>
+                        <p:cond delay="1400"/>
+                      </p:stCondLst>
+                      <p:childTnLst>
+                        <p:animScale>
+                          <p:by x="115000" y="115000"/>
+                          <p:cBhvr autoRev="1">
+                            <p:cTn id="23" dur="200" autoRev="1"/>
+                            <p:tgtEl>
+                              <p:spTgt spid="4"/>
+                            </p:tgtEl>
+                          </p:cBhvr>
+                        </p:animScale>
+                      </p:childTnLst>
+                    </p:cTn>
+                  </p:par>
+                  <p:par>
+                    <p:cTn id="25" presetID="10" presetClass="entr" presetSubtype="0" fill="hold" grpId="3" nodeType="withEffect">
                       <p:stCondLst>
                         <p:cond delay="600"/>
                       </p:stCondLst>
                       <p:childTnLst>
                         <p:set>
                           <p:cBhvr>
-                            <p:cTn id="13" dur="1" fill="hold"/>
+                            <p:cTn id="26" dur="1" fill="hold"/>
                             <p:tgtEl>
                               <p:spTgt spid="7"/>
                             </p:tgtEl>
@@ -11233,7 +11595,7 @@
                         </p:set>
                         <p:animEffect transition="in" filter="dissolve">
                           <p:cBhvr>
-                            <p:cTn id="14" dur="900"/>
+                            <p:cTn id="27" dur="900"/>
                             <p:tgtEl>
                               <p:spTgt spid="7"/>
                             </p:tgtEl>
@@ -11243,14 +11605,14 @@
                     </p:cTn>
                   </p:par>
                   <p:par>
-                    <p:cTn id="15" presetID="10" presetClass="entr" presetSubtype="0" fill="hold" grpId="4" nodeType="withEffect">
+                    <p:cTn id="28" presetID="10" presetClass="entr" presetSubtype="0" fill="hold" grpId="4" nodeType="withEffect">
                       <p:stCondLst>
                         <p:cond delay="800"/>
                       </p:stCondLst>
                       <p:childTnLst>
                         <p:set>
                           <p:cBhvr>
-                            <p:cTn id="16" dur="1" fill="hold"/>
+                            <p:cTn id="29" dur="1" fill="hold"/>
                             <p:tgtEl>
                               <p:spTgt spid="8"/>
                             </p:tgtEl>
@@ -11264,7 +11626,7 @@
                         </p:set>
                         <p:animEffect transition="in" filter="zoom(inCenter)">
                           <p:cBhvr>
-                            <p:cTn id="17" dur="900"/>
+                            <p:cTn id="30" dur="900"/>
                             <p:tgtEl>
                               <p:spTgt spid="8"/>
                             </p:tgtEl>
@@ -11274,14 +11636,14 @@
                     </p:cTn>
                   </p:par>
                   <p:par>
-                    <p:cTn id="18" presetID="10" presetClass="entr" presetSubtype="0" fill="hold" grpId="5" nodeType="withEffect">
+                    <p:cTn id="31" presetID="10" presetClass="entr" presetSubtype="0" fill="hold" grpId="5" nodeType="withEffect">
                       <p:stCondLst>
                         <p:cond delay="1000"/>
                       </p:stCondLst>
                       <p:childTnLst>
                         <p:set>
                           <p:cBhvr>
-                            <p:cTn id="19" dur="1" fill="hold"/>
+                            <p:cTn id="32" dur="1" fill="hold"/>
                             <p:tgtEl>
                               <p:spTgt spid="9"/>
                             </p:tgtEl>
@@ -11295,7 +11657,7 @@
                         </p:set>
                         <p:animEffect transition="in" filter="dissolve">
                           <p:cBhvr>
-                            <p:cTn id="20" dur="900"/>
+                            <p:cTn id="33" dur="900"/>
                             <p:tgtEl>
                               <p:spTgt spid="9"/>
                             </p:tgtEl>
@@ -11305,14 +11667,14 @@
                     </p:cTn>
                   </p:par>
                   <p:par>
-                    <p:cTn id="21" presetID="10" presetClass="entr" presetSubtype="0" fill="hold" grpId="6" nodeType="withEffect">
+                    <p:cTn id="34" presetID="10" presetClass="entr" presetSubtype="0" fill="hold" grpId="6" nodeType="withEffect">
                       <p:stCondLst>
                         <p:cond delay="1200"/>
                       </p:stCondLst>
                       <p:childTnLst>
                         <p:set>
                           <p:cBhvr>
-                            <p:cTn id="22" dur="1" fill="hold"/>
+                            <p:cTn id="35" dur="1" fill="hold"/>
                             <p:tgtEl>
                               <p:spTgt spid="10"/>
                             </p:tgtEl>
@@ -11326,7 +11688,7 @@
                         </p:set>
                         <p:animEffect transition="in" filter="zoom(inCenter)">
                           <p:cBhvr>
-                            <p:cTn id="23" dur="900"/>
+                            <p:cTn id="36" dur="900"/>
                             <p:tgtEl>
                               <p:spTgt spid="10"/>
                             </p:tgtEl>

</xml_diff>

<commit_message>
Fix audio shape so PowerPoint can open the file
Replace broken <p:pic> with <p:blipFill> (which pointed to a WAV file,
causing PowerPoint to refuse to open) with a correct <p:sp> shape that
uses <p:cNvMediaPr><a:audioFile r:link="rId99"/> and no blipFill.

Co-Authored-By: Claude Sonnet 4.6 <noreply@anthropic.com>
Claude-Session: https://claude.ai/code/session_01QS7srrPkzgdxeHFxN7zTWR
</commit_message>
<xml_diff>
--- a/rl_bachelor_extra.pptx
+++ b/rl_bachelor_extra.pptx
@@ -2477,26 +2477,20 @@
           </a:prstGeom>
         </p:spPr>
       </p:pic>
-      <p:pic>
-        <p:nvPicPr>
+      <p:sp>
+        <p:nvSpPr>
           <p:cNvPr id="499" name="bg_audio">
             <a:hlinkClick r:id="rId99" action="ppaction://media"/>
           </p:cNvPr>
-          <p:cNvPicPr>
-            <a:picLocks noRot="1" noChangeAspect="1" noMove="1" noResize="1" noSelect="1" noCrop="1" noGrp="1"/>
-          </p:cNvPicPr>
+          <p:cNvSpPr>
+            <a:spLocks noGrp="1"/>
+          </p:cNvSpPr>
           <p:nvPr>
             <p:cNvMediaPr>
               <a:audioFile r:link="rId99"/>
             </p:cNvMediaPr>
           </p:nvPr>
-        </p:nvPicPr>
-        <p:blipFill>
-          <a:blip r:embed="rId99"/>
-          <a:stretch>
-            <a:fillRect/>
-          </a:stretch>
-        </p:blipFill>
+        </p:nvSpPr>
         <p:spPr>
           <a:xfrm>
             <a:off x="-914400" y="-914400"/>
@@ -2505,8 +2499,16 @@
           <a:prstGeom prst="rect">
             <a:avLst/>
           </a:prstGeom>
-        </p:spPr>
-      </p:pic>
+          <a:solidFill>
+            <a:srgbClr val="000000">
+              <a:alpha val="0"/>
+            </a:srgbClr>
+          </a:solidFill>
+          <a:ln>
+            <a:noFill/>
+          </a:ln>
+        </p:spPr>
+      </p:sp>
     </p:spTree>
   </p:cSld>
   <p:clrMapOvr>

</xml_diff>

<commit_message>
Remove audio from final pptx — audio embedding caused PowerPoint to reject file
Audio was confirmed as the culprit via bisect testing. Removed the WAV
generation, audio shape injection, audio relationship, and audio timing
from the slide processing loop. All visual effects (decorations, transitions,
cascade animations) are retained.

Co-Authored-By: Claude Sonnet 4.6 <noreply@anthropic.com>
Claude-Session: https://claude.ai/code/session_01QS7srrPkzgdxeHFxN7zTWR
</commit_message>
<xml_diff>
--- a/rl_bachelor_extra.pptx
+++ b/rl_bachelor_extra.pptx
@@ -2477,38 +2477,6 @@
           </a:prstGeom>
         </p:spPr>
       </p:pic>
-      <p:sp>
-        <p:nvSpPr>
-          <p:cNvPr id="499" name="bg_audio">
-            <a:hlinkClick r:id="rId99" action="ppaction://media"/>
-          </p:cNvPr>
-          <p:cNvSpPr>
-            <a:spLocks noGrp="1"/>
-          </p:cNvSpPr>
-          <p:nvPr>
-            <p:cNvMediaPr>
-              <a:audioFile r:link="rId99"/>
-            </p:cNvMediaPr>
-          </p:nvPr>
-        </p:nvSpPr>
-        <p:spPr>
-          <a:xfrm>
-            <a:off x="-914400" y="-914400"/>
-            <a:ext cx="457200" cy="457200"/>
-          </a:xfrm>
-          <a:prstGeom prst="rect">
-            <a:avLst/>
-          </a:prstGeom>
-          <a:solidFill>
-            <a:srgbClr val="000000">
-              <a:alpha val="0"/>
-            </a:srgbClr>
-          </a:solidFill>
-          <a:ln>
-            <a:noFill/>
-          </a:ln>
-        </p:spPr>
-      </p:sp>
     </p:spTree>
   </p:cSld>
   <p:clrMapOvr>
@@ -2522,32 +2490,6 @@
       <p:par>
         <p:cTn id="1" dur="indefinite" restart="whenNotActive" nodeType="tmRoot">
           <p:childTnLst>
-            <p:par>
-              <p:cTn id="5" fill="hold">
-                <p:stCondLst>
-                  <p:cond delay="0"/>
-                </p:stCondLst>
-                <p:childTnLst>
-                  <p:par>
-                    <p:cTn id="900" fill="hold" nodeType="withEffect">
-                      <p:stCondLst>
-                        <p:cond delay="0"/>
-                      </p:stCondLst>
-                      <p:childTnLst>
-                        <p:audio isNarration="0">
-                          <p:cMediaNode vol="80000" mute="0" numSld="9" showWhenStopped="0">
-                            <p:cTn id="901" fill="hold" nodeType="withEffect"/>
-                            <p:tgtEl>
-                              <p:spTgt spid="499"/>
-                            </p:tgtEl>
-                          </p:cMediaNode>
-                        </p:audio>
-                      </p:childTnLst>
-                    </p:cTn>
-                  </p:par>
-                </p:childTnLst>
-              </p:cTn>
-            </p:par>
             <p:par>
               <p:cTn id="2" fill="hold">
                 <p:stCondLst>

</xml_diff>

<commit_message>
Fix iOS PowerPoint compatibility: remove glow effects and unsupported transitions
iOS PowerPoint rejects glow effects (<a:effectLst><a:glow>) and the
strips/checker/diamond transitions. Replaced with wipe/blinds/circle
which are confirmed working on mobile, and stripped all glow effects
from decorative shapes. All other visuals and animations retained.

Co-Authored-By: Claude Sonnet 4.6 <noreply@anthropic.com>
Claude-Session: https://claude.ai/code/session_01QS7srrPkzgdxeHFxN7zTWR
</commit_message>
<xml_diff>
--- a/rl_bachelor_extra.pptx
+++ b/rl_bachelor_extra.pptx
@@ -1589,13 +1589,6 @@
               </a:srgbClr>
             </a:solidFill>
           </a:ln>
-          <a:effectLst>
-            <a:glow rad="300000">
-              <a:srgbClr val="FF6D00">
-                <a:alpha val="42000"/>
-              </a:srgbClr>
-            </a:glow>
-          </a:effectLst>
         </p:spPr>
       </p:sp>
       <p:sp>
@@ -1620,13 +1613,6 @@
               </a:srgbClr>
             </a:solidFill>
           </a:ln>
-          <a:effectLst>
-            <a:glow rad="200000">
-              <a:srgbClr val="00BCD4">
-                <a:alpha val="38000"/>
-              </a:srgbClr>
-            </a:glow>
-          </a:effectLst>
         </p:spPr>
       </p:sp>
       <p:sp>
@@ -1651,13 +1637,6 @@
               </a:srgbClr>
             </a:solidFill>
           </a:ln>
-          <a:effectLst>
-            <a:glow rad="200000">
-              <a:srgbClr val="2196F3">
-                <a:alpha val="30000"/>
-              </a:srgbClr>
-            </a:glow>
-          </a:effectLst>
         </p:spPr>
       </p:sp>
       <p:sp>
@@ -1682,13 +1661,6 @@
               </a:srgbClr>
             </a:solidFill>
           </a:ln>
-          <a:effectLst>
-            <a:glow rad="200000">
-              <a:srgbClr val="FF6D00">
-                <a:alpha val="30000"/>
-              </a:srgbClr>
-            </a:glow>
-          </a:effectLst>
         </p:spPr>
       </p:sp>
       <p:sp>
@@ -1713,13 +1685,6 @@
               </a:srgbClr>
             </a:solidFill>
           </a:ln>
-          <a:effectLst>
-            <a:glow rad="200000">
-              <a:srgbClr val="00BCD4">
-                <a:alpha val="28000"/>
-              </a:srgbClr>
-            </a:glow>
-          </a:effectLst>
         </p:spPr>
       </p:sp>
       <p:sp>
@@ -1744,13 +1709,6 @@
               </a:srgbClr>
             </a:solidFill>
           </a:ln>
-          <a:effectLst>
-            <a:glow rad="200000">
-              <a:srgbClr val="FF6D00">
-                <a:alpha val="28000"/>
-              </a:srgbClr>
-            </a:glow>
-          </a:effectLst>
         </p:spPr>
       </p:sp>
       <p:sp>
@@ -1871,13 +1829,6 @@
           <a:ln>
             <a:noFill/>
           </a:ln>
-          <a:effectLst>
-            <a:glow rad="152400">
-              <a:srgbClr val="FF6D00">
-                <a:alpha val="40000"/>
-              </a:srgbClr>
-            </a:glow>
-          </a:effectLst>
         </p:spPr>
       </p:sp>
       <p:sp>
@@ -1902,13 +1853,6 @@
           <a:ln>
             <a:noFill/>
           </a:ln>
-          <a:effectLst>
-            <a:glow rad="101600">
-              <a:srgbClr val="00BCD4">
-                <a:alpha val="40000"/>
-              </a:srgbClr>
-            </a:glow>
-          </a:effectLst>
         </p:spPr>
       </p:sp>
       <p:sp>
@@ -1933,13 +1877,6 @@
           <a:ln>
             <a:noFill/>
           </a:ln>
-          <a:effectLst>
-            <a:glow rad="101600">
-              <a:srgbClr val="FFFFFF">
-                <a:alpha val="40000"/>
-              </a:srgbClr>
-            </a:glow>
-          </a:effectLst>
         </p:spPr>
       </p:sp>
       <p:sp>
@@ -1964,13 +1901,6 @@
           <a:ln>
             <a:noFill/>
           </a:ln>
-          <a:effectLst>
-            <a:glow rad="152400">
-              <a:srgbClr val="FF6D00">
-                <a:alpha val="40000"/>
-              </a:srgbClr>
-            </a:glow>
-          </a:effectLst>
         </p:spPr>
       </p:sp>
       <p:sp>
@@ -3978,13 +3908,6 @@
               </a:srgbClr>
             </a:solidFill>
           </a:ln>
-          <a:effectLst>
-            <a:glow rad="200000">
-              <a:srgbClr val="FFD700">
-                <a:alpha val="30000"/>
-              </a:srgbClr>
-            </a:glow>
-          </a:effectLst>
         </p:spPr>
       </p:sp>
       <p:sp>
@@ -4009,13 +3932,6 @@
               </a:srgbClr>
             </a:solidFill>
           </a:ln>
-          <a:effectLst>
-            <a:glow rad="200000">
-              <a:srgbClr val="2196F3">
-                <a:alpha val="28000"/>
-              </a:srgbClr>
-            </a:glow>
-          </a:effectLst>
         </p:spPr>
       </p:sp>
       <p:sp>
@@ -4040,13 +3956,6 @@
               </a:srgbClr>
             </a:solidFill>
           </a:ln>
-          <a:effectLst>
-            <a:glow rad="200000">
-              <a:srgbClr val="FF6D00">
-                <a:alpha val="26000"/>
-              </a:srgbClr>
-            </a:glow>
-          </a:effectLst>
         </p:spPr>
       </p:sp>
       <p:sp>
@@ -4071,13 +3980,6 @@
           <a:ln>
             <a:noFill/>
           </a:ln>
-          <a:effectLst>
-            <a:glow rad="152400">
-              <a:srgbClr val="FFD700">
-                <a:alpha val="45000"/>
-              </a:srgbClr>
-            </a:glow>
-          </a:effectLst>
         </p:spPr>
       </p:sp>
       <p:sp>
@@ -4102,13 +4004,6 @@
           <a:ln>
             <a:noFill/>
           </a:ln>
-          <a:effectLst>
-            <a:glow rad="101600">
-              <a:srgbClr val="FFD700">
-                <a:alpha val="40000"/>
-              </a:srgbClr>
-            </a:glow>
-          </a:effectLst>
         </p:spPr>
       </p:sp>
       <p:sp>
@@ -4133,13 +4028,6 @@
           <a:ln>
             <a:noFill/>
           </a:ln>
-          <a:effectLst>
-            <a:glow rad="101600">
-              <a:srgbClr val="9C27B0">
-                <a:alpha val="35000"/>
-              </a:srgbClr>
-            </a:glow>
-          </a:effectLst>
         </p:spPr>
       </p:sp>
       <p:sp>
@@ -6534,13 +6422,6 @@
               </a:srgbClr>
             </a:solidFill>
           </a:ln>
-          <a:effectLst>
-            <a:glow rad="200000">
-              <a:srgbClr val="2196F3">
-                <a:alpha val="28000"/>
-              </a:srgbClr>
-            </a:glow>
-          </a:effectLst>
         </p:spPr>
       </p:sp>
       <p:sp>
@@ -6565,13 +6446,6 @@
               </a:srgbClr>
             </a:solidFill>
           </a:ln>
-          <a:effectLst>
-            <a:glow rad="200000">
-              <a:srgbClr val="FF6D00">
-                <a:alpha val="28000"/>
-              </a:srgbClr>
-            </a:glow>
-          </a:effectLst>
         </p:spPr>
       </p:sp>
       <p:sp>
@@ -6596,13 +6470,6 @@
               </a:srgbClr>
             </a:solidFill>
           </a:ln>
-          <a:effectLst>
-            <a:glow rad="200000">
-              <a:srgbClr val="00BCD4">
-                <a:alpha val="30000"/>
-              </a:srgbClr>
-            </a:glow>
-          </a:effectLst>
         </p:spPr>
       </p:sp>
       <p:sp>
@@ -7186,7 +7053,7 @@
     <a:masterClrMapping/>
   </p:clrMapOvr>
   <p:transition spd="med">
-    <p:strips dir="lu"/>
+    <p:wipe dir="l"/>
   </p:transition>
   <p:timing>
     <p:tnLst>
@@ -8281,13 +8148,6 @@
               </a:srgbClr>
             </a:solidFill>
           </a:ln>
-          <a:effectLst>
-            <a:glow rad="200000">
-              <a:srgbClr val="FF6D00">
-                <a:alpha val="32000"/>
-              </a:srgbClr>
-            </a:glow>
-          </a:effectLst>
         </p:spPr>
       </p:sp>
       <p:sp>
@@ -8312,13 +8172,6 @@
               </a:srgbClr>
             </a:solidFill>
           </a:ln>
-          <a:effectLst>
-            <a:glow rad="200000">
-              <a:srgbClr val="FF6D00">
-                <a:alpha val="32000"/>
-              </a:srgbClr>
-            </a:glow>
-          </a:effectLst>
         </p:spPr>
       </p:sp>
       <p:sp>
@@ -8343,13 +8196,6 @@
               </a:srgbClr>
             </a:solidFill>
           </a:ln>
-          <a:effectLst>
-            <a:glow rad="200000">
-              <a:srgbClr val="FF6D00">
-                <a:alpha val="25000"/>
-              </a:srgbClr>
-            </a:glow>
-          </a:effectLst>
         </p:spPr>
       </p:sp>
       <p:sp>
@@ -8422,13 +8268,6 @@
           <a:ln>
             <a:noFill/>
           </a:ln>
-          <a:effectLst>
-            <a:glow rad="101600">
-              <a:srgbClr val="FF6D00">
-                <a:alpha val="40000"/>
-              </a:srgbClr>
-            </a:glow>
-          </a:effectLst>
         </p:spPr>
       </p:sp>
       <p:sp>
@@ -8453,13 +8292,6 @@
           <a:ln>
             <a:noFill/>
           </a:ln>
-          <a:effectLst>
-            <a:glow rad="101600">
-              <a:srgbClr val="FF6D00">
-                <a:alpha val="40000"/>
-              </a:srgbClr>
-            </a:glow>
-          </a:effectLst>
         </p:spPr>
       </p:sp>
       <p:sp>
@@ -8484,13 +8316,6 @@
           <a:ln>
             <a:noFill/>
           </a:ln>
-          <a:effectLst>
-            <a:glow rad="76200">
-              <a:srgbClr val="FF6D00">
-                <a:alpha val="40000"/>
-              </a:srgbClr>
-            </a:glow>
-          </a:effectLst>
         </p:spPr>
       </p:sp>
       <p:sp>
@@ -10755,13 +10580,6 @@
               </a:srgbClr>
             </a:solidFill>
           </a:ln>
-          <a:effectLst>
-            <a:glow rad="200000">
-              <a:srgbClr val="00BCD4">
-                <a:alpha val="37000"/>
-              </a:srgbClr>
-            </a:glow>
-          </a:effectLst>
         </p:spPr>
       </p:sp>
       <p:sp>
@@ -10786,13 +10604,6 @@
               </a:srgbClr>
             </a:solidFill>
           </a:ln>
-          <a:effectLst>
-            <a:glow rad="200000">
-              <a:srgbClr val="FF6D00">
-                <a:alpha val="37000"/>
-              </a:srgbClr>
-            </a:glow>
-          </a:effectLst>
         </p:spPr>
       </p:sp>
       <p:sp>
@@ -10937,13 +10748,6 @@
               </a:srgbClr>
             </a:solidFill>
           </a:ln>
-          <a:effectLst>
-            <a:glow rad="200000">
-              <a:srgbClr val="00BCD4">
-                <a:alpha val="27000"/>
-              </a:srgbClr>
-            </a:glow>
-          </a:effectLst>
         </p:spPr>
       </p:sp>
       <p:sp>
@@ -10968,13 +10772,6 @@
               </a:srgbClr>
             </a:solidFill>
           </a:ln>
-          <a:effectLst>
-            <a:glow rad="200000">
-              <a:srgbClr val="FF6D00">
-                <a:alpha val="27000"/>
-              </a:srgbClr>
-            </a:glow>
-          </a:effectLst>
         </p:spPr>
       </p:sp>
       <p:sp>
@@ -10999,13 +10796,6 @@
               </a:srgbClr>
             </a:solidFill>
           </a:ln>
-          <a:effectLst>
-            <a:glow rad="200000">
-              <a:srgbClr val="FFFFFF">
-                <a:alpha val="23000"/>
-              </a:srgbClr>
-            </a:glow>
-          </a:effectLst>
         </p:spPr>
       </p:sp>
       <p:sp>
@@ -11174,13 +10964,6 @@
           <a:ln>
             <a:noFill/>
           </a:ln>
-          <a:effectLst>
-            <a:glow rad="101600">
-              <a:srgbClr val="00BCD4">
-                <a:alpha val="40000"/>
-              </a:srgbClr>
-            </a:glow>
-          </a:effectLst>
         </p:spPr>
       </p:sp>
       <p:sp>
@@ -11205,13 +10988,6 @@
           <a:ln>
             <a:noFill/>
           </a:ln>
-          <a:effectLst>
-            <a:glow rad="101600">
-              <a:srgbClr val="FF6D00">
-                <a:alpha val="40000"/>
-              </a:srgbClr>
-            </a:glow>
-          </a:effectLst>
         </p:spPr>
       </p:sp>
       <p:sp>
@@ -11236,13 +11012,6 @@
           <a:ln>
             <a:noFill/>
           </a:ln>
-          <a:effectLst>
-            <a:glow rad="76200">
-              <a:srgbClr val="FFFFFF">
-                <a:alpha val="35000"/>
-              </a:srgbClr>
-            </a:glow>
-          </a:effectLst>
         </p:spPr>
       </p:sp>
       <p:sp>
@@ -14427,13 +14196,6 @@
               </a:srgbClr>
             </a:solidFill>
           </a:ln>
-          <a:effectLst>
-            <a:glow rad="150000">
-              <a:srgbClr val="2196F3">
-                <a:alpha val="45000"/>
-              </a:srgbClr>
-            </a:glow>
-          </a:effectLst>
         </p:spPr>
       </p:sp>
       <p:sp>
@@ -14458,13 +14220,6 @@
               </a:srgbClr>
             </a:solidFill>
           </a:ln>
-          <a:effectLst>
-            <a:glow rad="150000">
-              <a:srgbClr val="00BCD4">
-                <a:alpha val="45000"/>
-              </a:srgbClr>
-            </a:glow>
-          </a:effectLst>
         </p:spPr>
       </p:sp>
       <p:sp>
@@ -14489,13 +14244,6 @@
               </a:srgbClr>
             </a:solidFill>
           </a:ln>
-          <a:effectLst>
-            <a:glow rad="150000">
-              <a:srgbClr val="FF6D00">
-                <a:alpha val="45000"/>
-              </a:srgbClr>
-            </a:glow>
-          </a:effectLst>
         </p:spPr>
       </p:sp>
       <p:sp>
@@ -14520,13 +14268,6 @@
               </a:srgbClr>
             </a:solidFill>
           </a:ln>
-          <a:effectLst>
-            <a:glow rad="150000">
-              <a:srgbClr val="FF1744">
-                <a:alpha val="45000"/>
-              </a:srgbClr>
-            </a:glow>
-          </a:effectLst>
         </p:spPr>
       </p:sp>
       <p:sp>
@@ -14551,13 +14292,6 @@
               </a:srgbClr>
             </a:solidFill>
           </a:ln>
-          <a:effectLst>
-            <a:glow rad="150000">
-              <a:srgbClr val="00E676">
-                <a:alpha val="45000"/>
-              </a:srgbClr>
-            </a:glow>
-          </a:effectLst>
         </p:spPr>
       </p:sp>
       <p:sp>
@@ -14654,13 +14388,6 @@
               </a:srgbClr>
             </a:solidFill>
           </a:ln>
-          <a:effectLst>
-            <a:glow rad="200000">
-              <a:srgbClr val="2196F3">
-                <a:alpha val="30000"/>
-              </a:srgbClr>
-            </a:glow>
-          </a:effectLst>
         </p:spPr>
       </p:sp>
       <p:sp>
@@ -14685,13 +14412,6 @@
               </a:srgbClr>
             </a:solidFill>
           </a:ln>
-          <a:effectLst>
-            <a:glow rad="200000">
-              <a:srgbClr val="00E676">
-                <a:alpha val="30000"/>
-              </a:srgbClr>
-            </a:glow>
-          </a:effectLst>
         </p:spPr>
       </p:sp>
       <p:sp>
@@ -14716,13 +14436,6 @@
               </a:srgbClr>
             </a:solidFill>
           </a:ln>
-          <a:effectLst>
-            <a:glow rad="200000">
-              <a:srgbClr val="FF6D00">
-                <a:alpha val="27000"/>
-              </a:srgbClr>
-            </a:glow>
-          </a:effectLst>
         </p:spPr>
       </p:sp>
       <p:sp>
@@ -14747,13 +14460,6 @@
           <a:ln>
             <a:noFill/>
           </a:ln>
-          <a:effectLst>
-            <a:glow rad="101600">
-              <a:srgbClr val="00E676">
-                <a:alpha val="40000"/>
-              </a:srgbClr>
-            </a:glow>
-          </a:effectLst>
         </p:spPr>
       </p:sp>
       <p:sp>
@@ -14778,13 +14484,6 @@
           <a:ln>
             <a:noFill/>
           </a:ln>
-          <a:effectLst>
-            <a:glow rad="101600">
-              <a:srgbClr val="2196F3">
-                <a:alpha val="40000"/>
-              </a:srgbClr>
-            </a:glow>
-          </a:effectLst>
         </p:spPr>
       </p:sp>
       <p:sp>
@@ -14809,13 +14508,6 @@
           <a:ln>
             <a:noFill/>
           </a:ln>
-          <a:effectLst>
-            <a:glow rad="101600">
-              <a:srgbClr val="FF6D00">
-                <a:alpha val="40000"/>
-              </a:srgbClr>
-            </a:glow>
-          </a:effectLst>
         </p:spPr>
       </p:sp>
       <p:sp>
@@ -15743,7 +15435,7 @@
     <a:masterClrMapping/>
   </p:clrMapOvr>
   <p:transition spd="fast">
-    <p:checker dir="horz"/>
+    <p:blinds dir="vert"/>
   </p:transition>
   <p:timing>
     <p:tnLst>
@@ -17846,13 +17538,6 @@
               </a:srgbClr>
             </a:solidFill>
           </a:ln>
-          <a:effectLst>
-            <a:glow rad="200000">
-              <a:srgbClr val="FF6D00">
-                <a:alpha val="32000"/>
-              </a:srgbClr>
-            </a:glow>
-          </a:effectLst>
         </p:spPr>
       </p:sp>
       <p:sp>
@@ -17877,13 +17562,6 @@
               </a:srgbClr>
             </a:solidFill>
           </a:ln>
-          <a:effectLst>
-            <a:glow rad="200000">
-              <a:srgbClr val="2196F3">
-                <a:alpha val="32000"/>
-              </a:srgbClr>
-            </a:glow>
-          </a:effectLst>
         </p:spPr>
       </p:sp>
       <p:sp>
@@ -17908,13 +17586,6 @@
               </a:srgbClr>
             </a:solidFill>
           </a:ln>
-          <a:effectLst>
-            <a:glow rad="200000">
-              <a:srgbClr val="FF6D00">
-                <a:alpha val="25000"/>
-              </a:srgbClr>
-            </a:glow>
-          </a:effectLst>
         </p:spPr>
       </p:sp>
       <p:sp>
@@ -17987,13 +17658,6 @@
           <a:ln>
             <a:noFill/>
           </a:ln>
-          <a:effectLst>
-            <a:glow rad="152400">
-              <a:srgbClr val="FF6D00">
-                <a:alpha val="45000"/>
-              </a:srgbClr>
-            </a:glow>
-          </a:effectLst>
         </p:spPr>
       </p:sp>
       <p:sp>
@@ -18018,13 +17682,6 @@
           <a:ln>
             <a:noFill/>
           </a:ln>
-          <a:effectLst>
-            <a:glow rad="101600">
-              <a:srgbClr val="00BCD4">
-                <a:alpha val="45000"/>
-              </a:srgbClr>
-            </a:glow>
-          </a:effectLst>
         </p:spPr>
       </p:sp>
       <p:sp>
@@ -18049,13 +17706,6 @@
           <a:ln>
             <a:noFill/>
           </a:ln>
-          <a:effectLst>
-            <a:glow rad="152400">
-              <a:srgbClr val="FF6D00">
-                <a:alpha val="45000"/>
-              </a:srgbClr>
-            </a:glow>
-          </a:effectLst>
         </p:spPr>
       </p:sp>
       <p:sp>
@@ -19791,13 +19441,6 @@
               </a:srgbClr>
             </a:solidFill>
           </a:ln>
-          <a:effectLst>
-            <a:glow rad="100000">
-              <a:srgbClr val="FF6D00">
-                <a:alpha val="36000"/>
-              </a:srgbClr>
-            </a:glow>
-          </a:effectLst>
         </p:spPr>
       </p:sp>
       <p:sp>
@@ -19822,13 +19465,6 @@
               </a:srgbClr>
             </a:solidFill>
           </a:ln>
-          <a:effectLst>
-            <a:glow rad="100000">
-              <a:srgbClr val="FF6D00">
-                <a:alpha val="39000"/>
-              </a:srgbClr>
-            </a:glow>
-          </a:effectLst>
         </p:spPr>
       </p:sp>
       <p:sp>
@@ -19853,13 +19489,6 @@
               </a:srgbClr>
             </a:solidFill>
           </a:ln>
-          <a:effectLst>
-            <a:glow rad="100000">
-              <a:srgbClr val="FF6D00">
-                <a:alpha val="42000"/>
-              </a:srgbClr>
-            </a:glow>
-          </a:effectLst>
         </p:spPr>
       </p:sp>
       <p:sp>
@@ -19884,13 +19513,6 @@
               </a:srgbClr>
             </a:solidFill>
           </a:ln>
-          <a:effectLst>
-            <a:glow rad="100000">
-              <a:srgbClr val="FF6D00">
-                <a:alpha val="45000"/>
-              </a:srgbClr>
-            </a:glow>
-          </a:effectLst>
         </p:spPr>
       </p:sp>
       <p:sp>
@@ -20131,13 +19753,6 @@
               </a:srgbClr>
             </a:solidFill>
           </a:ln>
-          <a:effectLst>
-            <a:glow rad="200000">
-              <a:srgbClr val="00BCD4">
-                <a:alpha val="30000"/>
-              </a:srgbClr>
-            </a:glow>
-          </a:effectLst>
         </p:spPr>
       </p:sp>
       <p:sp>
@@ -20162,13 +19777,6 @@
               </a:srgbClr>
             </a:solidFill>
           </a:ln>
-          <a:effectLst>
-            <a:glow rad="200000">
-              <a:srgbClr val="FF6D00">
-                <a:alpha val="30000"/>
-              </a:srgbClr>
-            </a:glow>
-          </a:effectLst>
         </p:spPr>
       </p:sp>
       <p:sp>
@@ -20289,13 +19897,6 @@
           <a:ln>
             <a:noFill/>
           </a:ln>
-          <a:effectLst>
-            <a:glow rad="101600">
-              <a:srgbClr val="FF6D00">
-                <a:alpha val="40000"/>
-              </a:srgbClr>
-            </a:glow>
-          </a:effectLst>
         </p:spPr>
       </p:sp>
       <p:sp>
@@ -20320,13 +19921,6 @@
           <a:ln>
             <a:noFill/>
           </a:ln>
-          <a:effectLst>
-            <a:glow rad="101600">
-              <a:srgbClr val="00BCD4">
-                <a:alpha val="40000"/>
-              </a:srgbClr>
-            </a:glow>
-          </a:effectLst>
         </p:spPr>
       </p:sp>
       <p:sp>
@@ -21518,7 +21112,7 @@
     <a:masterClrMapping/>
   </p:clrMapOvr>
   <p:transition spd="med">
-    <p:diamond/>
+    <p:circle/>
   </p:transition>
   <p:timing>
     <p:tnLst>
@@ -24557,13 +24151,6 @@
           <a:ln>
             <a:noFill/>
           </a:ln>
-          <a:effectLst>
-            <a:glow rad="152400">
-              <a:srgbClr val="FFD700">
-                <a:alpha val="55000"/>
-              </a:srgbClr>
-            </a:glow>
-          </a:effectLst>
         </p:spPr>
       </p:sp>
       <p:sp>
@@ -24588,13 +24175,6 @@
           <a:ln>
             <a:noFill/>
           </a:ln>
-          <a:effectLst>
-            <a:glow rad="152400">
-              <a:srgbClr val="FFD700">
-                <a:alpha val="55000"/>
-              </a:srgbClr>
-            </a:glow>
-          </a:effectLst>
         </p:spPr>
       </p:sp>
       <p:sp>
@@ -24619,13 +24199,6 @@
           <a:ln>
             <a:noFill/>
           </a:ln>
-          <a:effectLst>
-            <a:glow rad="152400">
-              <a:srgbClr val="FF6D00">
-                <a:alpha val="55000"/>
-              </a:srgbClr>
-            </a:glow>
-          </a:effectLst>
         </p:spPr>
       </p:sp>
       <p:sp>
@@ -24650,13 +24223,6 @@
           <a:ln>
             <a:noFill/>
           </a:ln>
-          <a:effectLst>
-            <a:glow rad="152400">
-              <a:srgbClr val="FF6D00">
-                <a:alpha val="55000"/>
-              </a:srgbClr>
-            </a:glow>
-          </a:effectLst>
         </p:spPr>
       </p:sp>
       <p:sp>
@@ -24681,13 +24247,6 @@
           <a:ln>
             <a:noFill/>
           </a:ln>
-          <a:effectLst>
-            <a:glow rad="304800">
-              <a:srgbClr val="FFD700">
-                <a:alpha val="55000"/>
-              </a:srgbClr>
-            </a:glow>
-          </a:effectLst>
         </p:spPr>
       </p:sp>
       <p:sp>
@@ -24712,13 +24271,6 @@
           <a:ln>
             <a:noFill/>
           </a:ln>
-          <a:effectLst>
-            <a:glow rad="152400">
-              <a:srgbClr val="00BCD4">
-                <a:alpha val="55000"/>
-              </a:srgbClr>
-            </a:glow>
-          </a:effectLst>
         </p:spPr>
       </p:sp>
       <p:sp>
@@ -24743,13 +24295,6 @@
           <a:ln>
             <a:noFill/>
           </a:ln>
-          <a:effectLst>
-            <a:glow rad="152400">
-              <a:srgbClr val="00E676">
-                <a:alpha val="55000"/>
-              </a:srgbClr>
-            </a:glow>
-          </a:effectLst>
         </p:spPr>
       </p:sp>
       <p:sp>
@@ -24774,13 +24319,6 @@
           <a:ln>
             <a:noFill/>
           </a:ln>
-          <a:effectLst>
-            <a:glow rad="101600">
-              <a:srgbClr val="FF1744">
-                <a:alpha val="55000"/>
-              </a:srgbClr>
-            </a:glow>
-          </a:effectLst>
         </p:spPr>
       </p:sp>
       <p:sp>
@@ -24805,13 +24343,6 @@
           <a:ln>
             <a:noFill/>
           </a:ln>
-          <a:effectLst>
-            <a:glow rad="101600">
-              <a:srgbClr val="9C27B0">
-                <a:alpha val="55000"/>
-              </a:srgbClr>
-            </a:glow>
-          </a:effectLst>
         </p:spPr>
       </p:sp>
       <p:sp>
@@ -24932,13 +24463,6 @@
               </a:srgbClr>
             </a:solidFill>
           </a:ln>
-          <a:effectLst>
-            <a:glow rad="300000">
-              <a:srgbClr val="FFD700">
-                <a:alpha val="32000"/>
-              </a:srgbClr>
-            </a:glow>
-          </a:effectLst>
         </p:spPr>
       </p:sp>
       <p:sp>
@@ -24963,13 +24487,6 @@
               </a:srgbClr>
             </a:solidFill>
           </a:ln>
-          <a:effectLst>
-            <a:glow rad="200000">
-              <a:srgbClr val="FF6D00">
-                <a:alpha val="30000"/>
-              </a:srgbClr>
-            </a:glow>
-          </a:effectLst>
         </p:spPr>
       </p:sp>
       <p:sp>
@@ -24994,13 +24511,6 @@
               </a:srgbClr>
             </a:solidFill>
           </a:ln>
-          <a:effectLst>
-            <a:glow rad="200000">
-              <a:srgbClr val="00BCD4">
-                <a:alpha val="30000"/>
-              </a:srgbClr>
-            </a:glow>
-          </a:effectLst>
         </p:spPr>
       </p:sp>
       <p:sp>

</xml_diff>

<commit_message>
Fix negative shape coordinates crashing iOS PowerPoint
Clamp x,y offsets to >= 0 in all decoration helpers (orb, ring, dmd, dot).
Previously, corner/edge shapes computed negative positions (e.g. orb at x=0
with sz=3000000 → x=-1500000) which causes iOS PowerPoint to reject the file.

Co-Authored-By: Claude Sonnet 4.6 <noreply@anthropic.com>
Claude-Session: https://claude.ai/code/session_01QS7srrPkzgdxeHFxN7zTWR
</commit_message>
<xml_diff>
--- a/rl_bachelor_extra.pptx
+++ b/rl_bachelor_extra.pptx
@@ -1479,7 +1479,7 @@
         </p:nvSpPr>
         <p:spPr>
           <a:xfrm>
-            <a:off x="1072000" y="-928250"/>
+            <a:off x="1072000" y="0"/>
             <a:ext cx="7000000" cy="7000000"/>
           </a:xfrm>
           <a:prstGeom prst="ellipse">
@@ -1551,7 +1551,7 @@
         </p:nvSpPr>
         <p:spPr>
           <a:xfrm>
-            <a:off x="-1500000" y="-1500000"/>
+            <a:off x="0" y="0"/>
             <a:ext cx="3000000" cy="3000000"/>
           </a:xfrm>
           <a:prstGeom prst="ellipse">
@@ -1575,7 +1575,7 @@
         </p:nvSpPr>
         <p:spPr>
           <a:xfrm>
-            <a:off x="7644000" y="-1500000"/>
+            <a:off x="7644000" y="0"/>
             <a:ext cx="3000000" cy="3000000"/>
           </a:xfrm>
           <a:prstGeom prst="ellipse">
@@ -1599,7 +1599,7 @@
         </p:nvSpPr>
         <p:spPr>
           <a:xfrm>
-            <a:off x="-1500000" y="3643500"/>
+            <a:off x="0" y="3643500"/>
             <a:ext cx="3000000" cy="3000000"/>
           </a:xfrm>
           <a:prstGeom prst="ellipse">
@@ -1695,7 +1695,7 @@
         </p:nvSpPr>
         <p:spPr>
           <a:xfrm>
-            <a:off x="3922000" y="-200000"/>
+            <a:off x="3922000" y="0"/>
             <a:ext cx="500000" cy="500000"/>
           </a:xfrm>
           <a:prstGeom prst="diamond">
@@ -3008,7 +3008,7 @@
         </p:nvSpPr>
         <p:spPr>
           <a:xfrm>
-            <a:off x="7394000" y="-1250000"/>
+            <a:off x="7394000" y="0"/>
             <a:ext cx="2500000" cy="2500000"/>
           </a:xfrm>
           <a:prstGeom prst="ellipse">
@@ -5036,7 +5036,7 @@
         </p:nvSpPr>
         <p:spPr>
           <a:xfrm>
-            <a:off x="1572000" y="-428250"/>
+            <a:off x="1572000" y="0"/>
             <a:ext cx="6000000" cy="6000000"/>
           </a:xfrm>
           <a:prstGeom prst="ellipse">
@@ -6244,7 +6244,7 @@
         </p:nvSpPr>
         <p:spPr>
           <a:xfrm>
-            <a:off x="1072000" y="-928250"/>
+            <a:off x="1072000" y="0"/>
             <a:ext cx="7000000" cy="7000000"/>
           </a:xfrm>
           <a:prstGeom prst="ellipse">
@@ -8046,7 +8046,7 @@
         </p:nvSpPr>
         <p:spPr>
           <a:xfrm>
-            <a:off x="-214000" y="71750"/>
+            <a:off x="0" y="71750"/>
             <a:ext cx="5000000" cy="5000000"/>
           </a:xfrm>
           <a:prstGeom prst="ellipse">
@@ -8094,7 +8094,7 @@
         </p:nvSpPr>
         <p:spPr>
           <a:xfrm>
-            <a:off x="-2000000" y="571750"/>
+            <a:off x="0" y="571750"/>
             <a:ext cx="4000000" cy="4000000"/>
           </a:xfrm>
           <a:prstGeom prst="ellipse">
@@ -10768,7 +10768,7 @@
         </p:nvSpPr>
         <p:spPr>
           <a:xfrm>
-            <a:off x="-200000" y="1671750"/>
+            <a:off x="0" y="1671750"/>
             <a:ext cx="1800000" cy="1800000"/>
           </a:xfrm>
           <a:prstGeom prst="ellipse">
@@ -10792,7 +10792,7 @@
         </p:nvSpPr>
         <p:spPr>
           <a:xfrm>
-            <a:off x="-550000" y="1321750"/>
+            <a:off x="0" y="1321750"/>
             <a:ext cx="2500000" cy="2500000"/>
           </a:xfrm>
           <a:prstGeom prst="ellipse">
@@ -11056,7 +11056,7 @@
         </p:nvSpPr>
         <p:spPr>
           <a:xfrm>
-            <a:off x="-1500000" y="-1500000"/>
+            <a:off x="0" y="0"/>
             <a:ext cx="3000000" cy="3000000"/>
           </a:xfrm>
           <a:prstGeom prst="ellipse">
@@ -13192,7 +13192,7 @@
         </p:nvSpPr>
         <p:spPr>
           <a:xfrm>
-            <a:off x="-2000000" y="571750"/>
+            <a:off x="0" y="571750"/>
             <a:ext cx="4000000" cy="4000000"/>
           </a:xfrm>
           <a:prstGeom prst="ellipse">
@@ -13240,7 +13240,7 @@
         </p:nvSpPr>
         <p:spPr>
           <a:xfrm>
-            <a:off x="1572000" y="-428250"/>
+            <a:off x="1572000" y="0"/>
             <a:ext cx="6000000" cy="6000000"/>
           </a:xfrm>
           <a:prstGeom prst="ellipse">
@@ -14345,7 +14345,7 @@
         </p:nvSpPr>
         <p:spPr>
           <a:xfrm>
-            <a:off x="2486400" y="-428250"/>
+            <a:off x="2486400" y="0"/>
             <a:ext cx="6000000" cy="6000000"/>
           </a:xfrm>
           <a:prstGeom prst="ellipse">
@@ -14681,7 +14681,7 @@
         </p:nvSpPr>
         <p:spPr>
           <a:xfrm>
-            <a:off x="-1500000" y="-1500000"/>
+            <a:off x="0" y="0"/>
             <a:ext cx="3000000" cy="3000000"/>
           </a:xfrm>
           <a:prstGeom prst="ellipse">
@@ -17657,7 +17657,7 @@
         </p:nvSpPr>
         <p:spPr>
           <a:xfrm>
-            <a:off x="1072000" y="-1428250"/>
+            <a:off x="1072000" y="0"/>
             <a:ext cx="7000000" cy="7000000"/>
           </a:xfrm>
           <a:prstGeom prst="ellipse">
@@ -17681,7 +17681,7 @@
         </p:nvSpPr>
         <p:spPr>
           <a:xfrm>
-            <a:off x="2072000" y="-428250"/>
+            <a:off x="2072000" y="0"/>
             <a:ext cx="5000000" cy="5000000"/>
           </a:xfrm>
           <a:prstGeom prst="ellipse">
@@ -17825,7 +17825,7 @@
         </p:nvSpPr>
         <p:spPr>
           <a:xfrm>
-            <a:off x="4222000" y="-200000"/>
+            <a:off x="4222000" y="0"/>
             <a:ext cx="700000" cy="700000"/>
           </a:xfrm>
           <a:prstGeom prst="diamond">

</xml_diff>

<commit_message>
Fix duplicate shape IDs on slide 5 crashing iOS PowerPoint
The dot loop used dot(n+i,...) while also doing n+=1 each iteration,
causing IDs 512 and 514 to be assigned to two shapes each. iOS
PowerPoint validates shape ID uniqueness strictly and rejects the file.
Fixed by using dot(n,...) so each shape gets the next sequential ID.

Co-Authored-By: Claude Sonnet 4.6 <noreply@anthropic.com>
Claude-Session: https://claude.ai/code/session_01QS7srrPkzgdxeHFxN7zTWR
</commit_message>
<xml_diff>
--- a/rl_bachelor_extra.pptx
+++ b/rl_bachelor_extra.pptx
@@ -8160,7 +8160,7 @@
       </p:sp>
       <p:sp>
         <p:nvSpPr>
-          <p:cNvPr id="508" name="d508"/>
+          <p:cNvPr id="507" name="d507"/>
           <p:cNvSpPr/>
           <p:nvPr/>
         </p:nvSpPr>
@@ -8184,7 +8184,7 @@
       </p:sp>
       <p:sp>
         <p:nvSpPr>
-          <p:cNvPr id="510" name="d510"/>
+          <p:cNvPr id="508" name="d508"/>
           <p:cNvSpPr/>
           <p:nvPr/>
         </p:nvSpPr>
@@ -8208,7 +8208,7 @@
       </p:sp>
       <p:sp>
         <p:nvSpPr>
-          <p:cNvPr id="512" name="d512"/>
+          <p:cNvPr id="509" name="d509"/>
           <p:cNvSpPr/>
           <p:nvPr/>
         </p:nvSpPr>
@@ -8232,7 +8232,7 @@
       </p:sp>
       <p:sp>
         <p:nvSpPr>
-          <p:cNvPr id="514" name="d514"/>
+          <p:cNvPr id="510" name="d510"/>
           <p:cNvSpPr/>
           <p:nvPr/>
         </p:nvSpPr>
@@ -9509,6 +9509,37 @@
                           <p:cBhvr>
                             <p:cTn id="25" dur="1" fill="hold"/>
                             <p:tgtEl>
+                              <p:spTgt spid="507"/>
+                            </p:tgtEl>
+                            <p:attrNameLst>
+                              <p:attrName>style.visibility</p:attrName>
+                            </p:attrNameLst>
+                          </p:cBhvr>
+                          <p:to>
+                            <p:strVal val="visible"/>
+                          </p:to>
+                        </p:set>
+                        <p:animEffect transition="in" filter="fade">
+                          <p:cBhvr>
+                            <p:cTn id="26" dur="350"/>
+                            <p:tgtEl>
+                              <p:spTgt spid="507"/>
+                            </p:tgtEl>
+                          </p:cBhvr>
+                        </p:animEffect>
+                      </p:childTnLst>
+                    </p:cTn>
+                  </p:par>
+                  <p:par>
+                    <p:cTn id="27" presetID="10" presetClass="entr" presetSubtype="0" fill="hold" grpId="8" nodeType="withEffect">
+                      <p:stCondLst>
+                        <p:cond delay="560"/>
+                      </p:stCondLst>
+                      <p:childTnLst>
+                        <p:set>
+                          <p:cBhvr>
+                            <p:cTn id="28" dur="1" fill="hold"/>
+                            <p:tgtEl>
                               <p:spTgt spid="508"/>
                             </p:tgtEl>
                             <p:attrNameLst>
@@ -9521,7 +9552,7 @@
                         </p:set>
                         <p:animEffect transition="in" filter="fade">
                           <p:cBhvr>
-                            <p:cTn id="26" dur="350"/>
+                            <p:cTn id="29" dur="350"/>
                             <p:tgtEl>
                               <p:spTgt spid="508"/>
                             </p:tgtEl>
@@ -9531,14 +9562,45 @@
                     </p:cTn>
                   </p:par>
                   <p:par>
-                    <p:cTn id="27" presetID="10" presetClass="entr" presetSubtype="0" fill="hold" grpId="8" nodeType="withEffect">
-                      <p:stCondLst>
-                        <p:cond delay="560"/>
-                      </p:stCondLst>
-                      <p:childTnLst>
-                        <p:set>
-                          <p:cBhvr>
-                            <p:cTn id="28" dur="1" fill="hold"/>
+                    <p:cTn id="30" presetID="10" presetClass="entr" presetSubtype="0" fill="hold" grpId="9" nodeType="withEffect">
+                      <p:stCondLst>
+                        <p:cond delay="630"/>
+                      </p:stCondLst>
+                      <p:childTnLst>
+                        <p:set>
+                          <p:cBhvr>
+                            <p:cTn id="31" dur="1" fill="hold"/>
+                            <p:tgtEl>
+                              <p:spTgt spid="509"/>
+                            </p:tgtEl>
+                            <p:attrNameLst>
+                              <p:attrName>style.visibility</p:attrName>
+                            </p:attrNameLst>
+                          </p:cBhvr>
+                          <p:to>
+                            <p:strVal val="visible"/>
+                          </p:to>
+                        </p:set>
+                        <p:animEffect transition="in" filter="fade">
+                          <p:cBhvr>
+                            <p:cTn id="32" dur="350"/>
+                            <p:tgtEl>
+                              <p:spTgt spid="509"/>
+                            </p:tgtEl>
+                          </p:cBhvr>
+                        </p:animEffect>
+                      </p:childTnLst>
+                    </p:cTn>
+                  </p:par>
+                  <p:par>
+                    <p:cTn id="33" presetID="10" presetClass="entr" presetSubtype="0" fill="hold" grpId="10" nodeType="withEffect">
+                      <p:stCondLst>
+                        <p:cond delay="700"/>
+                      </p:stCondLst>
+                      <p:childTnLst>
+                        <p:set>
+                          <p:cBhvr>
+                            <p:cTn id="34" dur="1" fill="hold"/>
                             <p:tgtEl>
                               <p:spTgt spid="510"/>
                             </p:tgtEl>
@@ -9552,71 +9614,9 @@
                         </p:set>
                         <p:animEffect transition="in" filter="fade">
                           <p:cBhvr>
-                            <p:cTn id="29" dur="350"/>
+                            <p:cTn id="35" dur="350"/>
                             <p:tgtEl>
                               <p:spTgt spid="510"/>
-                            </p:tgtEl>
-                          </p:cBhvr>
-                        </p:animEffect>
-                      </p:childTnLst>
-                    </p:cTn>
-                  </p:par>
-                  <p:par>
-                    <p:cTn id="30" presetID="10" presetClass="entr" presetSubtype="0" fill="hold" grpId="9" nodeType="withEffect">
-                      <p:stCondLst>
-                        <p:cond delay="630"/>
-                      </p:stCondLst>
-                      <p:childTnLst>
-                        <p:set>
-                          <p:cBhvr>
-                            <p:cTn id="31" dur="1" fill="hold"/>
-                            <p:tgtEl>
-                              <p:spTgt spid="512"/>
-                            </p:tgtEl>
-                            <p:attrNameLst>
-                              <p:attrName>style.visibility</p:attrName>
-                            </p:attrNameLst>
-                          </p:cBhvr>
-                          <p:to>
-                            <p:strVal val="visible"/>
-                          </p:to>
-                        </p:set>
-                        <p:animEffect transition="in" filter="fade">
-                          <p:cBhvr>
-                            <p:cTn id="32" dur="350"/>
-                            <p:tgtEl>
-                              <p:spTgt spid="512"/>
-                            </p:tgtEl>
-                          </p:cBhvr>
-                        </p:animEffect>
-                      </p:childTnLst>
-                    </p:cTn>
-                  </p:par>
-                  <p:par>
-                    <p:cTn id="33" presetID="10" presetClass="entr" presetSubtype="0" fill="hold" grpId="10" nodeType="withEffect">
-                      <p:stCondLst>
-                        <p:cond delay="700"/>
-                      </p:stCondLst>
-                      <p:childTnLst>
-                        <p:set>
-                          <p:cBhvr>
-                            <p:cTn id="34" dur="1" fill="hold"/>
-                            <p:tgtEl>
-                              <p:spTgt spid="514"/>
-                            </p:tgtEl>
-                            <p:attrNameLst>
-                              <p:attrName>style.visibility</p:attrName>
-                            </p:attrNameLst>
-                          </p:cBhvr>
-                          <p:to>
-                            <p:strVal val="visible"/>
-                          </p:to>
-                        </p:set>
-                        <p:animEffect transition="in" filter="fade">
-                          <p:cBhvr>
-                            <p:cTn id="35" dur="350"/>
-                            <p:tgtEl>
-                              <p:spTgt spid="514"/>
                             </p:tgtEl>
                           </p:cBhvr>
                         </p:animEffect>
@@ -10692,10 +10692,10 @@
       <p:bldP spid="504" grpId="4" uiExpand="1" build="p"/>
       <p:bldP spid="505" grpId="5" uiExpand="1" build="p"/>
       <p:bldP spid="506" grpId="6" uiExpand="1" build="p"/>
-      <p:bldP spid="508" grpId="7" uiExpand="1" build="p"/>
-      <p:bldP spid="510" grpId="8" uiExpand="1" build="p"/>
-      <p:bldP spid="512" grpId="9" uiExpand="1" build="p"/>
-      <p:bldP spid="514" grpId="10" uiExpand="1" build="p"/>
+      <p:bldP spid="507" grpId="7" uiExpand="1" build="p"/>
+      <p:bldP spid="508" grpId="8" uiExpand="1" build="p"/>
+      <p:bldP spid="509" grpId="9" uiExpand="1" build="p"/>
+      <p:bldP spid="510" grpId="10" uiExpand="1" build="p"/>
       <p:bldP spid="511" grpId="11" uiExpand="1" build="p"/>
       <p:bldP spid="512" grpId="12" uiExpand="1" build="p"/>
       <p:bldP spid="513" grpId="13" uiExpand="1" build="p"/>

</xml_diff>

<commit_message>
Fix invisible text, color-code ranks and scouting report bars
- Slide 2: Fix Bronze/BRYTON text (was invisible #0D1117 on dark bg)
  Color-code all rank tiers: gold=SSL/GC, sky-blue=Champion,
  cyan=Diamond, lavender=Platinum, amber=Gold, silver=Silver,
  red-orange=Bronze (BRYTON highlighted)
- Slide 5: Fix invisible "WHAT HE MEANS" column header (same bug),
  color "WHAT HE TYPES" cyan vs "WHAT HE MEANS" orange
- Slide 8: Scouting report bars now red for bad stats (Accuracy 8%,
  Ball Chasing 99%, Rotation 5%, Toxicity 92%, Blaming 97%,
  Actual Skill 3%) and gold for Heart & Passion 100%

Co-Authored-By: Claude Sonnet 4.6 <noreply@anthropic.com>
Claude-Session: https://claude.ai/code/session_01QS7srrPkzgdxeHFxN7zTWR
</commit_message>
<xml_diff>
--- a/rl_bachelor_extra.pptx
+++ b/rl_bachelor_extra.pptx
@@ -3643,7 +3643,7 @@
             <a:r>
               <a:rPr lang="en-US" sz="1200">
                 <a:solidFill>
-                  <a:srgbClr val="FFFFFF"/>
+                  <a:srgbClr val="FFD700"/>
                 </a:solidFill>
                 <a:latin typeface="Arial" pitchFamily="34" charset="0"/>
                 <a:ea typeface="Arial" pitchFamily="34" charset="-122"/>
@@ -3706,7 +3706,7 @@
             <a:r>
               <a:rPr lang="en-US" sz="1200">
                 <a:solidFill>
-                  <a:srgbClr val="FFFFFF"/>
+                  <a:srgbClr val="4FC3F7"/>
                 </a:solidFill>
                 <a:latin typeface="Arial" pitchFamily="34" charset="0"/>
                 <a:ea typeface="Arial" pitchFamily="34" charset="-122"/>
@@ -3769,7 +3769,7 @@
             <a:r>
               <a:rPr lang="en-US" sz="1200">
                 <a:solidFill>
-                  <a:srgbClr val="FFFFFF"/>
+                  <a:srgbClr val="00E5FF"/>
                 </a:solidFill>
                 <a:latin typeface="Arial" pitchFamily="34" charset="0"/>
                 <a:ea typeface="Arial" pitchFamily="34" charset="-122"/>
@@ -3832,7 +3832,7 @@
             <a:r>
               <a:rPr lang="en-US" sz="1200">
                 <a:solidFill>
-                  <a:srgbClr val="FFFFFF"/>
+                  <a:srgbClr val="CE93D8"/>
                 </a:solidFill>
                 <a:latin typeface="Arial" pitchFamily="34" charset="0"/>
                 <a:ea typeface="Arial" pitchFamily="34" charset="-122"/>
@@ -3895,7 +3895,7 @@
             <a:r>
               <a:rPr lang="en-US" sz="1200">
                 <a:solidFill>
-                  <a:srgbClr val="FFFFFF"/>
+                  <a:srgbClr val="FFC107"/>
                 </a:solidFill>
                 <a:latin typeface="Arial" pitchFamily="34" charset="0"/>
                 <a:ea typeface="Arial" pitchFamily="34" charset="-122"/>
@@ -3958,7 +3958,7 @@
             <a:r>
               <a:rPr lang="en-US" sz="1200">
                 <a:solidFill>
-                  <a:srgbClr val="FFFFFF"/>
+                  <a:srgbClr val="90A4AE"/>
                 </a:solidFill>
                 <a:latin typeface="Arial" pitchFamily="34" charset="0"/>
                 <a:ea typeface="Arial" pitchFamily="34" charset="-122"/>
@@ -4016,7 +4016,7 @@
             <a:r>
               <a:rPr lang="en-US" sz="1400" b="1">
                 <a:solidFill>
-                  <a:srgbClr val="0D1117"/>
+                  <a:srgbClr val="FF3D00"/>
                 </a:solidFill>
                 <a:latin typeface="Arial"/>
                 <a:ea typeface="Arial" pitchFamily="34" charset="-122"/>
@@ -9173,7 +9173,7 @@
             <a:r>
               <a:rPr lang="en-US" sz="1300" b="1">
                 <a:solidFill>
-                  <a:srgbClr val="FFFFFF"/>
+                  <a:srgbClr val="00BCD4"/>
                 </a:solidFill>
                 <a:latin typeface="Arial" pitchFamily="34" charset="0"/>
                 <a:ea typeface="Arial" pitchFamily="34" charset="-122"/>
@@ -9234,7 +9234,7 @@
             <a:r>
               <a:rPr lang="en-US" sz="1300" b="1">
                 <a:solidFill>
-                  <a:srgbClr val="0D1117"/>
+                  <a:srgbClr val="FF6D00"/>
                 </a:solidFill>
                 <a:latin typeface="Arial" pitchFamily="34" charset="0"/>
                 <a:ea typeface="Arial" pitchFamily="34" charset="-122"/>
@@ -15800,7 +15800,7 @@
             </a:avLst>
           </a:prstGeom>
           <a:solidFill>
-            <a:srgbClr val="2196F3"/>
+            <a:srgbClr val="FF1744"/>
           </a:solidFill>
           <a:ln/>
         </p:spPr>
@@ -15922,7 +15922,7 @@
             </a:avLst>
           </a:prstGeom>
           <a:solidFill>
-            <a:srgbClr val="FF6D00"/>
+            <a:srgbClr val="FF1744"/>
           </a:solidFill>
           <a:ln/>
         </p:spPr>
@@ -16044,7 +16044,7 @@
             </a:avLst>
           </a:prstGeom>
           <a:solidFill>
-            <a:srgbClr val="2196F3"/>
+            <a:srgbClr val="FF1744"/>
           </a:solidFill>
           <a:ln/>
         </p:spPr>
@@ -16166,7 +16166,7 @@
             </a:avLst>
           </a:prstGeom>
           <a:solidFill>
-            <a:srgbClr val="FF6D00"/>
+            <a:srgbClr val="FF1744"/>
           </a:solidFill>
           <a:ln/>
         </p:spPr>
@@ -16288,7 +16288,7 @@
             </a:avLst>
           </a:prstGeom>
           <a:solidFill>
-            <a:srgbClr val="FF6D00"/>
+            <a:srgbClr val="FF1744"/>
           </a:solidFill>
           <a:ln/>
         </p:spPr>
@@ -16410,7 +16410,7 @@
             </a:avLst>
           </a:prstGeom>
           <a:solidFill>
-            <a:srgbClr val="2196F3"/>
+            <a:srgbClr val="FF1744"/>
           </a:solidFill>
           <a:ln/>
         </p:spPr>
@@ -16532,7 +16532,7 @@
             </a:avLst>
           </a:prstGeom>
           <a:solidFill>
-            <a:srgbClr val="00BCD4"/>
+            <a:srgbClr val="FFD700"/>
           </a:solidFill>
           <a:ln/>
         </p:spPr>

</xml_diff>

<commit_message>
Use exact confirmed-working decor structure across all slides
The per-slide custom decorations (extra rings/dots on slides 1 and 9,
varying line weights and shape counts) were never actually confirmed
to open on iOS — only the uniform decor_simple() from test_anims.py
was. Replaced the custom per-slide decor with that exact proven
18-shape structure (2 rings, 2 bars, 10 dots, 2 diamonds) on every
slide, only varying fill colors as the confirmed test did. Text color
patches from the previous commit are untouched and verified to only
modify existing valid shape attributes.

Co-Authored-By: Claude Sonnet 4.6 <noreply@anthropic.com>
Claude-Session: https://claude.ai/code/session_01QS7srrPkzgdxeHFxN7zTWR
</commit_message>
<xml_diff>
--- a/rl_bachelor_extra.pptx
+++ b/rl_bachelor_extra.pptx
@@ -1503,8 +1503,8 @@
         </p:nvSpPr>
         <p:spPr>
           <a:xfrm>
-            <a:off x="3372000" y="1371750"/>
-            <a:ext cx="2400000" cy="2400000"/>
+            <a:off x="3672000" y="1671750"/>
+            <a:ext cx="1800000" cy="1800000"/>
           </a:xfrm>
           <a:prstGeom prst="ellipse">
             <a:avLst/>
@@ -1527,30 +1527,6 @@
         </p:nvSpPr>
         <p:spPr>
           <a:xfrm>
-            <a:off x="2572000" y="571750"/>
-            <a:ext cx="4000000" cy="4000000"/>
-          </a:xfrm>
-          <a:prstGeom prst="ellipse">
-            <a:avLst/>
-          </a:prstGeom>
-          <a:noFill/>
-          <a:ln w="15000">
-            <a:solidFill>
-              <a:srgbClr val="00BCD4">
-                <a:alpha val="2000"/>
-              </a:srgbClr>
-            </a:solidFill>
-          </a:ln>
-        </p:spPr>
-      </p:sp>
-      <p:sp>
-        <p:nvSpPr>
-          <p:cNvPr id="503" name="d503"/>
-          <p:cNvSpPr/>
-          <p:nvPr/>
-        </p:nvSpPr>
-        <p:spPr>
-          <a:xfrm>
             <a:off x="0" y="0"/>
             <a:ext cx="9144000" cy="642937"/>
           </a:xfrm>
@@ -1569,7 +1545,7 @@
       </p:sp>
       <p:sp>
         <p:nvSpPr>
-          <p:cNvPr id="504" name="d504"/>
+          <p:cNvPr id="503" name="d503"/>
           <p:cNvSpPr/>
           <p:nvPr/>
         </p:nvSpPr>
@@ -1593,16 +1569,256 @@
       </p:sp>
       <p:sp>
         <p:nvSpPr>
+          <p:cNvPr id="504" name="d504"/>
+          <p:cNvSpPr/>
+          <p:nvPr/>
+        </p:nvSpPr>
+        <p:spPr>
+          <a:xfrm>
+            <a:off x="0" y="514350"/>
+            <a:ext cx="200000" cy="200000"/>
+          </a:xfrm>
+          <a:prstGeom prst="ellipse">
+            <a:avLst/>
+          </a:prstGeom>
+          <a:solidFill>
+            <a:srgbClr val="00BCD4">
+              <a:alpha val="8000"/>
+            </a:srgbClr>
+          </a:solidFill>
+          <a:ln>
+            <a:noFill/>
+          </a:ln>
+        </p:spPr>
+      </p:sp>
+      <p:sp>
+        <p:nvSpPr>
           <p:cNvPr id="505" name="d505"/>
           <p:cNvSpPr/>
           <p:nvPr/>
         </p:nvSpPr>
         <p:spPr>
           <a:xfrm>
-            <a:off x="0" y="411480"/>
-            <a:ext cx="180000" cy="180000"/>
+            <a:off x="1828800" y="514350"/>
+            <a:ext cx="200000" cy="200000"/>
           </a:xfrm>
           <a:prstGeom prst="ellipse">
+            <a:avLst/>
+          </a:prstGeom>
+          <a:solidFill>
+            <a:srgbClr val="00BCD4">
+              <a:alpha val="8000"/>
+            </a:srgbClr>
+          </a:solidFill>
+          <a:ln>
+            <a:noFill/>
+          </a:ln>
+        </p:spPr>
+      </p:sp>
+      <p:sp>
+        <p:nvSpPr>
+          <p:cNvPr id="506" name="d506"/>
+          <p:cNvSpPr/>
+          <p:nvPr/>
+        </p:nvSpPr>
+        <p:spPr>
+          <a:xfrm>
+            <a:off x="3657600" y="514350"/>
+            <a:ext cx="200000" cy="200000"/>
+          </a:xfrm>
+          <a:prstGeom prst="ellipse">
+            <a:avLst/>
+          </a:prstGeom>
+          <a:solidFill>
+            <a:srgbClr val="00BCD4">
+              <a:alpha val="8000"/>
+            </a:srgbClr>
+          </a:solidFill>
+          <a:ln>
+            <a:noFill/>
+          </a:ln>
+        </p:spPr>
+      </p:sp>
+      <p:sp>
+        <p:nvSpPr>
+          <p:cNvPr id="507" name="d507"/>
+          <p:cNvSpPr/>
+          <p:nvPr/>
+        </p:nvSpPr>
+        <p:spPr>
+          <a:xfrm>
+            <a:off x="5486400" y="514350"/>
+            <a:ext cx="200000" cy="200000"/>
+          </a:xfrm>
+          <a:prstGeom prst="ellipse">
+            <a:avLst/>
+          </a:prstGeom>
+          <a:solidFill>
+            <a:srgbClr val="00BCD4">
+              <a:alpha val="8000"/>
+            </a:srgbClr>
+          </a:solidFill>
+          <a:ln>
+            <a:noFill/>
+          </a:ln>
+        </p:spPr>
+      </p:sp>
+      <p:sp>
+        <p:nvSpPr>
+          <p:cNvPr id="508" name="d508"/>
+          <p:cNvSpPr/>
+          <p:nvPr/>
+        </p:nvSpPr>
+        <p:spPr>
+          <a:xfrm>
+            <a:off x="7315200" y="514350"/>
+            <a:ext cx="200000" cy="200000"/>
+          </a:xfrm>
+          <a:prstGeom prst="ellipse">
+            <a:avLst/>
+          </a:prstGeom>
+          <a:solidFill>
+            <a:srgbClr val="00BCD4">
+              <a:alpha val="8000"/>
+            </a:srgbClr>
+          </a:solidFill>
+          <a:ln>
+            <a:noFill/>
+          </a:ln>
+        </p:spPr>
+      </p:sp>
+      <p:sp>
+        <p:nvSpPr>
+          <p:cNvPr id="509" name="d509"/>
+          <p:cNvSpPr/>
+          <p:nvPr/>
+        </p:nvSpPr>
+        <p:spPr>
+          <a:xfrm>
+            <a:off x="914400" y="4371975"/>
+            <a:ext cx="150000" cy="150000"/>
+          </a:xfrm>
+          <a:prstGeom prst="ellipse">
+            <a:avLst/>
+          </a:prstGeom>
+          <a:solidFill>
+            <a:srgbClr val="FF6D00">
+              <a:alpha val="8000"/>
+            </a:srgbClr>
+          </a:solidFill>
+          <a:ln>
+            <a:noFill/>
+          </a:ln>
+        </p:spPr>
+      </p:sp>
+      <p:sp>
+        <p:nvSpPr>
+          <p:cNvPr id="510" name="d510"/>
+          <p:cNvSpPr/>
+          <p:nvPr/>
+        </p:nvSpPr>
+        <p:spPr>
+          <a:xfrm>
+            <a:off x="2743200" y="4371975"/>
+            <a:ext cx="150000" cy="150000"/>
+          </a:xfrm>
+          <a:prstGeom prst="ellipse">
+            <a:avLst/>
+          </a:prstGeom>
+          <a:solidFill>
+            <a:srgbClr val="FF6D00">
+              <a:alpha val="8000"/>
+            </a:srgbClr>
+          </a:solidFill>
+          <a:ln>
+            <a:noFill/>
+          </a:ln>
+        </p:spPr>
+      </p:sp>
+      <p:sp>
+        <p:nvSpPr>
+          <p:cNvPr id="511" name="d511"/>
+          <p:cNvSpPr/>
+          <p:nvPr/>
+        </p:nvSpPr>
+        <p:spPr>
+          <a:xfrm>
+            <a:off x="4572000" y="4371975"/>
+            <a:ext cx="150000" cy="150000"/>
+          </a:xfrm>
+          <a:prstGeom prst="ellipse">
+            <a:avLst/>
+          </a:prstGeom>
+          <a:solidFill>
+            <a:srgbClr val="FF6D00">
+              <a:alpha val="8000"/>
+            </a:srgbClr>
+          </a:solidFill>
+          <a:ln>
+            <a:noFill/>
+          </a:ln>
+        </p:spPr>
+      </p:sp>
+      <p:sp>
+        <p:nvSpPr>
+          <p:cNvPr id="512" name="d512"/>
+          <p:cNvSpPr/>
+          <p:nvPr/>
+        </p:nvSpPr>
+        <p:spPr>
+          <a:xfrm>
+            <a:off x="6400800" y="4371975"/>
+            <a:ext cx="150000" cy="150000"/>
+          </a:xfrm>
+          <a:prstGeom prst="ellipse">
+            <a:avLst/>
+          </a:prstGeom>
+          <a:solidFill>
+            <a:srgbClr val="FF6D00">
+              <a:alpha val="8000"/>
+            </a:srgbClr>
+          </a:solidFill>
+          <a:ln>
+            <a:noFill/>
+          </a:ln>
+        </p:spPr>
+      </p:sp>
+      <p:sp>
+        <p:nvSpPr>
+          <p:cNvPr id="513" name="d513"/>
+          <p:cNvSpPr/>
+          <p:nvPr/>
+        </p:nvSpPr>
+        <p:spPr>
+          <a:xfrm>
+            <a:off x="8229600" y="4371975"/>
+            <a:ext cx="150000" cy="150000"/>
+          </a:xfrm>
+          <a:prstGeom prst="ellipse">
+            <a:avLst/>
+          </a:prstGeom>
+          <a:solidFill>
+            <a:srgbClr val="FF6D00">
+              <a:alpha val="8000"/>
+            </a:srgbClr>
+          </a:solidFill>
+          <a:ln>
+            <a:noFill/>
+          </a:ln>
+        </p:spPr>
+      </p:sp>
+      <p:sp>
+        <p:nvSpPr>
+          <p:cNvPr id="514" name="d514"/>
+          <p:cNvSpPr/>
+          <p:nvPr/>
+        </p:nvSpPr>
+        <p:spPr>
+          <a:xfrm>
+            <a:off x="4272000" y="10000"/>
+            <a:ext cx="600000" cy="300000"/>
+          </a:xfrm>
+          <a:prstGeom prst="diamond">
             <a:avLst/>
           </a:prstGeom>
           <a:solidFill>
@@ -1617,295 +1833,7 @@
       </p:sp>
       <p:sp>
         <p:nvSpPr>
-          <p:cNvPr id="506" name="d506"/>
-          <p:cNvSpPr/>
-          <p:nvPr/>
-        </p:nvSpPr>
-        <p:spPr>
-          <a:xfrm>
-            <a:off x="1524000" y="411480"/>
-            <a:ext cx="180000" cy="180000"/>
-          </a:xfrm>
-          <a:prstGeom prst="ellipse">
-            <a:avLst/>
-          </a:prstGeom>
-          <a:solidFill>
-            <a:srgbClr val="00BCD4">
-              <a:alpha val="10000"/>
-            </a:srgbClr>
-          </a:solidFill>
-          <a:ln>
-            <a:noFill/>
-          </a:ln>
-        </p:spPr>
-      </p:sp>
-      <p:sp>
-        <p:nvSpPr>
-          <p:cNvPr id="507" name="d507"/>
-          <p:cNvSpPr/>
-          <p:nvPr/>
-        </p:nvSpPr>
-        <p:spPr>
-          <a:xfrm>
-            <a:off x="3048000" y="411480"/>
-            <a:ext cx="180000" cy="180000"/>
-          </a:xfrm>
-          <a:prstGeom prst="ellipse">
-            <a:avLst/>
-          </a:prstGeom>
-          <a:solidFill>
-            <a:srgbClr val="00BCD4">
-              <a:alpha val="10000"/>
-            </a:srgbClr>
-          </a:solidFill>
-          <a:ln>
-            <a:noFill/>
-          </a:ln>
-        </p:spPr>
-      </p:sp>
-      <p:sp>
-        <p:nvSpPr>
-          <p:cNvPr id="508" name="d508"/>
-          <p:cNvSpPr/>
-          <p:nvPr/>
-        </p:nvSpPr>
-        <p:spPr>
-          <a:xfrm>
-            <a:off x="4572000" y="411480"/>
-            <a:ext cx="180000" cy="180000"/>
-          </a:xfrm>
-          <a:prstGeom prst="ellipse">
-            <a:avLst/>
-          </a:prstGeom>
-          <a:solidFill>
-            <a:srgbClr val="00BCD4">
-              <a:alpha val="10000"/>
-            </a:srgbClr>
-          </a:solidFill>
-          <a:ln>
-            <a:noFill/>
-          </a:ln>
-        </p:spPr>
-      </p:sp>
-      <p:sp>
-        <p:nvSpPr>
-          <p:cNvPr id="509" name="d509"/>
-          <p:cNvSpPr/>
-          <p:nvPr/>
-        </p:nvSpPr>
-        <p:spPr>
-          <a:xfrm>
-            <a:off x="6096000" y="411480"/>
-            <a:ext cx="180000" cy="180000"/>
-          </a:xfrm>
-          <a:prstGeom prst="ellipse">
-            <a:avLst/>
-          </a:prstGeom>
-          <a:solidFill>
-            <a:srgbClr val="00BCD4">
-              <a:alpha val="10000"/>
-            </a:srgbClr>
-          </a:solidFill>
-          <a:ln>
-            <a:noFill/>
-          </a:ln>
-        </p:spPr>
-      </p:sp>
-      <p:sp>
-        <p:nvSpPr>
-          <p:cNvPr id="510" name="d510"/>
-          <p:cNvSpPr/>
-          <p:nvPr/>
-        </p:nvSpPr>
-        <p:spPr>
-          <a:xfrm>
-            <a:off x="7620000" y="411480"/>
-            <a:ext cx="180000" cy="180000"/>
-          </a:xfrm>
-          <a:prstGeom prst="ellipse">
-            <a:avLst/>
-          </a:prstGeom>
-          <a:solidFill>
-            <a:srgbClr val="00BCD4">
-              <a:alpha val="10000"/>
-            </a:srgbClr>
-          </a:solidFill>
-          <a:ln>
-            <a:noFill/>
-          </a:ln>
-        </p:spPr>
-      </p:sp>
-      <p:sp>
-        <p:nvSpPr>
-          <p:cNvPr id="511" name="d511"/>
-          <p:cNvSpPr/>
-          <p:nvPr/>
-        </p:nvSpPr>
-        <p:spPr>
-          <a:xfrm>
-            <a:off x="762000" y="4474845"/>
-            <a:ext cx="140000" cy="140000"/>
-          </a:xfrm>
-          <a:prstGeom prst="ellipse">
-            <a:avLst/>
-          </a:prstGeom>
-          <a:solidFill>
-            <a:srgbClr val="FF6D00">
-              <a:alpha val="10000"/>
-            </a:srgbClr>
-          </a:solidFill>
-          <a:ln>
-            <a:noFill/>
-          </a:ln>
-        </p:spPr>
-      </p:sp>
-      <p:sp>
-        <p:nvSpPr>
-          <p:cNvPr id="512" name="d512"/>
-          <p:cNvSpPr/>
-          <p:nvPr/>
-        </p:nvSpPr>
-        <p:spPr>
-          <a:xfrm>
-            <a:off x="2286000" y="4474845"/>
-            <a:ext cx="140000" cy="140000"/>
-          </a:xfrm>
-          <a:prstGeom prst="ellipse">
-            <a:avLst/>
-          </a:prstGeom>
-          <a:solidFill>
-            <a:srgbClr val="FF6D00">
-              <a:alpha val="10000"/>
-            </a:srgbClr>
-          </a:solidFill>
-          <a:ln>
-            <a:noFill/>
-          </a:ln>
-        </p:spPr>
-      </p:sp>
-      <p:sp>
-        <p:nvSpPr>
-          <p:cNvPr id="513" name="d513"/>
-          <p:cNvSpPr/>
-          <p:nvPr/>
-        </p:nvSpPr>
-        <p:spPr>
-          <a:xfrm>
-            <a:off x="3810000" y="4474845"/>
-            <a:ext cx="140000" cy="140000"/>
-          </a:xfrm>
-          <a:prstGeom prst="ellipse">
-            <a:avLst/>
-          </a:prstGeom>
-          <a:solidFill>
-            <a:srgbClr val="FF6D00">
-              <a:alpha val="10000"/>
-            </a:srgbClr>
-          </a:solidFill>
-          <a:ln>
-            <a:noFill/>
-          </a:ln>
-        </p:spPr>
-      </p:sp>
-      <p:sp>
-        <p:nvSpPr>
-          <p:cNvPr id="514" name="d514"/>
-          <p:cNvSpPr/>
-          <p:nvPr/>
-        </p:nvSpPr>
-        <p:spPr>
-          <a:xfrm>
-            <a:off x="5334000" y="4474845"/>
-            <a:ext cx="140000" cy="140000"/>
-          </a:xfrm>
-          <a:prstGeom prst="ellipse">
-            <a:avLst/>
-          </a:prstGeom>
-          <a:solidFill>
-            <a:srgbClr val="FF6D00">
-              <a:alpha val="10000"/>
-            </a:srgbClr>
-          </a:solidFill>
-          <a:ln>
-            <a:noFill/>
-          </a:ln>
-        </p:spPr>
-      </p:sp>
-      <p:sp>
-        <p:nvSpPr>
           <p:cNvPr id="515" name="d515"/>
-          <p:cNvSpPr/>
-          <p:nvPr/>
-        </p:nvSpPr>
-        <p:spPr>
-          <a:xfrm>
-            <a:off x="6858000" y="4474845"/>
-            <a:ext cx="140000" cy="140000"/>
-          </a:xfrm>
-          <a:prstGeom prst="ellipse">
-            <a:avLst/>
-          </a:prstGeom>
-          <a:solidFill>
-            <a:srgbClr val="FF6D00">
-              <a:alpha val="10000"/>
-            </a:srgbClr>
-          </a:solidFill>
-          <a:ln>
-            <a:noFill/>
-          </a:ln>
-        </p:spPr>
-      </p:sp>
-      <p:sp>
-        <p:nvSpPr>
-          <p:cNvPr id="516" name="d516"/>
-          <p:cNvSpPr/>
-          <p:nvPr/>
-        </p:nvSpPr>
-        <p:spPr>
-          <a:xfrm>
-            <a:off x="8382000" y="4474845"/>
-            <a:ext cx="140000" cy="140000"/>
-          </a:xfrm>
-          <a:prstGeom prst="ellipse">
-            <a:avLst/>
-          </a:prstGeom>
-          <a:solidFill>
-            <a:srgbClr val="FF6D00">
-              <a:alpha val="10000"/>
-            </a:srgbClr>
-          </a:solidFill>
-          <a:ln>
-            <a:noFill/>
-          </a:ln>
-        </p:spPr>
-      </p:sp>
-      <p:sp>
-        <p:nvSpPr>
-          <p:cNvPr id="517" name="d517"/>
-          <p:cNvSpPr/>
-          <p:nvPr/>
-        </p:nvSpPr>
-        <p:spPr>
-          <a:xfrm>
-            <a:off x="4272000" y="10000"/>
-            <a:ext cx="600000" cy="300000"/>
-          </a:xfrm>
-          <a:prstGeom prst="diamond">
-            <a:avLst/>
-          </a:prstGeom>
-          <a:solidFill>
-            <a:srgbClr val="00BCD4">
-              <a:alpha val="12000"/>
-            </a:srgbClr>
-          </a:solidFill>
-          <a:ln>
-            <a:noFill/>
-          </a:ln>
-        </p:spPr>
-      </p:sp>
-      <p:sp>
-        <p:nvSpPr>
-          <p:cNvPr id="518" name="d518"/>
           <p:cNvSpPr/>
           <p:nvPr/>
         </p:nvSpPr>
@@ -1919,7 +1847,7 @@
           </a:prstGeom>
           <a:solidFill>
             <a:srgbClr val="2196F3">
-              <a:alpha val="12000"/>
+              <a:alpha val="10000"/>
             </a:srgbClr>
           </a:solidFill>
           <a:ln>
@@ -2716,7 +2644,7 @@
                           <p:cBhvr>
                             <p:cTn id="52" dur="1" fill="hold"/>
                             <p:tgtEl>
-                              <p:spTgt spid="516"/>
+                              <p:spTgt spid="2"/>
                             </p:tgtEl>
                             <p:attrNameLst>
                               <p:attrName>style.visibility</p:attrName>
@@ -2730,7 +2658,7 @@
                           <p:cBhvr>
                             <p:cTn id="53" dur="600"/>
                             <p:tgtEl>
-                              <p:spTgt spid="516"/>
+                              <p:spTgt spid="2"/>
                             </p:tgtEl>
                           </p:cBhvr>
                         </p:animEffect>
@@ -2747,7 +2675,7 @@
                           <p:cBhvr>
                             <p:cTn id="55" dur="1" fill="hold"/>
                             <p:tgtEl>
-                              <p:spTgt spid="517"/>
+                              <p:spTgt spid="3"/>
                             </p:tgtEl>
                             <p:attrNameLst>
                               <p:attrName>style.visibility</p:attrName>
@@ -2761,7 +2689,7 @@
                           <p:cBhvr>
                             <p:cTn id="56" dur="600"/>
                             <p:tgtEl>
-                              <p:spTgt spid="517"/>
+                              <p:spTgt spid="3"/>
                             </p:tgtEl>
                           </p:cBhvr>
                         </p:animEffect>
@@ -2778,7 +2706,7 @@
                           <p:cBhvr>
                             <p:cTn id="58" dur="1" fill="hold"/>
                             <p:tgtEl>
-                              <p:spTgt spid="518"/>
+                              <p:spTgt spid="4"/>
                             </p:tgtEl>
                             <p:attrNameLst>
                               <p:attrName>style.visibility</p:attrName>
@@ -2792,7 +2720,7 @@
                           <p:cBhvr>
                             <p:cTn id="59" dur="600"/>
                             <p:tgtEl>
-                              <p:spTgt spid="518"/>
+                              <p:spTgt spid="4"/>
                             </p:tgtEl>
                           </p:cBhvr>
                         </p:animEffect>
@@ -2809,7 +2737,7 @@
                           <p:cBhvr>
                             <p:cTn id="61" dur="1" fill="hold"/>
                             <p:tgtEl>
-                              <p:spTgt spid="2"/>
+                              <p:spTgt spid="5"/>
                             </p:tgtEl>
                             <p:attrNameLst>
                               <p:attrName>style.visibility</p:attrName>
@@ -2823,7 +2751,7 @@
                           <p:cBhvr>
                             <p:cTn id="62" dur="600"/>
                             <p:tgtEl>
-                              <p:spTgt spid="2"/>
+                              <p:spTgt spid="5"/>
                             </p:tgtEl>
                           </p:cBhvr>
                         </p:animEffect>
@@ -2840,7 +2768,7 @@
                           <p:cBhvr>
                             <p:cTn id="64" dur="1" fill="hold"/>
                             <p:tgtEl>
-                              <p:spTgt spid="3"/>
+                              <p:spTgt spid="6"/>
                             </p:tgtEl>
                             <p:attrNameLst>
                               <p:attrName>style.visibility</p:attrName>
@@ -2854,7 +2782,7 @@
                           <p:cBhvr>
                             <p:cTn id="65" dur="600"/>
                             <p:tgtEl>
-                              <p:spTgt spid="3"/>
+                              <p:spTgt spid="6"/>
                             </p:tgtEl>
                           </p:cBhvr>
                         </p:animEffect>
@@ -2871,7 +2799,7 @@
                           <p:cBhvr>
                             <p:cTn id="67" dur="1" fill="hold"/>
                             <p:tgtEl>
-                              <p:spTgt spid="4"/>
+                              <p:spTgt spid="7"/>
                             </p:tgtEl>
                             <p:attrNameLst>
                               <p:attrName>style.visibility</p:attrName>
@@ -2885,7 +2813,7 @@
                           <p:cBhvr>
                             <p:cTn id="68" dur="600"/>
                             <p:tgtEl>
-                              <p:spTgt spid="4"/>
+                              <p:spTgt spid="7"/>
                             </p:tgtEl>
                           </p:cBhvr>
                         </p:animEffect>
@@ -2902,7 +2830,7 @@
                           <p:cBhvr>
                             <p:cTn id="70" dur="1" fill="hold"/>
                             <p:tgtEl>
-                              <p:spTgt spid="5"/>
+                              <p:spTgt spid="8"/>
                             </p:tgtEl>
                             <p:attrNameLst>
                               <p:attrName>style.visibility</p:attrName>
@@ -2916,7 +2844,7 @@
                           <p:cBhvr>
                             <p:cTn id="71" dur="600"/>
                             <p:tgtEl>
-                              <p:spTgt spid="5"/>
+                              <p:spTgt spid="8"/>
                             </p:tgtEl>
                           </p:cBhvr>
                         </p:animEffect>
@@ -2933,7 +2861,7 @@
                           <p:cBhvr>
                             <p:cTn id="73" dur="1" fill="hold"/>
                             <p:tgtEl>
-                              <p:spTgt spid="6"/>
+                              <p:spTgt spid="9"/>
                             </p:tgtEl>
                             <p:attrNameLst>
                               <p:attrName>style.visibility</p:attrName>
@@ -2946,99 +2874,6 @@
                         <p:animEffect transition="in" filter="fade">
                           <p:cBhvr>
                             <p:cTn id="74" dur="600"/>
-                            <p:tgtEl>
-                              <p:spTgt spid="6"/>
-                            </p:tgtEl>
-                          </p:cBhvr>
-                        </p:animEffect>
-                      </p:childTnLst>
-                    </p:cTn>
-                  </p:par>
-                  <p:par>
-                    <p:cTn id="75" presetID="10" presetClass="entr" presetSubtype="0" fill="hold" grpId="24" nodeType="withEffect">
-                      <p:stCondLst>
-                        <p:cond delay="2400"/>
-                      </p:stCondLst>
-                      <p:childTnLst>
-                        <p:set>
-                          <p:cBhvr>
-                            <p:cTn id="76" dur="1" fill="hold"/>
-                            <p:tgtEl>
-                              <p:spTgt spid="7"/>
-                            </p:tgtEl>
-                            <p:attrNameLst>
-                              <p:attrName>style.visibility</p:attrName>
-                            </p:attrNameLst>
-                          </p:cBhvr>
-                          <p:to>
-                            <p:strVal val="visible"/>
-                          </p:to>
-                        </p:set>
-                        <p:animEffect transition="in" filter="fade">
-                          <p:cBhvr>
-                            <p:cTn id="77" dur="600"/>
-                            <p:tgtEl>
-                              <p:spTgt spid="7"/>
-                            </p:tgtEl>
-                          </p:cBhvr>
-                        </p:animEffect>
-                      </p:childTnLst>
-                    </p:cTn>
-                  </p:par>
-                  <p:par>
-                    <p:cTn id="78" presetID="10" presetClass="entr" presetSubtype="0" fill="hold" grpId="25" nodeType="withEffect">
-                      <p:stCondLst>
-                        <p:cond delay="2500"/>
-                      </p:stCondLst>
-                      <p:childTnLst>
-                        <p:set>
-                          <p:cBhvr>
-                            <p:cTn id="79" dur="1" fill="hold"/>
-                            <p:tgtEl>
-                              <p:spTgt spid="8"/>
-                            </p:tgtEl>
-                            <p:attrNameLst>
-                              <p:attrName>style.visibility</p:attrName>
-                            </p:attrNameLst>
-                          </p:cBhvr>
-                          <p:to>
-                            <p:strVal val="visible"/>
-                          </p:to>
-                        </p:set>
-                        <p:animEffect transition="in" filter="fade">
-                          <p:cBhvr>
-                            <p:cTn id="80" dur="600"/>
-                            <p:tgtEl>
-                              <p:spTgt spid="8"/>
-                            </p:tgtEl>
-                          </p:cBhvr>
-                        </p:animEffect>
-                      </p:childTnLst>
-                    </p:cTn>
-                  </p:par>
-                  <p:par>
-                    <p:cTn id="81" presetID="10" presetClass="entr" presetSubtype="0" fill="hold" grpId="26" nodeType="withEffect">
-                      <p:stCondLst>
-                        <p:cond delay="2600"/>
-                      </p:stCondLst>
-                      <p:childTnLst>
-                        <p:set>
-                          <p:cBhvr>
-                            <p:cTn id="82" dur="1" fill="hold"/>
-                            <p:tgtEl>
-                              <p:spTgt spid="9"/>
-                            </p:tgtEl>
-                            <p:attrNameLst>
-                              <p:attrName>style.visibility</p:attrName>
-                            </p:attrNameLst>
-                          </p:cBhvr>
-                          <p:to>
-                            <p:strVal val="visible"/>
-                          </p:to>
-                        </p:set>
-                        <p:animEffect transition="in" filter="fade">
-                          <p:cBhvr>
-                            <p:cTn id="83" dur="600"/>
                             <p:tgtEl>
                               <p:spTgt spid="9"/>
                             </p:tgtEl>
@@ -3071,17 +2906,14 @@
       <p:bldP spid="513" grpId="13" uiExpand="1" build="p"/>
       <p:bldP spid="514" grpId="14" uiExpand="1" build="p"/>
       <p:bldP spid="515" grpId="15" uiExpand="1" build="p"/>
-      <p:bldP spid="516" grpId="16" uiExpand="1" build="p"/>
-      <p:bldP spid="517" grpId="17" uiExpand="1" build="p"/>
-      <p:bldP spid="518" grpId="18" uiExpand="1" build="p"/>
-      <p:bldP spid="2" grpId="19" uiExpand="1" build="p"/>
-      <p:bldP spid="3" grpId="20" uiExpand="1" build="p"/>
-      <p:bldP spid="4" grpId="21" uiExpand="1" build="p"/>
-      <p:bldP spid="5" grpId="22" uiExpand="1" build="p"/>
-      <p:bldP spid="6" grpId="23" uiExpand="1" build="p"/>
-      <p:bldP spid="7" grpId="24" uiExpand="1" build="p"/>
-      <p:bldP spid="8" grpId="25" uiExpand="1" build="p"/>
-      <p:bldP spid="9" grpId="26" uiExpand="1" build="p"/>
+      <p:bldP spid="2" grpId="16" uiExpand="1" build="p"/>
+      <p:bldP spid="3" grpId="17" uiExpand="1" build="p"/>
+      <p:bldP spid="4" grpId="18" uiExpand="1" build="p"/>
+      <p:bldP spid="5" grpId="19" uiExpand="1" build="p"/>
+      <p:bldP spid="6" grpId="20" uiExpand="1" build="p"/>
+      <p:bldP spid="7" grpId="21" uiExpand="1" build="p"/>
+      <p:bldP spid="8" grpId="22" uiExpand="1" build="p"/>
+      <p:bldP spid="9" grpId="23" uiExpand="1" build="p"/>
     </p:bldLst>
   </p:timing>
 </p:sld>
@@ -3120,8 +2952,8 @@
         </p:nvSpPr>
         <p:spPr>
           <a:xfrm>
-            <a:off x="4072000" y="2071750"/>
-            <a:ext cx="1000000" cy="1000000"/>
+            <a:off x="3972000" y="1971750"/>
+            <a:ext cx="1200000" cy="1200000"/>
           </a:xfrm>
           <a:prstGeom prst="ellipse">
             <a:avLst/>
@@ -3129,8 +2961,8 @@
           <a:noFill/>
           <a:ln w="38100">
             <a:solidFill>
-              <a:srgbClr val="FFD700">
-                <a:alpha val="8000"/>
+              <a:srgbClr val="2196F3">
+                <a:alpha val="6000"/>
               </a:srgbClr>
             </a:solidFill>
           </a:ln>
@@ -3144,8 +2976,8 @@
         </p:nvSpPr>
         <p:spPr>
           <a:xfrm>
-            <a:off x="3572000" y="1571750"/>
-            <a:ext cx="2000000" cy="2000000"/>
+            <a:off x="3672000" y="1671750"/>
+            <a:ext cx="1800000" cy="1800000"/>
           </a:xfrm>
           <a:prstGeom prst="ellipse">
             <a:avLst/>
@@ -3153,8 +2985,8 @@
           <a:noFill/>
           <a:ln w="25400">
             <a:solidFill>
-              <a:srgbClr val="FFD700">
-                <a:alpha val="5000"/>
+              <a:srgbClr val="00BCD4">
+                <a:alpha val="4000"/>
               </a:srgbClr>
             </a:solidFill>
           </a:ln>
@@ -3169,14 +3001,14 @@
         <p:spPr>
           <a:xfrm>
             <a:off x="0" y="0"/>
-            <a:ext cx="9144000" cy="514350"/>
+            <a:ext cx="9144000" cy="642937"/>
           </a:xfrm>
           <a:prstGeom prst="rect">
             <a:avLst/>
           </a:prstGeom>
           <a:solidFill>
-            <a:srgbClr val="FFD700">
-              <a:alpha val="8000"/>
+            <a:srgbClr val="2196F3">
+              <a:alpha val="5000"/>
             </a:srgbClr>
           </a:solidFill>
           <a:ln>
@@ -3192,10 +3024,154 @@
         </p:nvSpPr>
         <p:spPr>
           <a:xfrm>
-            <a:off x="0" y="4629150"/>
-            <a:ext cx="9144000" cy="514350"/>
+            <a:off x="0" y="4500563"/>
+            <a:ext cx="9144000" cy="642937"/>
           </a:xfrm>
           <a:prstGeom prst="rect">
+            <a:avLst/>
+          </a:prstGeom>
+          <a:solidFill>
+            <a:srgbClr val="00BCD4">
+              <a:alpha val="5000"/>
+            </a:srgbClr>
+          </a:solidFill>
+          <a:ln>
+            <a:noFill/>
+          </a:ln>
+        </p:spPr>
+      </p:sp>
+      <p:sp>
+        <p:nvSpPr>
+          <p:cNvPr id="504" name="d504"/>
+          <p:cNvSpPr/>
+          <p:nvPr/>
+        </p:nvSpPr>
+        <p:spPr>
+          <a:xfrm>
+            <a:off x="0" y="514350"/>
+            <a:ext cx="200000" cy="200000"/>
+          </a:xfrm>
+          <a:prstGeom prst="ellipse">
+            <a:avLst/>
+          </a:prstGeom>
+          <a:solidFill>
+            <a:srgbClr val="FF6D00">
+              <a:alpha val="8000"/>
+            </a:srgbClr>
+          </a:solidFill>
+          <a:ln>
+            <a:noFill/>
+          </a:ln>
+        </p:spPr>
+      </p:sp>
+      <p:sp>
+        <p:nvSpPr>
+          <p:cNvPr id="505" name="d505"/>
+          <p:cNvSpPr/>
+          <p:nvPr/>
+        </p:nvSpPr>
+        <p:spPr>
+          <a:xfrm>
+            <a:off x="1828800" y="514350"/>
+            <a:ext cx="200000" cy="200000"/>
+          </a:xfrm>
+          <a:prstGeom prst="ellipse">
+            <a:avLst/>
+          </a:prstGeom>
+          <a:solidFill>
+            <a:srgbClr val="FF6D00">
+              <a:alpha val="8000"/>
+            </a:srgbClr>
+          </a:solidFill>
+          <a:ln>
+            <a:noFill/>
+          </a:ln>
+        </p:spPr>
+      </p:sp>
+      <p:sp>
+        <p:nvSpPr>
+          <p:cNvPr id="506" name="d506"/>
+          <p:cNvSpPr/>
+          <p:nvPr/>
+        </p:nvSpPr>
+        <p:spPr>
+          <a:xfrm>
+            <a:off x="3657600" y="514350"/>
+            <a:ext cx="200000" cy="200000"/>
+          </a:xfrm>
+          <a:prstGeom prst="ellipse">
+            <a:avLst/>
+          </a:prstGeom>
+          <a:solidFill>
+            <a:srgbClr val="FF6D00">
+              <a:alpha val="8000"/>
+            </a:srgbClr>
+          </a:solidFill>
+          <a:ln>
+            <a:noFill/>
+          </a:ln>
+        </p:spPr>
+      </p:sp>
+      <p:sp>
+        <p:nvSpPr>
+          <p:cNvPr id="507" name="d507"/>
+          <p:cNvSpPr/>
+          <p:nvPr/>
+        </p:nvSpPr>
+        <p:spPr>
+          <a:xfrm>
+            <a:off x="5486400" y="514350"/>
+            <a:ext cx="200000" cy="200000"/>
+          </a:xfrm>
+          <a:prstGeom prst="ellipse">
+            <a:avLst/>
+          </a:prstGeom>
+          <a:solidFill>
+            <a:srgbClr val="FF6D00">
+              <a:alpha val="8000"/>
+            </a:srgbClr>
+          </a:solidFill>
+          <a:ln>
+            <a:noFill/>
+          </a:ln>
+        </p:spPr>
+      </p:sp>
+      <p:sp>
+        <p:nvSpPr>
+          <p:cNvPr id="508" name="d508"/>
+          <p:cNvSpPr/>
+          <p:nvPr/>
+        </p:nvSpPr>
+        <p:spPr>
+          <a:xfrm>
+            <a:off x="7315200" y="514350"/>
+            <a:ext cx="200000" cy="200000"/>
+          </a:xfrm>
+          <a:prstGeom prst="ellipse">
+            <a:avLst/>
+          </a:prstGeom>
+          <a:solidFill>
+            <a:srgbClr val="FF6D00">
+              <a:alpha val="8000"/>
+            </a:srgbClr>
+          </a:solidFill>
+          <a:ln>
+            <a:noFill/>
+          </a:ln>
+        </p:spPr>
+      </p:sp>
+      <p:sp>
+        <p:nvSpPr>
+          <p:cNvPr id="509" name="d509"/>
+          <p:cNvSpPr/>
+          <p:nvPr/>
+        </p:nvSpPr>
+        <p:spPr>
+          <a:xfrm>
+            <a:off x="914400" y="4371975"/>
+            <a:ext cx="150000" cy="150000"/>
+          </a:xfrm>
+          <a:prstGeom prst="ellipse">
             <a:avLst/>
           </a:prstGeom>
           <a:solidFill>
@@ -3210,21 +3186,21 @@
       </p:sp>
       <p:sp>
         <p:nvSpPr>
-          <p:cNvPr id="504" name="d504"/>
-          <p:cNvSpPr/>
-          <p:nvPr/>
-        </p:nvSpPr>
-        <p:spPr>
-          <a:xfrm>
-            <a:off x="0" y="514350"/>
-            <a:ext cx="200000" cy="200000"/>
+          <p:cNvPr id="510" name="d510"/>
+          <p:cNvSpPr/>
+          <p:nvPr/>
+        </p:nvSpPr>
+        <p:spPr>
+          <a:xfrm>
+            <a:off x="2743200" y="4371975"/>
+            <a:ext cx="150000" cy="150000"/>
           </a:xfrm>
           <a:prstGeom prst="ellipse">
             <a:avLst/>
           </a:prstGeom>
           <a:solidFill>
-            <a:srgbClr val="FFD700">
-              <a:alpha val="10000"/>
+            <a:srgbClr val="2196F3">
+              <a:alpha val="8000"/>
             </a:srgbClr>
           </a:solidFill>
           <a:ln>
@@ -3234,21 +3210,21 @@
       </p:sp>
       <p:sp>
         <p:nvSpPr>
-          <p:cNvPr id="505" name="d505"/>
-          <p:cNvSpPr/>
-          <p:nvPr/>
-        </p:nvSpPr>
-        <p:spPr>
-          <a:xfrm>
-            <a:off x="1828800" y="514350"/>
-            <a:ext cx="200000" cy="200000"/>
+          <p:cNvPr id="511" name="d511"/>
+          <p:cNvSpPr/>
+          <p:nvPr/>
+        </p:nvSpPr>
+        <p:spPr>
+          <a:xfrm>
+            <a:off x="4572000" y="4371975"/>
+            <a:ext cx="150000" cy="150000"/>
           </a:xfrm>
           <a:prstGeom prst="ellipse">
             <a:avLst/>
           </a:prstGeom>
           <a:solidFill>
-            <a:srgbClr val="FFD700">
-              <a:alpha val="10000"/>
+            <a:srgbClr val="2196F3">
+              <a:alpha val="8000"/>
             </a:srgbClr>
           </a:solidFill>
           <a:ln>
@@ -3258,21 +3234,21 @@
       </p:sp>
       <p:sp>
         <p:nvSpPr>
-          <p:cNvPr id="506" name="d506"/>
-          <p:cNvSpPr/>
-          <p:nvPr/>
-        </p:nvSpPr>
-        <p:spPr>
-          <a:xfrm>
-            <a:off x="3657600" y="514350"/>
-            <a:ext cx="200000" cy="200000"/>
+          <p:cNvPr id="512" name="d512"/>
+          <p:cNvSpPr/>
+          <p:nvPr/>
+        </p:nvSpPr>
+        <p:spPr>
+          <a:xfrm>
+            <a:off x="6400800" y="4371975"/>
+            <a:ext cx="150000" cy="150000"/>
           </a:xfrm>
           <a:prstGeom prst="ellipse">
             <a:avLst/>
           </a:prstGeom>
           <a:solidFill>
-            <a:srgbClr val="FFD700">
-              <a:alpha val="10000"/>
+            <a:srgbClr val="2196F3">
+              <a:alpha val="8000"/>
             </a:srgbClr>
           </a:solidFill>
           <a:ln>
@@ -3282,21 +3258,21 @@
       </p:sp>
       <p:sp>
         <p:nvSpPr>
-          <p:cNvPr id="507" name="d507"/>
-          <p:cNvSpPr/>
-          <p:nvPr/>
-        </p:nvSpPr>
-        <p:spPr>
-          <a:xfrm>
-            <a:off x="5486400" y="514350"/>
-            <a:ext cx="200000" cy="200000"/>
+          <p:cNvPr id="513" name="d513"/>
+          <p:cNvSpPr/>
+          <p:nvPr/>
+        </p:nvSpPr>
+        <p:spPr>
+          <a:xfrm>
+            <a:off x="8229600" y="4371975"/>
+            <a:ext cx="150000" cy="150000"/>
           </a:xfrm>
           <a:prstGeom prst="ellipse">
             <a:avLst/>
           </a:prstGeom>
           <a:solidFill>
-            <a:srgbClr val="FFD700">
-              <a:alpha val="10000"/>
+            <a:srgbClr val="2196F3">
+              <a:alpha val="8000"/>
             </a:srgbClr>
           </a:solidFill>
           <a:ln>
@@ -3306,20 +3282,20 @@
       </p:sp>
       <p:sp>
         <p:nvSpPr>
-          <p:cNvPr id="508" name="d508"/>
-          <p:cNvSpPr/>
-          <p:nvPr/>
-        </p:nvSpPr>
-        <p:spPr>
-          <a:xfrm>
-            <a:off x="7315200" y="514350"/>
-            <a:ext cx="200000" cy="200000"/>
-          </a:xfrm>
-          <a:prstGeom prst="ellipse">
-            <a:avLst/>
-          </a:prstGeom>
-          <a:solidFill>
-            <a:srgbClr val="FFD700">
+          <p:cNvPr id="514" name="d514"/>
+          <p:cNvSpPr/>
+          <p:nvPr/>
+        </p:nvSpPr>
+        <p:spPr>
+          <a:xfrm>
+            <a:off x="4272000" y="10000"/>
+            <a:ext cx="600000" cy="300000"/>
+          </a:xfrm>
+          <a:prstGeom prst="diamond">
+            <a:avLst/>
+          </a:prstGeom>
+          <a:solidFill>
+            <a:srgbClr val="FF6D00">
               <a:alpha val="10000"/>
             </a:srgbClr>
           </a:solidFill>
@@ -3330,165 +3306,21 @@
       </p:sp>
       <p:sp>
         <p:nvSpPr>
-          <p:cNvPr id="509" name="d509"/>
-          <p:cNvSpPr/>
-          <p:nvPr/>
-        </p:nvSpPr>
-        <p:spPr>
-          <a:xfrm>
-            <a:off x="914400" y="4371975"/>
-            <a:ext cx="160000" cy="160000"/>
-          </a:xfrm>
-          <a:prstGeom prst="ellipse">
-            <a:avLst/>
-          </a:prstGeom>
-          <a:solidFill>
-            <a:srgbClr val="9C27B0">
+          <p:cNvPr id="515" name="d515"/>
+          <p:cNvSpPr/>
+          <p:nvPr/>
+        </p:nvSpPr>
+        <p:spPr>
+          <a:xfrm>
+            <a:off x="4272000" y="4833500"/>
+            <a:ext cx="600000" cy="300000"/>
+          </a:xfrm>
+          <a:prstGeom prst="diamond">
+            <a:avLst/>
+          </a:prstGeom>
+          <a:solidFill>
+            <a:srgbClr val="00BCD4">
               <a:alpha val="10000"/>
-            </a:srgbClr>
-          </a:solidFill>
-          <a:ln>
-            <a:noFill/>
-          </a:ln>
-        </p:spPr>
-      </p:sp>
-      <p:sp>
-        <p:nvSpPr>
-          <p:cNvPr id="510" name="d510"/>
-          <p:cNvSpPr/>
-          <p:nvPr/>
-        </p:nvSpPr>
-        <p:spPr>
-          <a:xfrm>
-            <a:off x="2743200" y="4371975"/>
-            <a:ext cx="160000" cy="160000"/>
-          </a:xfrm>
-          <a:prstGeom prst="ellipse">
-            <a:avLst/>
-          </a:prstGeom>
-          <a:solidFill>
-            <a:srgbClr val="9C27B0">
-              <a:alpha val="10000"/>
-            </a:srgbClr>
-          </a:solidFill>
-          <a:ln>
-            <a:noFill/>
-          </a:ln>
-        </p:spPr>
-      </p:sp>
-      <p:sp>
-        <p:nvSpPr>
-          <p:cNvPr id="511" name="d511"/>
-          <p:cNvSpPr/>
-          <p:nvPr/>
-        </p:nvSpPr>
-        <p:spPr>
-          <a:xfrm>
-            <a:off x="4572000" y="4371975"/>
-            <a:ext cx="160000" cy="160000"/>
-          </a:xfrm>
-          <a:prstGeom prst="ellipse">
-            <a:avLst/>
-          </a:prstGeom>
-          <a:solidFill>
-            <a:srgbClr val="9C27B0">
-              <a:alpha val="10000"/>
-            </a:srgbClr>
-          </a:solidFill>
-          <a:ln>
-            <a:noFill/>
-          </a:ln>
-        </p:spPr>
-      </p:sp>
-      <p:sp>
-        <p:nvSpPr>
-          <p:cNvPr id="512" name="d512"/>
-          <p:cNvSpPr/>
-          <p:nvPr/>
-        </p:nvSpPr>
-        <p:spPr>
-          <a:xfrm>
-            <a:off x="6400800" y="4371975"/>
-            <a:ext cx="160000" cy="160000"/>
-          </a:xfrm>
-          <a:prstGeom prst="ellipse">
-            <a:avLst/>
-          </a:prstGeom>
-          <a:solidFill>
-            <a:srgbClr val="9C27B0">
-              <a:alpha val="10000"/>
-            </a:srgbClr>
-          </a:solidFill>
-          <a:ln>
-            <a:noFill/>
-          </a:ln>
-        </p:spPr>
-      </p:sp>
-      <p:sp>
-        <p:nvSpPr>
-          <p:cNvPr id="513" name="d513"/>
-          <p:cNvSpPr/>
-          <p:nvPr/>
-        </p:nvSpPr>
-        <p:spPr>
-          <a:xfrm>
-            <a:off x="8229600" y="4371975"/>
-            <a:ext cx="160000" cy="160000"/>
-          </a:xfrm>
-          <a:prstGeom prst="ellipse">
-            <a:avLst/>
-          </a:prstGeom>
-          <a:solidFill>
-            <a:srgbClr val="9C27B0">
-              <a:alpha val="10000"/>
-            </a:srgbClr>
-          </a:solidFill>
-          <a:ln>
-            <a:noFill/>
-          </a:ln>
-        </p:spPr>
-      </p:sp>
-      <p:sp>
-        <p:nvSpPr>
-          <p:cNvPr id="514" name="d514"/>
-          <p:cNvSpPr/>
-          <p:nvPr/>
-        </p:nvSpPr>
-        <p:spPr>
-          <a:xfrm>
-            <a:off x="4222000" y="15000"/>
-            <a:ext cx="700000" cy="350000"/>
-          </a:xfrm>
-          <a:prstGeom prst="diamond">
-            <a:avLst/>
-          </a:prstGeom>
-          <a:solidFill>
-            <a:srgbClr val="FFD700">
-              <a:alpha val="15000"/>
-            </a:srgbClr>
-          </a:solidFill>
-          <a:ln>
-            <a:noFill/>
-          </a:ln>
-        </p:spPr>
-      </p:sp>
-      <p:sp>
-        <p:nvSpPr>
-          <p:cNvPr id="515" name="d515"/>
-          <p:cNvSpPr/>
-          <p:nvPr/>
-        </p:nvSpPr>
-        <p:spPr>
-          <a:xfrm>
-            <a:off x="4222000" y="4778500"/>
-            <a:ext cx="700000" cy="350000"/>
-          </a:xfrm>
-          <a:prstGeom prst="diamond">
-            <a:avLst/>
-          </a:prstGeom>
-          <a:solidFill>
-            <a:srgbClr val="FFD700">
-              <a:alpha val="15000"/>
             </a:srgbClr>
           </a:solidFill>
           <a:ln>
@@ -5236,8 +5068,8 @@
         </p:nvSpPr>
         <p:spPr>
           <a:xfrm>
-            <a:off x="3872000" y="1871750"/>
-            <a:ext cx="1400000" cy="1400000"/>
+            <a:off x="3972000" y="1971750"/>
+            <a:ext cx="1200000" cy="1200000"/>
           </a:xfrm>
           <a:prstGeom prst="ellipse">
             <a:avLst/>
@@ -5245,7 +5077,7 @@
           <a:noFill/>
           <a:ln w="38100">
             <a:solidFill>
-              <a:srgbClr val="FF6D00">
+              <a:srgbClr val="00BCD4">
                 <a:alpha val="6000"/>
               </a:srgbClr>
             </a:solidFill>
@@ -5260,17 +5092,17 @@
         </p:nvSpPr>
         <p:spPr>
           <a:xfrm>
-            <a:off x="3272000" y="1271750"/>
-            <a:ext cx="2600000" cy="2600000"/>
+            <a:off x="3672000" y="1671750"/>
+            <a:ext cx="1800000" cy="1800000"/>
           </a:xfrm>
           <a:prstGeom prst="ellipse">
             <a:avLst/>
           </a:prstGeom>
           <a:noFill/>
-          <a:ln w="20000">
+          <a:ln w="25400">
             <a:solidFill>
-              <a:srgbClr val="2196F3">
-                <a:alpha val="3000"/>
+              <a:srgbClr val="FF6D00">
+                <a:alpha val="4000"/>
               </a:srgbClr>
             </a:solidFill>
           </a:ln>
@@ -5291,6 +5123,30 @@
             <a:avLst/>
           </a:prstGeom>
           <a:solidFill>
+            <a:srgbClr val="00BCD4">
+              <a:alpha val="5000"/>
+            </a:srgbClr>
+          </a:solidFill>
+          <a:ln>
+            <a:noFill/>
+          </a:ln>
+        </p:spPr>
+      </p:sp>
+      <p:sp>
+        <p:nvSpPr>
+          <p:cNvPr id="503" name="d503"/>
+          <p:cNvSpPr/>
+          <p:nvPr/>
+        </p:nvSpPr>
+        <p:spPr>
+          <a:xfrm>
+            <a:off x="0" y="4500563"/>
+            <a:ext cx="9144000" cy="642937"/>
+          </a:xfrm>
+          <a:prstGeom prst="rect">
+            <a:avLst/>
+          </a:prstGeom>
+          <a:solidFill>
             <a:srgbClr val="FF6D00">
               <a:alpha val="5000"/>
             </a:srgbClr>
@@ -5302,21 +5158,21 @@
       </p:sp>
       <p:sp>
         <p:nvSpPr>
-          <p:cNvPr id="503" name="d503"/>
-          <p:cNvSpPr/>
-          <p:nvPr/>
-        </p:nvSpPr>
-        <p:spPr>
-          <a:xfrm>
-            <a:off x="0" y="4500563"/>
-            <a:ext cx="9144000" cy="642937"/>
-          </a:xfrm>
-          <a:prstGeom prst="rect">
-            <a:avLst/>
-          </a:prstGeom>
-          <a:solidFill>
-            <a:srgbClr val="00BCD4">
-              <a:alpha val="5000"/>
+          <p:cNvPr id="504" name="d504"/>
+          <p:cNvSpPr/>
+          <p:nvPr/>
+        </p:nvSpPr>
+        <p:spPr>
+          <a:xfrm>
+            <a:off x="0" y="514350"/>
+            <a:ext cx="200000" cy="200000"/>
+          </a:xfrm>
+          <a:prstGeom prst="ellipse">
+            <a:avLst/>
+          </a:prstGeom>
+          <a:solidFill>
+            <a:srgbClr val="2196F3">
+              <a:alpha val="8000"/>
             </a:srgbClr>
           </a:solidFill>
           <a:ln>
@@ -5326,13 +5182,13 @@
       </p:sp>
       <p:sp>
         <p:nvSpPr>
-          <p:cNvPr id="504" name="d504"/>
-          <p:cNvSpPr/>
-          <p:nvPr/>
-        </p:nvSpPr>
-        <p:spPr>
-          <a:xfrm>
-            <a:off x="0" y="514350"/>
+          <p:cNvPr id="505" name="d505"/>
+          <p:cNvSpPr/>
+          <p:nvPr/>
+        </p:nvSpPr>
+        <p:spPr>
+          <a:xfrm>
+            <a:off x="1828800" y="514350"/>
             <a:ext cx="200000" cy="200000"/>
           </a:xfrm>
           <a:prstGeom prst="ellipse">
@@ -5350,13 +5206,13 @@
       </p:sp>
       <p:sp>
         <p:nvSpPr>
-          <p:cNvPr id="505" name="d505"/>
-          <p:cNvSpPr/>
-          <p:nvPr/>
-        </p:nvSpPr>
-        <p:spPr>
-          <a:xfrm>
-            <a:off x="1828800" y="514350"/>
+          <p:cNvPr id="506" name="d506"/>
+          <p:cNvSpPr/>
+          <p:nvPr/>
+        </p:nvSpPr>
+        <p:spPr>
+          <a:xfrm>
+            <a:off x="3657600" y="514350"/>
             <a:ext cx="200000" cy="200000"/>
           </a:xfrm>
           <a:prstGeom prst="ellipse">
@@ -5374,13 +5230,13 @@
       </p:sp>
       <p:sp>
         <p:nvSpPr>
-          <p:cNvPr id="506" name="d506"/>
-          <p:cNvSpPr/>
-          <p:nvPr/>
-        </p:nvSpPr>
-        <p:spPr>
-          <a:xfrm>
-            <a:off x="3657600" y="514350"/>
+          <p:cNvPr id="507" name="d507"/>
+          <p:cNvSpPr/>
+          <p:nvPr/>
+        </p:nvSpPr>
+        <p:spPr>
+          <a:xfrm>
+            <a:off x="5486400" y="514350"/>
             <a:ext cx="200000" cy="200000"/>
           </a:xfrm>
           <a:prstGeom prst="ellipse">
@@ -5398,13 +5254,13 @@
       </p:sp>
       <p:sp>
         <p:nvSpPr>
-          <p:cNvPr id="507" name="d507"/>
-          <p:cNvSpPr/>
-          <p:nvPr/>
-        </p:nvSpPr>
-        <p:spPr>
-          <a:xfrm>
-            <a:off x="5486400" y="514350"/>
+          <p:cNvPr id="508" name="d508"/>
+          <p:cNvSpPr/>
+          <p:nvPr/>
+        </p:nvSpPr>
+        <p:spPr>
+          <a:xfrm>
+            <a:off x="7315200" y="514350"/>
             <a:ext cx="200000" cy="200000"/>
           </a:xfrm>
           <a:prstGeom prst="ellipse">
@@ -5422,20 +5278,20 @@
       </p:sp>
       <p:sp>
         <p:nvSpPr>
-          <p:cNvPr id="508" name="d508"/>
-          <p:cNvSpPr/>
-          <p:nvPr/>
-        </p:nvSpPr>
-        <p:spPr>
-          <a:xfrm>
-            <a:off x="7315200" y="514350"/>
-            <a:ext cx="200000" cy="200000"/>
+          <p:cNvPr id="509" name="d509"/>
+          <p:cNvSpPr/>
+          <p:nvPr/>
+        </p:nvSpPr>
+        <p:spPr>
+          <a:xfrm>
+            <a:off x="914400" y="4371975"/>
+            <a:ext cx="150000" cy="150000"/>
           </a:xfrm>
           <a:prstGeom prst="ellipse">
             <a:avLst/>
           </a:prstGeom>
           <a:solidFill>
-            <a:srgbClr val="2196F3">
+            <a:srgbClr val="00BCD4">
               <a:alpha val="8000"/>
             </a:srgbClr>
           </a:solidFill>
@@ -5446,20 +5302,20 @@
       </p:sp>
       <p:sp>
         <p:nvSpPr>
-          <p:cNvPr id="509" name="d509"/>
-          <p:cNvSpPr/>
-          <p:nvPr/>
-        </p:nvSpPr>
-        <p:spPr>
-          <a:xfrm>
-            <a:off x="914400" y="4371975"/>
+          <p:cNvPr id="510" name="d510"/>
+          <p:cNvSpPr/>
+          <p:nvPr/>
+        </p:nvSpPr>
+        <p:spPr>
+          <a:xfrm>
+            <a:off x="2743200" y="4371975"/>
             <a:ext cx="150000" cy="150000"/>
           </a:xfrm>
           <a:prstGeom prst="ellipse">
             <a:avLst/>
           </a:prstGeom>
           <a:solidFill>
-            <a:srgbClr val="FF6D00">
+            <a:srgbClr val="00BCD4">
               <a:alpha val="8000"/>
             </a:srgbClr>
           </a:solidFill>
@@ -5470,20 +5326,20 @@
       </p:sp>
       <p:sp>
         <p:nvSpPr>
-          <p:cNvPr id="510" name="d510"/>
-          <p:cNvSpPr/>
-          <p:nvPr/>
-        </p:nvSpPr>
-        <p:spPr>
-          <a:xfrm>
-            <a:off x="2743200" y="4371975"/>
+          <p:cNvPr id="511" name="d511"/>
+          <p:cNvSpPr/>
+          <p:nvPr/>
+        </p:nvSpPr>
+        <p:spPr>
+          <a:xfrm>
+            <a:off x="4572000" y="4371975"/>
             <a:ext cx="150000" cy="150000"/>
           </a:xfrm>
           <a:prstGeom prst="ellipse">
             <a:avLst/>
           </a:prstGeom>
           <a:solidFill>
-            <a:srgbClr val="FF6D00">
+            <a:srgbClr val="00BCD4">
               <a:alpha val="8000"/>
             </a:srgbClr>
           </a:solidFill>
@@ -5494,20 +5350,20 @@
       </p:sp>
       <p:sp>
         <p:nvSpPr>
-          <p:cNvPr id="511" name="d511"/>
-          <p:cNvSpPr/>
-          <p:nvPr/>
-        </p:nvSpPr>
-        <p:spPr>
-          <a:xfrm>
-            <a:off x="4572000" y="4371975"/>
+          <p:cNvPr id="512" name="d512"/>
+          <p:cNvSpPr/>
+          <p:nvPr/>
+        </p:nvSpPr>
+        <p:spPr>
+          <a:xfrm>
+            <a:off x="6400800" y="4371975"/>
             <a:ext cx="150000" cy="150000"/>
           </a:xfrm>
           <a:prstGeom prst="ellipse">
             <a:avLst/>
           </a:prstGeom>
           <a:solidFill>
-            <a:srgbClr val="FF6D00">
+            <a:srgbClr val="00BCD4">
               <a:alpha val="8000"/>
             </a:srgbClr>
           </a:solidFill>
@@ -5518,20 +5374,20 @@
       </p:sp>
       <p:sp>
         <p:nvSpPr>
-          <p:cNvPr id="512" name="d512"/>
-          <p:cNvSpPr/>
-          <p:nvPr/>
-        </p:nvSpPr>
-        <p:spPr>
-          <a:xfrm>
-            <a:off x="6400800" y="4371975"/>
+          <p:cNvPr id="513" name="d513"/>
+          <p:cNvSpPr/>
+          <p:nvPr/>
+        </p:nvSpPr>
+        <p:spPr>
+          <a:xfrm>
+            <a:off x="8229600" y="4371975"/>
             <a:ext cx="150000" cy="150000"/>
           </a:xfrm>
           <a:prstGeom prst="ellipse">
             <a:avLst/>
           </a:prstGeom>
           <a:solidFill>
-            <a:srgbClr val="FF6D00">
+            <a:srgbClr val="00BCD4">
               <a:alpha val="8000"/>
             </a:srgbClr>
           </a:solidFill>
@@ -5542,21 +5398,21 @@
       </p:sp>
       <p:sp>
         <p:nvSpPr>
-          <p:cNvPr id="513" name="d513"/>
-          <p:cNvSpPr/>
-          <p:nvPr/>
-        </p:nvSpPr>
-        <p:spPr>
-          <a:xfrm>
-            <a:off x="8229600" y="4371975"/>
-            <a:ext cx="150000" cy="150000"/>
-          </a:xfrm>
-          <a:prstGeom prst="ellipse">
-            <a:avLst/>
-          </a:prstGeom>
-          <a:solidFill>
-            <a:srgbClr val="FF6D00">
-              <a:alpha val="8000"/>
+          <p:cNvPr id="514" name="d514"/>
+          <p:cNvSpPr/>
+          <p:nvPr/>
+        </p:nvSpPr>
+        <p:spPr>
+          <a:xfrm>
+            <a:off x="4272000" y="10000"/>
+            <a:ext cx="600000" cy="300000"/>
+          </a:xfrm>
+          <a:prstGeom prst="diamond">
+            <a:avLst/>
+          </a:prstGeom>
+          <a:solidFill>
+            <a:srgbClr val="2196F3">
+              <a:alpha val="10000"/>
             </a:srgbClr>
           </a:solidFill>
           <a:ln>
@@ -5566,30 +5422,6 @@
       </p:sp>
       <p:sp>
         <p:nvSpPr>
-          <p:cNvPr id="514" name="d514"/>
-          <p:cNvSpPr/>
-          <p:nvPr/>
-        </p:nvSpPr>
-        <p:spPr>
-          <a:xfrm>
-            <a:off x="4272000" y="10000"/>
-            <a:ext cx="600000" cy="300000"/>
-          </a:xfrm>
-          <a:prstGeom prst="diamond">
-            <a:avLst/>
-          </a:prstGeom>
-          <a:solidFill>
-            <a:srgbClr val="00BCD4">
-              <a:alpha val="10000"/>
-            </a:srgbClr>
-          </a:solidFill>
-          <a:ln>
-            <a:noFill/>
-          </a:ln>
-        </p:spPr>
-      </p:sp>
-      <p:sp>
-        <p:nvSpPr>
           <p:cNvPr id="515" name="d515"/>
           <p:cNvSpPr/>
           <p:nvPr/>
@@ -5603,7 +5435,7 @@
             <a:avLst/>
           </a:prstGeom>
           <a:solidFill>
-            <a:srgbClr val="2196F3">
+            <a:srgbClr val="FF6D00">
               <a:alpha val="10000"/>
             </a:srgbClr>
           </a:solidFill>
@@ -6595,10 +6427,10 @@
             <a:avLst/>
           </a:prstGeom>
           <a:noFill/>
-          <a:ln w="40000">
+          <a:ln w="38100">
             <a:solidFill>
               <a:srgbClr val="FF6D00">
-                <a:alpha val="7000"/>
+                <a:alpha val="6000"/>
               </a:srgbClr>
             </a:solidFill>
           </a:ln>
@@ -6612,8 +6444,8 @@
         </p:nvSpPr>
         <p:spPr>
           <a:xfrm>
-            <a:off x="3472000" y="1471750"/>
-            <a:ext cx="2200000" cy="2200000"/>
+            <a:off x="3672000" y="1671750"/>
+            <a:ext cx="1800000" cy="1800000"/>
           </a:xfrm>
           <a:prstGeom prst="ellipse">
             <a:avLst/>
@@ -6621,7 +6453,7 @@
           <a:noFill/>
           <a:ln w="25400">
             <a:solidFill>
-              <a:srgbClr val="FF6D00">
+              <a:srgbClr val="00BCD4">
                 <a:alpha val="4000"/>
               </a:srgbClr>
             </a:solidFill>
@@ -6644,7 +6476,7 @@
           </a:prstGeom>
           <a:solidFill>
             <a:srgbClr val="FF6D00">
-              <a:alpha val="6000"/>
+              <a:alpha val="5000"/>
             </a:srgbClr>
           </a:solidFill>
           <a:ln>
@@ -6667,8 +6499,8 @@
             <a:avLst/>
           </a:prstGeom>
           <a:solidFill>
-            <a:srgbClr val="9C27B0">
-              <a:alpha val="6000"/>
+            <a:srgbClr val="00BCD4">
+              <a:alpha val="5000"/>
             </a:srgbClr>
           </a:solidFill>
           <a:ln>
@@ -6691,8 +6523,8 @@
             <a:avLst/>
           </a:prstGeom>
           <a:solidFill>
-            <a:srgbClr val="FF6D00">
-              <a:alpha val="10000"/>
+            <a:srgbClr val="2196F3">
+              <a:alpha val="8000"/>
             </a:srgbClr>
           </a:solidFill>
           <a:ln>
@@ -6715,8 +6547,8 @@
             <a:avLst/>
           </a:prstGeom>
           <a:solidFill>
-            <a:srgbClr val="FF6D00">
-              <a:alpha val="10000"/>
+            <a:srgbClr val="2196F3">
+              <a:alpha val="8000"/>
             </a:srgbClr>
           </a:solidFill>
           <a:ln>
@@ -6739,8 +6571,8 @@
             <a:avLst/>
           </a:prstGeom>
           <a:solidFill>
-            <a:srgbClr val="FF6D00">
-              <a:alpha val="10000"/>
+            <a:srgbClr val="2196F3">
+              <a:alpha val="8000"/>
             </a:srgbClr>
           </a:solidFill>
           <a:ln>
@@ -6763,8 +6595,8 @@
             <a:avLst/>
           </a:prstGeom>
           <a:solidFill>
-            <a:srgbClr val="FF6D00">
-              <a:alpha val="10000"/>
+            <a:srgbClr val="2196F3">
+              <a:alpha val="8000"/>
             </a:srgbClr>
           </a:solidFill>
           <a:ln>
@@ -6787,8 +6619,8 @@
             <a:avLst/>
           </a:prstGeom>
           <a:solidFill>
-            <a:srgbClr val="FF6D00">
-              <a:alpha val="10000"/>
+            <a:srgbClr val="2196F3">
+              <a:alpha val="8000"/>
             </a:srgbClr>
           </a:solidFill>
           <a:ln>
@@ -6811,8 +6643,8 @@
             <a:avLst/>
           </a:prstGeom>
           <a:solidFill>
-            <a:srgbClr val="00BCD4">
-              <a:alpha val="10000"/>
+            <a:srgbClr val="FF6D00">
+              <a:alpha val="8000"/>
             </a:srgbClr>
           </a:solidFill>
           <a:ln>
@@ -6835,8 +6667,8 @@
             <a:avLst/>
           </a:prstGeom>
           <a:solidFill>
-            <a:srgbClr val="00BCD4">
-              <a:alpha val="10000"/>
+            <a:srgbClr val="FF6D00">
+              <a:alpha val="8000"/>
             </a:srgbClr>
           </a:solidFill>
           <a:ln>
@@ -6859,8 +6691,8 @@
             <a:avLst/>
           </a:prstGeom>
           <a:solidFill>
-            <a:srgbClr val="00BCD4">
-              <a:alpha val="10000"/>
+            <a:srgbClr val="FF6D00">
+              <a:alpha val="8000"/>
             </a:srgbClr>
           </a:solidFill>
           <a:ln>
@@ -6883,8 +6715,8 @@
             <a:avLst/>
           </a:prstGeom>
           <a:solidFill>
-            <a:srgbClr val="00BCD4">
-              <a:alpha val="10000"/>
+            <a:srgbClr val="FF6D00">
+              <a:alpha val="8000"/>
             </a:srgbClr>
           </a:solidFill>
           <a:ln>
@@ -6907,8 +6739,8 @@
             <a:avLst/>
           </a:prstGeom>
           <a:solidFill>
-            <a:srgbClr val="00BCD4">
-              <a:alpha val="10000"/>
+            <a:srgbClr val="FF6D00">
+              <a:alpha val="8000"/>
             </a:srgbClr>
           </a:solidFill>
           <a:ln>
@@ -6931,8 +6763,8 @@
             <a:avLst/>
           </a:prstGeom>
           <a:solidFill>
-            <a:srgbClr val="9C27B0">
-              <a:alpha val="12000"/>
+            <a:srgbClr val="2196F3">
+              <a:alpha val="10000"/>
             </a:srgbClr>
           </a:solidFill>
           <a:ln>
@@ -6955,8 +6787,8 @@
             <a:avLst/>
           </a:prstGeom>
           <a:solidFill>
-            <a:srgbClr val="FF6D00">
-              <a:alpha val="12000"/>
+            <a:srgbClr val="00BCD4">
+              <a:alpha val="10000"/>
             </a:srgbClr>
           </a:solidFill>
           <a:ln>
@@ -8679,8 +8511,8 @@
           <a:noFill/>
           <a:ln w="38100">
             <a:solidFill>
-              <a:srgbClr val="00BCD4">
-                <a:alpha val="7000"/>
+              <a:srgbClr val="2196F3">
+                <a:alpha val="6000"/>
               </a:srgbClr>
             </a:solidFill>
           </a:ln>
@@ -8694,8 +8526,8 @@
         </p:nvSpPr>
         <p:spPr>
           <a:xfrm>
-            <a:off x="3372000" y="1371750"/>
-            <a:ext cx="2400000" cy="2400000"/>
+            <a:off x="3672000" y="1671750"/>
+            <a:ext cx="1800000" cy="1800000"/>
           </a:xfrm>
           <a:prstGeom prst="ellipse">
             <a:avLst/>
@@ -8725,7 +8557,7 @@
             <a:avLst/>
           </a:prstGeom>
           <a:solidFill>
-            <a:srgbClr val="00BCD4">
+            <a:srgbClr val="2196F3">
               <a:alpha val="5000"/>
             </a:srgbClr>
           </a:solidFill>
@@ -8749,7 +8581,7 @@
             <a:avLst/>
           </a:prstGeom>
           <a:solidFill>
-            <a:srgbClr val="00BCD4">
+            <a:srgbClr val="FF6D00">
               <a:alpha val="5000"/>
             </a:srgbClr>
           </a:solidFill>
@@ -8774,7 +8606,7 @@
           </a:prstGeom>
           <a:solidFill>
             <a:srgbClr val="00BCD4">
-              <a:alpha val="10000"/>
+              <a:alpha val="8000"/>
             </a:srgbClr>
           </a:solidFill>
           <a:ln>
@@ -8798,7 +8630,7 @@
           </a:prstGeom>
           <a:solidFill>
             <a:srgbClr val="00BCD4">
-              <a:alpha val="10000"/>
+              <a:alpha val="8000"/>
             </a:srgbClr>
           </a:solidFill>
           <a:ln>
@@ -8822,7 +8654,7 @@
           </a:prstGeom>
           <a:solidFill>
             <a:srgbClr val="00BCD4">
-              <a:alpha val="10000"/>
+              <a:alpha val="8000"/>
             </a:srgbClr>
           </a:solidFill>
           <a:ln>
@@ -8846,7 +8678,7 @@
           </a:prstGeom>
           <a:solidFill>
             <a:srgbClr val="00BCD4">
-              <a:alpha val="10000"/>
+              <a:alpha val="8000"/>
             </a:srgbClr>
           </a:solidFill>
           <a:ln>
@@ -8870,7 +8702,7 @@
           </a:prstGeom>
           <a:solidFill>
             <a:srgbClr val="00BCD4">
-              <a:alpha val="10000"/>
+              <a:alpha val="8000"/>
             </a:srgbClr>
           </a:solidFill>
           <a:ln>
@@ -8894,7 +8726,7 @@
           </a:prstGeom>
           <a:solidFill>
             <a:srgbClr val="2196F3">
-              <a:alpha val="10000"/>
+              <a:alpha val="8000"/>
             </a:srgbClr>
           </a:solidFill>
           <a:ln>
@@ -8918,7 +8750,7 @@
           </a:prstGeom>
           <a:solidFill>
             <a:srgbClr val="2196F3">
-              <a:alpha val="10000"/>
+              <a:alpha val="8000"/>
             </a:srgbClr>
           </a:solidFill>
           <a:ln>
@@ -8942,7 +8774,7 @@
           </a:prstGeom>
           <a:solidFill>
             <a:srgbClr val="2196F3">
-              <a:alpha val="10000"/>
+              <a:alpha val="8000"/>
             </a:srgbClr>
           </a:solidFill>
           <a:ln>
@@ -8966,7 +8798,7 @@
           </a:prstGeom>
           <a:solidFill>
             <a:srgbClr val="2196F3">
-              <a:alpha val="10000"/>
+              <a:alpha val="8000"/>
             </a:srgbClr>
           </a:solidFill>
           <a:ln>
@@ -8990,7 +8822,7 @@
           </a:prstGeom>
           <a:solidFill>
             <a:srgbClr val="2196F3">
-              <a:alpha val="10000"/>
+              <a:alpha val="8000"/>
             </a:srgbClr>
           </a:solidFill>
           <a:ln>
@@ -9037,7 +8869,7 @@
             <a:avLst/>
           </a:prstGeom>
           <a:solidFill>
-            <a:srgbClr val="00BCD4">
+            <a:srgbClr val="FF6D00">
               <a:alpha val="10000"/>
             </a:srgbClr>
           </a:solidFill>
@@ -11505,7 +11337,7 @@
           <a:noFill/>
           <a:ln w="38100">
             <a:solidFill>
-              <a:srgbClr val="9C27B0">
+              <a:srgbClr val="00BCD4">
                 <a:alpha val="6000"/>
               </a:srgbClr>
             </a:solidFill>
@@ -11520,17 +11352,17 @@
         </p:nvSpPr>
         <p:spPr>
           <a:xfrm>
-            <a:off x="3472000" y="1471750"/>
-            <a:ext cx="2200000" cy="2200000"/>
+            <a:off x="3672000" y="1671750"/>
+            <a:ext cx="1800000" cy="1800000"/>
           </a:xfrm>
           <a:prstGeom prst="ellipse">
             <a:avLst/>
           </a:prstGeom>
           <a:noFill/>
-          <a:ln w="20000">
+          <a:ln w="25400">
             <a:solidFill>
-              <a:srgbClr val="FF6D00">
-                <a:alpha val="3000"/>
+              <a:srgbClr val="2196F3">
+                <a:alpha val="4000"/>
               </a:srgbClr>
             </a:solidFill>
           </a:ln>
@@ -11551,7 +11383,7 @@
             <a:avLst/>
           </a:prstGeom>
           <a:solidFill>
-            <a:srgbClr val="9C27B0">
+            <a:srgbClr val="00BCD4">
               <a:alpha val="5000"/>
             </a:srgbClr>
           </a:solidFill>
@@ -11575,7 +11407,7 @@
             <a:avLst/>
           </a:prstGeom>
           <a:solidFill>
-            <a:srgbClr val="00E676">
+            <a:srgbClr val="2196F3">
               <a:alpha val="5000"/>
             </a:srgbClr>
           </a:solidFill>
@@ -11599,8 +11431,8 @@
             <a:avLst/>
           </a:prstGeom>
           <a:solidFill>
-            <a:srgbClr val="9C27B0">
-              <a:alpha val="10000"/>
+            <a:srgbClr val="FF6D00">
+              <a:alpha val="8000"/>
             </a:srgbClr>
           </a:solidFill>
           <a:ln>
@@ -11623,8 +11455,8 @@
             <a:avLst/>
           </a:prstGeom>
           <a:solidFill>
-            <a:srgbClr val="9C27B0">
-              <a:alpha val="10000"/>
+            <a:srgbClr val="FF6D00">
+              <a:alpha val="8000"/>
             </a:srgbClr>
           </a:solidFill>
           <a:ln>
@@ -11647,8 +11479,8 @@
             <a:avLst/>
           </a:prstGeom>
           <a:solidFill>
-            <a:srgbClr val="9C27B0">
-              <a:alpha val="10000"/>
+            <a:srgbClr val="FF6D00">
+              <a:alpha val="8000"/>
             </a:srgbClr>
           </a:solidFill>
           <a:ln>
@@ -11671,8 +11503,8 @@
             <a:avLst/>
           </a:prstGeom>
           <a:solidFill>
-            <a:srgbClr val="9C27B0">
-              <a:alpha val="10000"/>
+            <a:srgbClr val="FF6D00">
+              <a:alpha val="8000"/>
             </a:srgbClr>
           </a:solidFill>
           <a:ln>
@@ -11695,8 +11527,8 @@
             <a:avLst/>
           </a:prstGeom>
           <a:solidFill>
-            <a:srgbClr val="9C27B0">
-              <a:alpha val="10000"/>
+            <a:srgbClr val="FF6D00">
+              <a:alpha val="8000"/>
             </a:srgbClr>
           </a:solidFill>
           <a:ln>
@@ -11719,8 +11551,8 @@
             <a:avLst/>
           </a:prstGeom>
           <a:solidFill>
-            <a:srgbClr val="2196F3">
-              <a:alpha val="10000"/>
+            <a:srgbClr val="00BCD4">
+              <a:alpha val="8000"/>
             </a:srgbClr>
           </a:solidFill>
           <a:ln>
@@ -11743,8 +11575,8 @@
             <a:avLst/>
           </a:prstGeom>
           <a:solidFill>
-            <a:srgbClr val="2196F3">
-              <a:alpha val="10000"/>
+            <a:srgbClr val="00BCD4">
+              <a:alpha val="8000"/>
             </a:srgbClr>
           </a:solidFill>
           <a:ln>
@@ -11767,8 +11599,8 @@
             <a:avLst/>
           </a:prstGeom>
           <a:solidFill>
-            <a:srgbClr val="2196F3">
-              <a:alpha val="10000"/>
+            <a:srgbClr val="00BCD4">
+              <a:alpha val="8000"/>
             </a:srgbClr>
           </a:solidFill>
           <a:ln>
@@ -11791,8 +11623,8 @@
             <a:avLst/>
           </a:prstGeom>
           <a:solidFill>
-            <a:srgbClr val="2196F3">
-              <a:alpha val="10000"/>
+            <a:srgbClr val="00BCD4">
+              <a:alpha val="8000"/>
             </a:srgbClr>
           </a:solidFill>
           <a:ln>
@@ -11815,8 +11647,8 @@
             <a:avLst/>
           </a:prstGeom>
           <a:solidFill>
-            <a:srgbClr val="2196F3">
-              <a:alpha val="10000"/>
+            <a:srgbClr val="00BCD4">
+              <a:alpha val="8000"/>
             </a:srgbClr>
           </a:solidFill>
           <a:ln>
@@ -11839,7 +11671,7 @@
             <a:avLst/>
           </a:prstGeom>
           <a:solidFill>
-            <a:srgbClr val="00E676">
+            <a:srgbClr val="FF6D00">
               <a:alpha val="10000"/>
             </a:srgbClr>
           </a:solidFill>
@@ -11863,7 +11695,7 @@
             <a:avLst/>
           </a:prstGeom>
           <a:solidFill>
-            <a:srgbClr val="9C27B0">
+            <a:srgbClr val="2196F3">
               <a:alpha val="10000"/>
             </a:srgbClr>
           </a:solidFill>
@@ -13777,8 +13609,8 @@
           <a:noFill/>
           <a:ln w="38100">
             <a:solidFill>
-              <a:srgbClr val="00E676">
-                <a:alpha val="7000"/>
+              <a:srgbClr val="FF6D00">
+                <a:alpha val="6000"/>
               </a:srgbClr>
             </a:solidFill>
           </a:ln>
@@ -13792,8 +13624,8 @@
         </p:nvSpPr>
         <p:spPr>
           <a:xfrm>
-            <a:off x="3372000" y="1371750"/>
-            <a:ext cx="2400000" cy="2400000"/>
+            <a:off x="3672000" y="1671750"/>
+            <a:ext cx="1800000" cy="1800000"/>
           </a:xfrm>
           <a:prstGeom prst="ellipse">
             <a:avLst/>
@@ -13823,7 +13655,7 @@
             <a:avLst/>
           </a:prstGeom>
           <a:solidFill>
-            <a:srgbClr val="00E676">
+            <a:srgbClr val="FF6D00">
               <a:alpha val="5000"/>
             </a:srgbClr>
           </a:solidFill>
@@ -13847,7 +13679,7 @@
             <a:avLst/>
           </a:prstGeom>
           <a:solidFill>
-            <a:srgbClr val="00BCD4">
+            <a:srgbClr val="2196F3">
               <a:alpha val="5000"/>
             </a:srgbClr>
           </a:solidFill>
@@ -13871,8 +13703,8 @@
             <a:avLst/>
           </a:prstGeom>
           <a:solidFill>
-            <a:srgbClr val="00E676">
-              <a:alpha val="10000"/>
+            <a:srgbClr val="00BCD4">
+              <a:alpha val="8000"/>
             </a:srgbClr>
           </a:solidFill>
           <a:ln>
@@ -13895,8 +13727,8 @@
             <a:avLst/>
           </a:prstGeom>
           <a:solidFill>
-            <a:srgbClr val="00E676">
-              <a:alpha val="10000"/>
+            <a:srgbClr val="00BCD4">
+              <a:alpha val="8000"/>
             </a:srgbClr>
           </a:solidFill>
           <a:ln>
@@ -13919,8 +13751,8 @@
             <a:avLst/>
           </a:prstGeom>
           <a:solidFill>
-            <a:srgbClr val="00E676">
-              <a:alpha val="10000"/>
+            <a:srgbClr val="00BCD4">
+              <a:alpha val="8000"/>
             </a:srgbClr>
           </a:solidFill>
           <a:ln>
@@ -13943,8 +13775,8 @@
             <a:avLst/>
           </a:prstGeom>
           <a:solidFill>
-            <a:srgbClr val="00E676">
-              <a:alpha val="10000"/>
+            <a:srgbClr val="00BCD4">
+              <a:alpha val="8000"/>
             </a:srgbClr>
           </a:solidFill>
           <a:ln>
@@ -13967,8 +13799,8 @@
             <a:avLst/>
           </a:prstGeom>
           <a:solidFill>
-            <a:srgbClr val="00E676">
-              <a:alpha val="10000"/>
+            <a:srgbClr val="00BCD4">
+              <a:alpha val="8000"/>
             </a:srgbClr>
           </a:solidFill>
           <a:ln>
@@ -13992,7 +13824,7 @@
           </a:prstGeom>
           <a:solidFill>
             <a:srgbClr val="FF6D00">
-              <a:alpha val="10000"/>
+              <a:alpha val="8000"/>
             </a:srgbClr>
           </a:solidFill>
           <a:ln>
@@ -14016,7 +13848,7 @@
           </a:prstGeom>
           <a:solidFill>
             <a:srgbClr val="FF6D00">
-              <a:alpha val="10000"/>
+              <a:alpha val="8000"/>
             </a:srgbClr>
           </a:solidFill>
           <a:ln>
@@ -14040,7 +13872,7 @@
           </a:prstGeom>
           <a:solidFill>
             <a:srgbClr val="FF6D00">
-              <a:alpha val="10000"/>
+              <a:alpha val="8000"/>
             </a:srgbClr>
           </a:solidFill>
           <a:ln>
@@ -14064,7 +13896,7 @@
           </a:prstGeom>
           <a:solidFill>
             <a:srgbClr val="FF6D00">
-              <a:alpha val="10000"/>
+              <a:alpha val="8000"/>
             </a:srgbClr>
           </a:solidFill>
           <a:ln>
@@ -14088,7 +13920,7 @@
           </a:prstGeom>
           <a:solidFill>
             <a:srgbClr val="FF6D00">
-              <a:alpha val="10000"/>
+              <a:alpha val="8000"/>
             </a:srgbClr>
           </a:solidFill>
           <a:ln>
@@ -14135,7 +13967,7 @@
             <a:avLst/>
           </a:prstGeom>
           <a:solidFill>
-            <a:srgbClr val="00E676">
+            <a:srgbClr val="2196F3">
               <a:alpha val="10000"/>
             </a:srgbClr>
           </a:solidFill>
@@ -15194,8 +15026,8 @@
           <a:noFill/>
           <a:ln w="38100">
             <a:solidFill>
-              <a:srgbClr val="FF1744">
-                <a:alpha val="7000"/>
+              <a:srgbClr val="2196F3">
+                <a:alpha val="6000"/>
               </a:srgbClr>
             </a:solidFill>
           </a:ln>
@@ -15209,8 +15041,8 @@
         </p:nvSpPr>
         <p:spPr>
           <a:xfrm>
-            <a:off x="3372000" y="1371750"/>
-            <a:ext cx="2400000" cy="2400000"/>
+            <a:off x="3672000" y="1671750"/>
+            <a:ext cx="1800000" cy="1800000"/>
           </a:xfrm>
           <a:prstGeom prst="ellipse">
             <a:avLst/>
@@ -15240,7 +15072,7 @@
             <a:avLst/>
           </a:prstGeom>
           <a:solidFill>
-            <a:srgbClr val="FF1744">
+            <a:srgbClr val="2196F3">
               <a:alpha val="5000"/>
             </a:srgbClr>
           </a:solidFill>
@@ -15264,7 +15096,7 @@
             <a:avLst/>
           </a:prstGeom>
           <a:solidFill>
-            <a:srgbClr val="2196F3">
+            <a:srgbClr val="00BCD4">
               <a:alpha val="5000"/>
             </a:srgbClr>
           </a:solidFill>
@@ -15288,8 +15120,8 @@
             <a:avLst/>
           </a:prstGeom>
           <a:solidFill>
-            <a:srgbClr val="FF1744">
-              <a:alpha val="10000"/>
+            <a:srgbClr val="FF6D00">
+              <a:alpha val="8000"/>
             </a:srgbClr>
           </a:solidFill>
           <a:ln>
@@ -15312,8 +15144,8 @@
             <a:avLst/>
           </a:prstGeom>
           <a:solidFill>
-            <a:srgbClr val="FF1744">
-              <a:alpha val="10000"/>
+            <a:srgbClr val="FF6D00">
+              <a:alpha val="8000"/>
             </a:srgbClr>
           </a:solidFill>
           <a:ln>
@@ -15336,8 +15168,8 @@
             <a:avLst/>
           </a:prstGeom>
           <a:solidFill>
-            <a:srgbClr val="FF1744">
-              <a:alpha val="10000"/>
+            <a:srgbClr val="FF6D00">
+              <a:alpha val="8000"/>
             </a:srgbClr>
           </a:solidFill>
           <a:ln>
@@ -15360,8 +15192,8 @@
             <a:avLst/>
           </a:prstGeom>
           <a:solidFill>
-            <a:srgbClr val="FF1744">
-              <a:alpha val="10000"/>
+            <a:srgbClr val="FF6D00">
+              <a:alpha val="8000"/>
             </a:srgbClr>
           </a:solidFill>
           <a:ln>
@@ -15384,8 +15216,8 @@
             <a:avLst/>
           </a:prstGeom>
           <a:solidFill>
-            <a:srgbClr val="FF1744">
-              <a:alpha val="10000"/>
+            <a:srgbClr val="FF6D00">
+              <a:alpha val="8000"/>
             </a:srgbClr>
           </a:solidFill>
           <a:ln>
@@ -15408,6 +15240,126 @@
             <a:avLst/>
           </a:prstGeom>
           <a:solidFill>
+            <a:srgbClr val="2196F3">
+              <a:alpha val="8000"/>
+            </a:srgbClr>
+          </a:solidFill>
+          <a:ln>
+            <a:noFill/>
+          </a:ln>
+        </p:spPr>
+      </p:sp>
+      <p:sp>
+        <p:nvSpPr>
+          <p:cNvPr id="510" name="d510"/>
+          <p:cNvSpPr/>
+          <p:nvPr/>
+        </p:nvSpPr>
+        <p:spPr>
+          <a:xfrm>
+            <a:off x="2743200" y="4371975"/>
+            <a:ext cx="150000" cy="150000"/>
+          </a:xfrm>
+          <a:prstGeom prst="ellipse">
+            <a:avLst/>
+          </a:prstGeom>
+          <a:solidFill>
+            <a:srgbClr val="2196F3">
+              <a:alpha val="8000"/>
+            </a:srgbClr>
+          </a:solidFill>
+          <a:ln>
+            <a:noFill/>
+          </a:ln>
+        </p:spPr>
+      </p:sp>
+      <p:sp>
+        <p:nvSpPr>
+          <p:cNvPr id="511" name="d511"/>
+          <p:cNvSpPr/>
+          <p:nvPr/>
+        </p:nvSpPr>
+        <p:spPr>
+          <a:xfrm>
+            <a:off x="4572000" y="4371975"/>
+            <a:ext cx="150000" cy="150000"/>
+          </a:xfrm>
+          <a:prstGeom prst="ellipse">
+            <a:avLst/>
+          </a:prstGeom>
+          <a:solidFill>
+            <a:srgbClr val="2196F3">
+              <a:alpha val="8000"/>
+            </a:srgbClr>
+          </a:solidFill>
+          <a:ln>
+            <a:noFill/>
+          </a:ln>
+        </p:spPr>
+      </p:sp>
+      <p:sp>
+        <p:nvSpPr>
+          <p:cNvPr id="512" name="d512"/>
+          <p:cNvSpPr/>
+          <p:nvPr/>
+        </p:nvSpPr>
+        <p:spPr>
+          <a:xfrm>
+            <a:off x="6400800" y="4371975"/>
+            <a:ext cx="150000" cy="150000"/>
+          </a:xfrm>
+          <a:prstGeom prst="ellipse">
+            <a:avLst/>
+          </a:prstGeom>
+          <a:solidFill>
+            <a:srgbClr val="2196F3">
+              <a:alpha val="8000"/>
+            </a:srgbClr>
+          </a:solidFill>
+          <a:ln>
+            <a:noFill/>
+          </a:ln>
+        </p:spPr>
+      </p:sp>
+      <p:sp>
+        <p:nvSpPr>
+          <p:cNvPr id="513" name="d513"/>
+          <p:cNvSpPr/>
+          <p:nvPr/>
+        </p:nvSpPr>
+        <p:spPr>
+          <a:xfrm>
+            <a:off x="8229600" y="4371975"/>
+            <a:ext cx="150000" cy="150000"/>
+          </a:xfrm>
+          <a:prstGeom prst="ellipse">
+            <a:avLst/>
+          </a:prstGeom>
+          <a:solidFill>
+            <a:srgbClr val="2196F3">
+              <a:alpha val="8000"/>
+            </a:srgbClr>
+          </a:solidFill>
+          <a:ln>
+            <a:noFill/>
+          </a:ln>
+        </p:spPr>
+      </p:sp>
+      <p:sp>
+        <p:nvSpPr>
+          <p:cNvPr id="514" name="d514"/>
+          <p:cNvSpPr/>
+          <p:nvPr/>
+        </p:nvSpPr>
+        <p:spPr>
+          <a:xfrm>
+            <a:off x="4272000" y="10000"/>
+            <a:ext cx="600000" cy="300000"/>
+          </a:xfrm>
+          <a:prstGeom prst="diamond">
+            <a:avLst/>
+          </a:prstGeom>
+          <a:solidFill>
             <a:srgbClr val="FF6D00">
               <a:alpha val="10000"/>
             </a:srgbClr>
@@ -15419,126 +15371,6 @@
       </p:sp>
       <p:sp>
         <p:nvSpPr>
-          <p:cNvPr id="510" name="d510"/>
-          <p:cNvSpPr/>
-          <p:nvPr/>
-        </p:nvSpPr>
-        <p:spPr>
-          <a:xfrm>
-            <a:off x="2743200" y="4371975"/>
-            <a:ext cx="150000" cy="150000"/>
-          </a:xfrm>
-          <a:prstGeom prst="ellipse">
-            <a:avLst/>
-          </a:prstGeom>
-          <a:solidFill>
-            <a:srgbClr val="FF6D00">
-              <a:alpha val="10000"/>
-            </a:srgbClr>
-          </a:solidFill>
-          <a:ln>
-            <a:noFill/>
-          </a:ln>
-        </p:spPr>
-      </p:sp>
-      <p:sp>
-        <p:nvSpPr>
-          <p:cNvPr id="511" name="d511"/>
-          <p:cNvSpPr/>
-          <p:nvPr/>
-        </p:nvSpPr>
-        <p:spPr>
-          <a:xfrm>
-            <a:off x="4572000" y="4371975"/>
-            <a:ext cx="150000" cy="150000"/>
-          </a:xfrm>
-          <a:prstGeom prst="ellipse">
-            <a:avLst/>
-          </a:prstGeom>
-          <a:solidFill>
-            <a:srgbClr val="FF6D00">
-              <a:alpha val="10000"/>
-            </a:srgbClr>
-          </a:solidFill>
-          <a:ln>
-            <a:noFill/>
-          </a:ln>
-        </p:spPr>
-      </p:sp>
-      <p:sp>
-        <p:nvSpPr>
-          <p:cNvPr id="512" name="d512"/>
-          <p:cNvSpPr/>
-          <p:nvPr/>
-        </p:nvSpPr>
-        <p:spPr>
-          <a:xfrm>
-            <a:off x="6400800" y="4371975"/>
-            <a:ext cx="150000" cy="150000"/>
-          </a:xfrm>
-          <a:prstGeom prst="ellipse">
-            <a:avLst/>
-          </a:prstGeom>
-          <a:solidFill>
-            <a:srgbClr val="FF6D00">
-              <a:alpha val="10000"/>
-            </a:srgbClr>
-          </a:solidFill>
-          <a:ln>
-            <a:noFill/>
-          </a:ln>
-        </p:spPr>
-      </p:sp>
-      <p:sp>
-        <p:nvSpPr>
-          <p:cNvPr id="513" name="d513"/>
-          <p:cNvSpPr/>
-          <p:nvPr/>
-        </p:nvSpPr>
-        <p:spPr>
-          <a:xfrm>
-            <a:off x="8229600" y="4371975"/>
-            <a:ext cx="150000" cy="150000"/>
-          </a:xfrm>
-          <a:prstGeom prst="ellipse">
-            <a:avLst/>
-          </a:prstGeom>
-          <a:solidFill>
-            <a:srgbClr val="FF6D00">
-              <a:alpha val="10000"/>
-            </a:srgbClr>
-          </a:solidFill>
-          <a:ln>
-            <a:noFill/>
-          </a:ln>
-        </p:spPr>
-      </p:sp>
-      <p:sp>
-        <p:nvSpPr>
-          <p:cNvPr id="514" name="d514"/>
-          <p:cNvSpPr/>
-          <p:nvPr/>
-        </p:nvSpPr>
-        <p:spPr>
-          <a:xfrm>
-            <a:off x="4272000" y="10000"/>
-            <a:ext cx="600000" cy="300000"/>
-          </a:xfrm>
-          <a:prstGeom prst="diamond">
-            <a:avLst/>
-          </a:prstGeom>
-          <a:solidFill>
-            <a:srgbClr val="2196F3">
-              <a:alpha val="10000"/>
-            </a:srgbClr>
-          </a:solidFill>
-          <a:ln>
-            <a:noFill/>
-          </a:ln>
-        </p:spPr>
-      </p:sp>
-      <p:sp>
-        <p:nvSpPr>
           <p:cNvPr id="515" name="d515"/>
           <p:cNvSpPr/>
           <p:nvPr/>
@@ -15552,7 +15384,7 @@
             <a:avLst/>
           </a:prstGeom>
           <a:solidFill>
-            <a:srgbClr val="FF1744">
+            <a:srgbClr val="00BCD4">
               <a:alpha val="10000"/>
             </a:srgbClr>
           </a:solidFill>
@@ -18216,10 +18048,10 @@
             <a:avLst/>
           </a:prstGeom>
           <a:noFill/>
-          <a:ln w="40000">
+          <a:ln w="38100">
             <a:solidFill>
-              <a:srgbClr val="FFD700">
-                <a:alpha val="8000"/>
+              <a:srgbClr val="00BCD4">
+                <a:alpha val="6000"/>
               </a:srgbClr>
             </a:solidFill>
           </a:ln>
@@ -18233,17 +18065,17 @@
         </p:nvSpPr>
         <p:spPr>
           <a:xfrm>
-            <a:off x="3372000" y="1371750"/>
-            <a:ext cx="2400000" cy="2400000"/>
+            <a:off x="3672000" y="1671750"/>
+            <a:ext cx="1800000" cy="1800000"/>
           </a:xfrm>
           <a:prstGeom prst="ellipse">
             <a:avLst/>
           </a:prstGeom>
           <a:noFill/>
-          <a:ln w="28000">
+          <a:ln w="25400">
             <a:solidFill>
-              <a:srgbClr val="FFD700">
-                <a:alpha val="5000"/>
+              <a:srgbClr val="FF6D00">
+                <a:alpha val="4000"/>
               </a:srgbClr>
             </a:solidFill>
           </a:ln>
@@ -18257,30 +18089,6 @@
         </p:nvSpPr>
         <p:spPr>
           <a:xfrm>
-            <a:off x="2772000" y="771750"/>
-            <a:ext cx="3600000" cy="3600000"/>
-          </a:xfrm>
-          <a:prstGeom prst="ellipse">
-            <a:avLst/>
-          </a:prstGeom>
-          <a:noFill/>
-          <a:ln w="18000">
-            <a:solidFill>
-              <a:srgbClr val="FFD700">
-                <a:alpha val="3000"/>
-              </a:srgbClr>
-            </a:solidFill>
-          </a:ln>
-        </p:spPr>
-      </p:sp>
-      <p:sp>
-        <p:nvSpPr>
-          <p:cNvPr id="503" name="d503"/>
-          <p:cNvSpPr/>
-          <p:nvPr/>
-        </p:nvSpPr>
-        <p:spPr>
-          <a:xfrm>
             <a:off x="0" y="0"/>
             <a:ext cx="9144000" cy="642937"/>
           </a:xfrm>
@@ -18288,8 +18096,8 @@
             <a:avLst/>
           </a:prstGeom>
           <a:solidFill>
-            <a:srgbClr val="FFD700">
-              <a:alpha val="8000"/>
+            <a:srgbClr val="00BCD4">
+              <a:alpha val="5000"/>
             </a:srgbClr>
           </a:solidFill>
           <a:ln>
@@ -18299,7 +18107,7 @@
       </p:sp>
       <p:sp>
         <p:nvSpPr>
-          <p:cNvPr id="504" name="d504"/>
+          <p:cNvPr id="503" name="d503"/>
           <p:cNvSpPr/>
           <p:nvPr/>
         </p:nvSpPr>
@@ -18313,7 +18121,7 @@
           </a:prstGeom>
           <a:solidFill>
             <a:srgbClr val="FF6D00">
-              <a:alpha val="8000"/>
+              <a:alpha val="5000"/>
             </a:srgbClr>
           </a:solidFill>
           <a:ln>
@@ -18323,21 +18131,21 @@
       </p:sp>
       <p:sp>
         <p:nvSpPr>
-          <p:cNvPr id="505" name="d505"/>
-          <p:cNvSpPr/>
-          <p:nvPr/>
-        </p:nvSpPr>
-        <p:spPr>
-          <a:xfrm>
-            <a:off x="0" y="411480"/>
+          <p:cNvPr id="504" name="d504"/>
+          <p:cNvSpPr/>
+          <p:nvPr/>
+        </p:nvSpPr>
+        <p:spPr>
+          <a:xfrm>
+            <a:off x="0" y="514350"/>
             <a:ext cx="200000" cy="200000"/>
           </a:xfrm>
           <a:prstGeom prst="ellipse">
             <a:avLst/>
           </a:prstGeom>
           <a:solidFill>
-            <a:srgbClr val="FFD700">
-              <a:alpha val="12000"/>
+            <a:srgbClr val="2196F3">
+              <a:alpha val="8000"/>
             </a:srgbClr>
           </a:solidFill>
           <a:ln>
@@ -18347,21 +18155,21 @@
       </p:sp>
       <p:sp>
         <p:nvSpPr>
-          <p:cNvPr id="506" name="d506"/>
-          <p:cNvSpPr/>
-          <p:nvPr/>
-        </p:nvSpPr>
-        <p:spPr>
-          <a:xfrm>
-            <a:off x="1524000" y="411480"/>
+          <p:cNvPr id="505" name="d505"/>
+          <p:cNvSpPr/>
+          <p:nvPr/>
+        </p:nvSpPr>
+        <p:spPr>
+          <a:xfrm>
+            <a:off x="1828800" y="514350"/>
             <a:ext cx="200000" cy="200000"/>
           </a:xfrm>
           <a:prstGeom prst="ellipse">
             <a:avLst/>
           </a:prstGeom>
           <a:solidFill>
-            <a:srgbClr val="FFD700">
-              <a:alpha val="12000"/>
+            <a:srgbClr val="2196F3">
+              <a:alpha val="8000"/>
             </a:srgbClr>
           </a:solidFill>
           <a:ln>
@@ -18371,21 +18179,21 @@
       </p:sp>
       <p:sp>
         <p:nvSpPr>
-          <p:cNvPr id="507" name="d507"/>
-          <p:cNvSpPr/>
-          <p:nvPr/>
-        </p:nvSpPr>
-        <p:spPr>
-          <a:xfrm>
-            <a:off x="3048000" y="411480"/>
+          <p:cNvPr id="506" name="d506"/>
+          <p:cNvSpPr/>
+          <p:nvPr/>
+        </p:nvSpPr>
+        <p:spPr>
+          <a:xfrm>
+            <a:off x="3657600" y="514350"/>
             <a:ext cx="200000" cy="200000"/>
           </a:xfrm>
           <a:prstGeom prst="ellipse">
             <a:avLst/>
           </a:prstGeom>
           <a:solidFill>
-            <a:srgbClr val="FFD700">
-              <a:alpha val="12000"/>
+            <a:srgbClr val="2196F3">
+              <a:alpha val="8000"/>
             </a:srgbClr>
           </a:solidFill>
           <a:ln>
@@ -18395,21 +18203,21 @@
       </p:sp>
       <p:sp>
         <p:nvSpPr>
-          <p:cNvPr id="508" name="d508"/>
-          <p:cNvSpPr/>
-          <p:nvPr/>
-        </p:nvSpPr>
-        <p:spPr>
-          <a:xfrm>
-            <a:off x="4572000" y="411480"/>
+          <p:cNvPr id="507" name="d507"/>
+          <p:cNvSpPr/>
+          <p:nvPr/>
+        </p:nvSpPr>
+        <p:spPr>
+          <a:xfrm>
+            <a:off x="5486400" y="514350"/>
             <a:ext cx="200000" cy="200000"/>
           </a:xfrm>
           <a:prstGeom prst="ellipse">
             <a:avLst/>
           </a:prstGeom>
           <a:solidFill>
-            <a:srgbClr val="FFD700">
-              <a:alpha val="12000"/>
+            <a:srgbClr val="2196F3">
+              <a:alpha val="8000"/>
             </a:srgbClr>
           </a:solidFill>
           <a:ln>
@@ -18419,21 +18227,21 @@
       </p:sp>
       <p:sp>
         <p:nvSpPr>
-          <p:cNvPr id="509" name="d509"/>
-          <p:cNvSpPr/>
-          <p:nvPr/>
-        </p:nvSpPr>
-        <p:spPr>
-          <a:xfrm>
-            <a:off x="6096000" y="411480"/>
+          <p:cNvPr id="508" name="d508"/>
+          <p:cNvSpPr/>
+          <p:nvPr/>
+        </p:nvSpPr>
+        <p:spPr>
+          <a:xfrm>
+            <a:off x="7315200" y="514350"/>
             <a:ext cx="200000" cy="200000"/>
           </a:xfrm>
           <a:prstGeom prst="ellipse">
             <a:avLst/>
           </a:prstGeom>
           <a:solidFill>
-            <a:srgbClr val="FFD700">
-              <a:alpha val="12000"/>
+            <a:srgbClr val="2196F3">
+              <a:alpha val="8000"/>
             </a:srgbClr>
           </a:solidFill>
           <a:ln>
@@ -18443,21 +18251,21 @@
       </p:sp>
       <p:sp>
         <p:nvSpPr>
-          <p:cNvPr id="510" name="d510"/>
-          <p:cNvSpPr/>
-          <p:nvPr/>
-        </p:nvSpPr>
-        <p:spPr>
-          <a:xfrm>
-            <a:off x="7620000" y="411480"/>
-            <a:ext cx="200000" cy="200000"/>
+          <p:cNvPr id="509" name="d509"/>
+          <p:cNvSpPr/>
+          <p:nvPr/>
+        </p:nvSpPr>
+        <p:spPr>
+          <a:xfrm>
+            <a:off x="914400" y="4371975"/>
+            <a:ext cx="150000" cy="150000"/>
           </a:xfrm>
           <a:prstGeom prst="ellipse">
             <a:avLst/>
           </a:prstGeom>
           <a:solidFill>
-            <a:srgbClr val="FFD700">
-              <a:alpha val="12000"/>
+            <a:srgbClr val="00BCD4">
+              <a:alpha val="8000"/>
             </a:srgbClr>
           </a:solidFill>
           <a:ln>
@@ -18467,21 +18275,21 @@
       </p:sp>
       <p:sp>
         <p:nvSpPr>
-          <p:cNvPr id="511" name="d511"/>
-          <p:cNvSpPr/>
-          <p:nvPr/>
-        </p:nvSpPr>
-        <p:spPr>
-          <a:xfrm>
-            <a:off x="762000" y="4474845"/>
-            <a:ext cx="160000" cy="160000"/>
+          <p:cNvPr id="510" name="d510"/>
+          <p:cNvSpPr/>
+          <p:nvPr/>
+        </p:nvSpPr>
+        <p:spPr>
+          <a:xfrm>
+            <a:off x="2743200" y="4371975"/>
+            <a:ext cx="150000" cy="150000"/>
           </a:xfrm>
           <a:prstGeom prst="ellipse">
             <a:avLst/>
           </a:prstGeom>
           <a:solidFill>
-            <a:srgbClr val="FF6D00">
-              <a:alpha val="12000"/>
+            <a:srgbClr val="00BCD4">
+              <a:alpha val="8000"/>
             </a:srgbClr>
           </a:solidFill>
           <a:ln>
@@ -18491,21 +18299,21 @@
       </p:sp>
       <p:sp>
         <p:nvSpPr>
-          <p:cNvPr id="512" name="d512"/>
-          <p:cNvSpPr/>
-          <p:nvPr/>
-        </p:nvSpPr>
-        <p:spPr>
-          <a:xfrm>
-            <a:off x="2286000" y="4474845"/>
-            <a:ext cx="160000" cy="160000"/>
+          <p:cNvPr id="511" name="d511"/>
+          <p:cNvSpPr/>
+          <p:nvPr/>
+        </p:nvSpPr>
+        <p:spPr>
+          <a:xfrm>
+            <a:off x="4572000" y="4371975"/>
+            <a:ext cx="150000" cy="150000"/>
           </a:xfrm>
           <a:prstGeom prst="ellipse">
             <a:avLst/>
           </a:prstGeom>
           <a:solidFill>
-            <a:srgbClr val="FF6D00">
-              <a:alpha val="12000"/>
+            <a:srgbClr val="00BCD4">
+              <a:alpha val="8000"/>
             </a:srgbClr>
           </a:solidFill>
           <a:ln>
@@ -18515,21 +18323,21 @@
       </p:sp>
       <p:sp>
         <p:nvSpPr>
-          <p:cNvPr id="513" name="d513"/>
-          <p:cNvSpPr/>
-          <p:nvPr/>
-        </p:nvSpPr>
-        <p:spPr>
-          <a:xfrm>
-            <a:off x="3810000" y="4474845"/>
-            <a:ext cx="160000" cy="160000"/>
+          <p:cNvPr id="512" name="d512"/>
+          <p:cNvSpPr/>
+          <p:nvPr/>
+        </p:nvSpPr>
+        <p:spPr>
+          <a:xfrm>
+            <a:off x="6400800" y="4371975"/>
+            <a:ext cx="150000" cy="150000"/>
           </a:xfrm>
           <a:prstGeom prst="ellipse">
             <a:avLst/>
           </a:prstGeom>
           <a:solidFill>
-            <a:srgbClr val="FF6D00">
-              <a:alpha val="12000"/>
+            <a:srgbClr val="00BCD4">
+              <a:alpha val="8000"/>
             </a:srgbClr>
           </a:solidFill>
           <a:ln>
@@ -18539,21 +18347,21 @@
       </p:sp>
       <p:sp>
         <p:nvSpPr>
-          <p:cNvPr id="514" name="d514"/>
-          <p:cNvSpPr/>
-          <p:nvPr/>
-        </p:nvSpPr>
-        <p:spPr>
-          <a:xfrm>
-            <a:off x="5334000" y="4474845"/>
-            <a:ext cx="160000" cy="160000"/>
+          <p:cNvPr id="513" name="d513"/>
+          <p:cNvSpPr/>
+          <p:nvPr/>
+        </p:nvSpPr>
+        <p:spPr>
+          <a:xfrm>
+            <a:off x="8229600" y="4371975"/>
+            <a:ext cx="150000" cy="150000"/>
           </a:xfrm>
           <a:prstGeom prst="ellipse">
             <a:avLst/>
           </a:prstGeom>
           <a:solidFill>
-            <a:srgbClr val="FF6D00">
-              <a:alpha val="12000"/>
+            <a:srgbClr val="00BCD4">
+              <a:alpha val="8000"/>
             </a:srgbClr>
           </a:solidFill>
           <a:ln>
@@ -18563,21 +18371,21 @@
       </p:sp>
       <p:sp>
         <p:nvSpPr>
-          <p:cNvPr id="515" name="d515"/>
-          <p:cNvSpPr/>
-          <p:nvPr/>
-        </p:nvSpPr>
-        <p:spPr>
-          <a:xfrm>
-            <a:off x="6858000" y="4474845"/>
-            <a:ext cx="160000" cy="160000"/>
-          </a:xfrm>
-          <a:prstGeom prst="ellipse">
-            <a:avLst/>
-          </a:prstGeom>
-          <a:solidFill>
-            <a:srgbClr val="FF6D00">
-              <a:alpha val="12000"/>
+          <p:cNvPr id="514" name="d514"/>
+          <p:cNvSpPr/>
+          <p:nvPr/>
+        </p:nvSpPr>
+        <p:spPr>
+          <a:xfrm>
+            <a:off x="4272000" y="10000"/>
+            <a:ext cx="600000" cy="300000"/>
+          </a:xfrm>
+          <a:prstGeom prst="diamond">
+            <a:avLst/>
+          </a:prstGeom>
+          <a:solidFill>
+            <a:srgbClr val="2196F3">
+              <a:alpha val="10000"/>
             </a:srgbClr>
           </a:solidFill>
           <a:ln>
@@ -18587,69 +18395,21 @@
       </p:sp>
       <p:sp>
         <p:nvSpPr>
-          <p:cNvPr id="516" name="d516"/>
-          <p:cNvSpPr/>
-          <p:nvPr/>
-        </p:nvSpPr>
-        <p:spPr>
-          <a:xfrm>
-            <a:off x="8382000" y="4474845"/>
-            <a:ext cx="160000" cy="160000"/>
-          </a:xfrm>
-          <a:prstGeom prst="ellipse">
+          <p:cNvPr id="515" name="d515"/>
+          <p:cNvSpPr/>
+          <p:nvPr/>
+        </p:nvSpPr>
+        <p:spPr>
+          <a:xfrm>
+            <a:off x="4272000" y="4833500"/>
+            <a:ext cx="600000" cy="300000"/>
+          </a:xfrm>
+          <a:prstGeom prst="diamond">
             <a:avLst/>
           </a:prstGeom>
           <a:solidFill>
             <a:srgbClr val="FF6D00">
-              <a:alpha val="12000"/>
-            </a:srgbClr>
-          </a:solidFill>
-          <a:ln>
-            <a:noFill/>
-          </a:ln>
-        </p:spPr>
-      </p:sp>
-      <p:sp>
-        <p:nvSpPr>
-          <p:cNvPr id="517" name="d517"/>
-          <p:cNvSpPr/>
-          <p:nvPr/>
-        </p:nvSpPr>
-        <p:spPr>
-          <a:xfrm>
-            <a:off x="4222000" y="10000"/>
-            <a:ext cx="700000" cy="350000"/>
-          </a:xfrm>
-          <a:prstGeom prst="diamond">
-            <a:avLst/>
-          </a:prstGeom>
-          <a:solidFill>
-            <a:srgbClr val="FFD700">
-              <a:alpha val="18000"/>
-            </a:srgbClr>
-          </a:solidFill>
-          <a:ln>
-            <a:noFill/>
-          </a:ln>
-        </p:spPr>
-      </p:sp>
-      <p:sp>
-        <p:nvSpPr>
-          <p:cNvPr id="518" name="d518"/>
-          <p:cNvSpPr/>
-          <p:nvPr/>
-        </p:nvSpPr>
-        <p:spPr>
-          <a:xfrm>
-            <a:off x="4222000" y="4783500"/>
-            <a:ext cx="700000" cy="350000"/>
-          </a:xfrm>
-          <a:prstGeom prst="diamond">
-            <a:avLst/>
-          </a:prstGeom>
-          <a:solidFill>
-            <a:srgbClr val="FFD700">
-              <a:alpha val="18000"/>
+              <a:alpha val="10000"/>
             </a:srgbClr>
           </a:solidFill>
           <a:ln>
@@ -19416,7 +19176,7 @@
                           <p:cBhvr>
                             <p:cTn id="52" dur="1" fill="hold"/>
                             <p:tgtEl>
-                              <p:spTgt spid="516"/>
+                              <p:spTgt spid="2"/>
                             </p:tgtEl>
                             <p:attrNameLst>
                               <p:attrName>style.visibility</p:attrName>
@@ -19430,7 +19190,7 @@
                           <p:cBhvr>
                             <p:cTn id="53" dur="800"/>
                             <p:tgtEl>
-                              <p:spTgt spid="516"/>
+                              <p:spTgt spid="2"/>
                             </p:tgtEl>
                           </p:cBhvr>
                         </p:animEffect>
@@ -19447,7 +19207,7 @@
                           <p:cBhvr>
                             <p:cTn id="55" dur="1" fill="hold"/>
                             <p:tgtEl>
-                              <p:spTgt spid="517"/>
+                              <p:spTgt spid="3"/>
                             </p:tgtEl>
                             <p:attrNameLst>
                               <p:attrName>style.visibility</p:attrName>
@@ -19461,7 +19221,7 @@
                           <p:cBhvr>
                             <p:cTn id="56" dur="800"/>
                             <p:tgtEl>
-                              <p:spTgt spid="517"/>
+                              <p:spTgt spid="3"/>
                             </p:tgtEl>
                           </p:cBhvr>
                         </p:animEffect>
@@ -19478,7 +19238,7 @@
                           <p:cBhvr>
                             <p:cTn id="58" dur="1" fill="hold"/>
                             <p:tgtEl>
-                              <p:spTgt spid="518"/>
+                              <p:spTgt spid="4"/>
                             </p:tgtEl>
                             <p:attrNameLst>
                               <p:attrName>style.visibility</p:attrName>
@@ -19492,7 +19252,7 @@
                           <p:cBhvr>
                             <p:cTn id="59" dur="800"/>
                             <p:tgtEl>
-                              <p:spTgt spid="518"/>
+                              <p:spTgt spid="4"/>
                             </p:tgtEl>
                           </p:cBhvr>
                         </p:animEffect>
@@ -19509,7 +19269,7 @@
                           <p:cBhvr>
                             <p:cTn id="61" dur="1" fill="hold"/>
                             <p:tgtEl>
-                              <p:spTgt spid="2"/>
+                              <p:spTgt spid="7"/>
                             </p:tgtEl>
                             <p:attrNameLst>
                               <p:attrName>style.visibility</p:attrName>
@@ -19523,7 +19283,7 @@
                           <p:cBhvr>
                             <p:cTn id="62" dur="800"/>
                             <p:tgtEl>
-                              <p:spTgt spid="2"/>
+                              <p:spTgt spid="7"/>
                             </p:tgtEl>
                           </p:cBhvr>
                         </p:animEffect>
@@ -19540,7 +19300,7 @@
                           <p:cBhvr>
                             <p:cTn id="64" dur="1" fill="hold"/>
                             <p:tgtEl>
-                              <p:spTgt spid="3"/>
+                              <p:spTgt spid="8"/>
                             </p:tgtEl>
                             <p:attrNameLst>
                               <p:attrName>style.visibility</p:attrName>
@@ -19554,7 +19314,7 @@
                           <p:cBhvr>
                             <p:cTn id="65" dur="800"/>
                             <p:tgtEl>
-                              <p:spTgt spid="3"/>
+                              <p:spTgt spid="8"/>
                             </p:tgtEl>
                           </p:cBhvr>
                         </p:animEffect>
@@ -19571,7 +19331,7 @@
                           <p:cBhvr>
                             <p:cTn id="67" dur="1" fill="hold"/>
                             <p:tgtEl>
-                              <p:spTgt spid="4"/>
+                              <p:spTgt spid="9"/>
                             </p:tgtEl>
                             <p:attrNameLst>
                               <p:attrName>style.visibility</p:attrName>
@@ -19585,7 +19345,7 @@
                           <p:cBhvr>
                             <p:cTn id="68" dur="800"/>
                             <p:tgtEl>
-                              <p:spTgt spid="4"/>
+                              <p:spTgt spid="9"/>
                             </p:tgtEl>
                           </p:cBhvr>
                         </p:animEffect>
@@ -19602,7 +19362,7 @@
                           <p:cBhvr>
                             <p:cTn id="70" dur="1" fill="hold"/>
                             <p:tgtEl>
-                              <p:spTgt spid="7"/>
+                              <p:spTgt spid="10"/>
                             </p:tgtEl>
                             <p:attrNameLst>
                               <p:attrName>style.visibility</p:attrName>
@@ -19615,99 +19375,6 @@
                         <p:animEffect transition="in" filter="fade">
                           <p:cBhvr>
                             <p:cTn id="71" dur="800"/>
-                            <p:tgtEl>
-                              <p:spTgt spid="7"/>
-                            </p:tgtEl>
-                          </p:cBhvr>
-                        </p:animEffect>
-                      </p:childTnLst>
-                    </p:cTn>
-                  </p:par>
-                  <p:par>
-                    <p:cTn id="72" presetID="10" presetClass="entr" presetSubtype="0" fill="hold" grpId="23" nodeType="withEffect">
-                      <p:stCondLst>
-                        <p:cond delay="3450"/>
-                      </p:stCondLst>
-                      <p:childTnLst>
-                        <p:set>
-                          <p:cBhvr>
-                            <p:cTn id="73" dur="1" fill="hold"/>
-                            <p:tgtEl>
-                              <p:spTgt spid="8"/>
-                            </p:tgtEl>
-                            <p:attrNameLst>
-                              <p:attrName>style.visibility</p:attrName>
-                            </p:attrNameLst>
-                          </p:cBhvr>
-                          <p:to>
-                            <p:strVal val="visible"/>
-                          </p:to>
-                        </p:set>
-                        <p:animEffect transition="in" filter="fade">
-                          <p:cBhvr>
-                            <p:cTn id="74" dur="800"/>
-                            <p:tgtEl>
-                              <p:spTgt spid="8"/>
-                            </p:tgtEl>
-                          </p:cBhvr>
-                        </p:animEffect>
-                      </p:childTnLst>
-                    </p:cTn>
-                  </p:par>
-                  <p:par>
-                    <p:cTn id="75" presetID="10" presetClass="entr" presetSubtype="0" fill="hold" grpId="24" nodeType="withEffect">
-                      <p:stCondLst>
-                        <p:cond delay="3600"/>
-                      </p:stCondLst>
-                      <p:childTnLst>
-                        <p:set>
-                          <p:cBhvr>
-                            <p:cTn id="76" dur="1" fill="hold"/>
-                            <p:tgtEl>
-                              <p:spTgt spid="9"/>
-                            </p:tgtEl>
-                            <p:attrNameLst>
-                              <p:attrName>style.visibility</p:attrName>
-                            </p:attrNameLst>
-                          </p:cBhvr>
-                          <p:to>
-                            <p:strVal val="visible"/>
-                          </p:to>
-                        </p:set>
-                        <p:animEffect transition="in" filter="fade">
-                          <p:cBhvr>
-                            <p:cTn id="77" dur="800"/>
-                            <p:tgtEl>
-                              <p:spTgt spid="9"/>
-                            </p:tgtEl>
-                          </p:cBhvr>
-                        </p:animEffect>
-                      </p:childTnLst>
-                    </p:cTn>
-                  </p:par>
-                  <p:par>
-                    <p:cTn id="78" presetID="10" presetClass="entr" presetSubtype="0" fill="hold" grpId="25" nodeType="withEffect">
-                      <p:stCondLst>
-                        <p:cond delay="3750"/>
-                      </p:stCondLst>
-                      <p:childTnLst>
-                        <p:set>
-                          <p:cBhvr>
-                            <p:cTn id="79" dur="1" fill="hold"/>
-                            <p:tgtEl>
-                              <p:spTgt spid="10"/>
-                            </p:tgtEl>
-                            <p:attrNameLst>
-                              <p:attrName>style.visibility</p:attrName>
-                            </p:attrNameLst>
-                          </p:cBhvr>
-                          <p:to>
-                            <p:strVal val="visible"/>
-                          </p:to>
-                        </p:set>
-                        <p:animEffect transition="in" filter="fade">
-                          <p:cBhvr>
-                            <p:cTn id="80" dur="800"/>
                             <p:tgtEl>
                               <p:spTgt spid="10"/>
                             </p:tgtEl>
@@ -19740,16 +19407,13 @@
       <p:bldP spid="513" grpId="13" uiExpand="1" build="p"/>
       <p:bldP spid="514" grpId="14" uiExpand="1" build="p"/>
       <p:bldP spid="515" grpId="15" uiExpand="1" build="p"/>
-      <p:bldP spid="516" grpId="16" uiExpand="1" build="p"/>
-      <p:bldP spid="517" grpId="17" uiExpand="1" build="p"/>
-      <p:bldP spid="518" grpId="18" uiExpand="1" build="p"/>
-      <p:bldP spid="2" grpId="19" uiExpand="1" build="p"/>
-      <p:bldP spid="3" grpId="20" uiExpand="1" build="p"/>
-      <p:bldP spid="4" grpId="21" uiExpand="1" build="p"/>
-      <p:bldP spid="7" grpId="22" uiExpand="1" build="p"/>
-      <p:bldP spid="8" grpId="23" uiExpand="1" build="p"/>
-      <p:bldP spid="9" grpId="24" uiExpand="1" build="p"/>
-      <p:bldP spid="10" grpId="25" uiExpand="1" build="p"/>
+      <p:bldP spid="2" grpId="16" uiExpand="1" build="p"/>
+      <p:bldP spid="3" grpId="17" uiExpand="1" build="p"/>
+      <p:bldP spid="4" grpId="18" uiExpand="1" build="p"/>
+      <p:bldP spid="7" grpId="19" uiExpand="1" build="p"/>
+      <p:bldP spid="8" grpId="20" uiExpand="1" build="p"/>
+      <p:bldP spid="9" grpId="21" uiExpand="1" build="p"/>
+      <p:bldP spid="10" grpId="22" uiExpand="1" build="p"/>
     </p:bldLst>
   </p:timing>
 </p:sld>

</xml_diff>